<commit_message>
Stage 11 results: patching, knockout, title-position probe, author chain; report and talk updated
</commit_message>
<xml_diff>
--- a/experiment_files/351_stage10/reports/talk/Stage10_author_readout_talk.pptx
+++ b/experiment_files/351_stage10/reports/talk/Stage10_author_readout_talk.pptx
@@ -22,6 +22,10 @@
     <p:sldId id="270" r:id="rId22"/>
     <p:sldId id="271" r:id="rId23"/>
     <p:sldId id="272" r:id="rId24"/>
+    <p:sldId id="273" r:id="rId25"/>
+    <p:sldId id="274" r:id="rId26"/>
+    <p:sldId id="275" r:id="rId27"/>
+    <p:sldId id="276" r:id="rId28"/>
   </p:sldIdLst>
   <p:sldSz cx="12191695" cy="6858000" type="screen4x3"/>
   <p:notesSz cx="6858000" cy="9144000"/>
@@ -588,7 +592,7 @@
           <a:lstStyle/>
           <a:p>
             <a:r>
-              <a:t>Comparing lenses. On readout quality fitA is best in most middle layers, self100 at L40; at L48 the Jacobian lenses put the right token in the top 10 for 15-18% of tokens versus 1% for the logit lens. At L62 the plain logit lens is best.</a:t>
+              <a:t>Stage 11 turns the readout question into interventions. 593 target and 593 control papers, matched within citation bins. Patching: run the paper with its true title and with a matched false title, and copy the true run hidden state into the false run at one layer. Knockout: forbid attention to the title tokens from layer l to the end. Probe: train a linear map from the last title token to the output state. Chain: score every author after the previous ones.</a:t>
             </a:r>
           </a:p>
         </p:txBody>
@@ -658,7 +662,7 @@
           <a:lstStyle/>
           <a:p>
             <a:r>
-              <a:t>Do Jacobian lenses see paper-specific information the logit lens misses? A little: +0.01 to +0.03 more title-specific signal at L24-L48, CIs above zero, but tiny next to 0.44 at L62. And it is not bigger for target: target minus control of that extra is about zero, negative at L48 and L56.</a:t>
+              <a:t>Two causal curves. Left: copying the hidden states of the tokens after the title (closing quote, year, Authors:, the name) from the true run into the false run recovers 29 percent at L40, 83 percent at L48 and everything from L52. Copying only the last title token recovers about 12 percent. Right: blocking attention to the title from L0 removes 83 percent of the effect, from L32 37 percent, from L48 6 percent, from L52 nothing. Blocking only the colon and name positions removes at most 15 percent, so the information is routed through the tokens right after the title. Target and control follow the same curves.</a:t>
             </a:r>
           </a:p>
         </p:txBody>
@@ -728,7 +732,7 @@
           <a:lstStyle/>
           <a:p>
             <a:r>
-              <a:t>Citations. Within both groups the title-specific signal rises steadily with citation bin: target from +0.35 in bin 0-2 to +0.64 in 4097+. Spearman with log citations: 0.45 overall, 0.33 within target, 0.19 within control. The level itself changes much less - names are not easier to guess for famous papers, the model just knows famous papers better.</a:t>
+              <a:t>Is the author readable at the title itself? With the lenses, barely: about 0.01 to 0.03 title-specific signal at the last title token. A linear probe trained across papers gets more, 0.04 at L16 rising to 0.08 at L56, and a little more for target papers. Caution: a probe trained across papers can also pick up topic-to-name associations, not only this paper.</a:t>
             </a:r>
           </a:p>
         </p:txBody>
@@ -798,7 +802,7 @@
           <a:lstStyle/>
           <a:p>
             <a:r>
-              <a:t>Is the signal decided by the first token? It depends on the name format. Initial-first names: the initial carries little, the signal is on the later tokens that include the surname. Given-name-first names: the given name carries about as much as the rest. Note teacher forcing: later tokens already see the correct prefix in every condition, so their title-specific signal can only come from the title.</a:t>
+              <a:t>Author chain. When the earlier authors are in the context, later authors become easier: plus 0.17 to 0.23 for target, 0.12 to 0.18 for control. But the title matters less: the title-specific signal drops from 0.45 to 0.26 for later target authors, because the co-authors already identify the paper. Target still beats control within bins, plus 0.11 to 0.15.</a:t>
             </a:r>
           </a:p>
         </p:txBody>
@@ -868,7 +872,7 @@
           <a:lstStyle/>
           <a:p>
             <a:r>
-              <a:t>Does knowing the first word make the rest easier? For a full given name, yes: when it is in the top 10 the surname is +0.22 better at the output, +0.32 for the logit lens at L62. For an initial, no. Mixing both formats would even show a negative effect, because initials are easy and the surnames after them are hard.</a:t>
+              <a:t>Comparing lenses. On readout quality fitA is best in most middle layers, self100 at L40; at L48 the Jacobian lenses put the right token in the top 10 for 15-18% of tokens versus 1% for the logit lens. At L62 the plain logit lens is best.</a:t>
             </a:r>
           </a:p>
         </p:txBody>
@@ -938,7 +942,7 @@
           <a:lstStyle/>
           <a:p>
             <a:r>
-              <a:t>Left: title-specific signal by token role at the output - surname first token carries most, initials least, punctuation about zero (negative control). Right: across all unrecalled papers, the more multiple-choice orders right, the better the model output (Spearman 0.27).</a:t>
+              <a:t>Do Jacobian lenses see paper-specific information the logit lens misses? A little: +0.01 to +0.03 more title-specific signal at L24-L48, CIs above zero, but tiny next to 0.44 at L62. And it is not bigger for target: target minus control of that extra is about zero, negative at L48 and L56.</a:t>
             </a:r>
           </a:p>
         </p:txBody>
@@ -1008,7 +1012,7 @@
           <a:lstStyle/>
           <a:p>
             <a:r>
-              <a:t>Wrap up the five findings.</a:t>
+              <a:t>Citations. Within both groups the title-specific signal rises steadily with citation bin: target from +0.35 in bin 0-2 to +0.64 in 4097+. Spearman with log citations: 0.45 overall, 0.33 within target, 0.19 within control. The level itself changes much less - names are not easier to guess for famous papers, the model just knows famous papers better.</a:t>
             </a:r>
           </a:p>
         </p:txBody>
@@ -1078,7 +1082,147 @@
           <a:lstStyle/>
           <a:p>
             <a:r>
-              <a:t>Limits and next steps. Everything here is correlational. Next: causal patching at L56, author-chain scoring, and blocking attention to the title tokens in the late layers.</a:t>
+              <a:t>Is the signal decided by the first token? It depends on the name format. Initial-first names: the initial carries little, the signal is on the later tokens that include the surname. Given-name-first names: the given name carries about as much as the rest. Note teacher forcing: later tokens already see the correct prefix in every condition, so their title-specific signal can only come from the title.</a:t>
+            </a:r>
+          </a:p>
+        </p:txBody>
+      </p:sp>
+      <p:sp>
+        <p:nvSpPr>
+          <p:cNvPr id="4" name="Slide Number Placeholder 3"/>
+          <p:cNvSpPr>
+            <a:spLocks noGrp="1"/>
+          </p:cNvSpPr>
+          <p:nvPr>
+            <p:ph type="sldNum" idx="5" sz="quarter"/>
+          </p:nvPr>
+        </p:nvSpPr>
+        <p:spPr/>
+      </p:sp>
+    </p:spTree>
+  </p:cSld>
+  <p:clrMapOvr>
+    <a:masterClrMapping/>
+  </p:clrMapOvr>
+</p:notes>
+</file>
+
+<file path=ppt/notesSlides/notesSlide18.xml><?xml version="1.0" encoding="utf-8"?>
+<p:notes xmlns:a="http://schemas.openxmlformats.org/drawingml/2006/main" xmlns:p="http://schemas.openxmlformats.org/presentationml/2006/main" xmlns:r="http://schemas.openxmlformats.org/officeDocument/2006/relationships">
+  <p:cSld>
+    <p:spTree>
+      <p:nvGrpSpPr>
+        <p:cNvPr id="1" name=""/>
+        <p:cNvGrpSpPr/>
+        <p:nvPr/>
+      </p:nvGrpSpPr>
+      <p:grpSpPr>
+        <a:xfrm>
+          <a:off x="0" y="0"/>
+          <a:ext cx="0" cy="0"/>
+          <a:chOff x="0" y="0"/>
+          <a:chExt cx="0" cy="0"/>
+        </a:xfrm>
+      </p:grpSpPr>
+      <p:sp>
+        <p:nvSpPr>
+          <p:cNvPr id="2" name="Slide Image Placeholder 1"/>
+          <p:cNvSpPr>
+            <a:spLocks noGrp="1"/>
+          </p:cNvSpPr>
+          <p:nvPr>
+            <p:ph type="sldImg" idx="2"/>
+          </p:nvPr>
+        </p:nvSpPr>
+        <p:spPr/>
+      </p:sp>
+      <p:sp>
+        <p:nvSpPr>
+          <p:cNvPr id="3" name="Notes Placeholder 2"/>
+          <p:cNvSpPr>
+            <a:spLocks noGrp="1"/>
+          </p:cNvSpPr>
+          <p:nvPr>
+            <p:ph type="body" idx="3" sz="quarter"/>
+          </p:nvPr>
+        </p:nvSpPr>
+        <p:spPr/>
+        <p:txBody>
+          <a:bodyPr/>
+          <a:lstStyle/>
+          <a:p>
+            <a:r>
+              <a:t>Does knowing the first word make the rest easier? For a full given name, yes: when it is in the top 10 the surname is +0.22 better at the output, +0.32 for the logit lens at L62. For an initial, no. Mixing both formats would even show a negative effect, because initials are easy and the surnames after them are hard.</a:t>
+            </a:r>
+          </a:p>
+        </p:txBody>
+      </p:sp>
+      <p:sp>
+        <p:nvSpPr>
+          <p:cNvPr id="4" name="Slide Number Placeholder 3"/>
+          <p:cNvSpPr>
+            <a:spLocks noGrp="1"/>
+          </p:cNvSpPr>
+          <p:nvPr>
+            <p:ph type="sldNum" idx="5" sz="quarter"/>
+          </p:nvPr>
+        </p:nvSpPr>
+        <p:spPr/>
+      </p:sp>
+    </p:spTree>
+  </p:cSld>
+  <p:clrMapOvr>
+    <a:masterClrMapping/>
+  </p:clrMapOvr>
+</p:notes>
+</file>
+
+<file path=ppt/notesSlides/notesSlide19.xml><?xml version="1.0" encoding="utf-8"?>
+<p:notes xmlns:a="http://schemas.openxmlformats.org/drawingml/2006/main" xmlns:p="http://schemas.openxmlformats.org/presentationml/2006/main" xmlns:r="http://schemas.openxmlformats.org/officeDocument/2006/relationships">
+  <p:cSld>
+    <p:spTree>
+      <p:nvGrpSpPr>
+        <p:cNvPr id="1" name=""/>
+        <p:cNvGrpSpPr/>
+        <p:nvPr/>
+      </p:nvGrpSpPr>
+      <p:grpSpPr>
+        <a:xfrm>
+          <a:off x="0" y="0"/>
+          <a:ext cx="0" cy="0"/>
+          <a:chOff x="0" y="0"/>
+          <a:chExt cx="0" cy="0"/>
+        </a:xfrm>
+      </p:grpSpPr>
+      <p:sp>
+        <p:nvSpPr>
+          <p:cNvPr id="2" name="Slide Image Placeholder 1"/>
+          <p:cNvSpPr>
+            <a:spLocks noGrp="1"/>
+          </p:cNvSpPr>
+          <p:nvPr>
+            <p:ph type="sldImg" idx="2"/>
+          </p:nvPr>
+        </p:nvSpPr>
+        <p:spPr/>
+      </p:sp>
+      <p:sp>
+        <p:nvSpPr>
+          <p:cNvPr id="3" name="Notes Placeholder 2"/>
+          <p:cNvSpPr>
+            <a:spLocks noGrp="1"/>
+          </p:cNvSpPr>
+          <p:nvPr>
+            <p:ph type="body" idx="3" sz="quarter"/>
+          </p:nvPr>
+        </p:nvSpPr>
+        <p:spPr/>
+        <p:txBody>
+          <a:bodyPr/>
+          <a:lstStyle/>
+          <a:p>
+            <a:r>
+              <a:t>Left: title-specific signal by token role at the output - surname first token carries most, initials least, punctuation about zero (negative control). Right: across all unrecalled papers, the more multiple-choice orders right, the better the model output (Spearman 0.27).</a:t>
             </a:r>
           </a:p>
         </p:txBody>
@@ -1149,6 +1293,146 @@
           <a:p>
             <a:r>
               <a:t>Earlier labels: for about half of the papers the model cannot write the authors when asked openly, but picks the true author list in a 4-option multiple choice. We call these target papers. Control papers: cannot write, cannot pick. If recognition is already computed in middle layers, a lens should read the right names better for target than control there.</a:t>
+            </a:r>
+          </a:p>
+        </p:txBody>
+      </p:sp>
+      <p:sp>
+        <p:nvSpPr>
+          <p:cNvPr id="4" name="Slide Number Placeholder 3"/>
+          <p:cNvSpPr>
+            <a:spLocks noGrp="1"/>
+          </p:cNvSpPr>
+          <p:nvPr>
+            <p:ph type="sldNum" idx="5" sz="quarter"/>
+          </p:nvPr>
+        </p:nvSpPr>
+        <p:spPr/>
+      </p:sp>
+    </p:spTree>
+  </p:cSld>
+  <p:clrMapOvr>
+    <a:masterClrMapping/>
+  </p:clrMapOvr>
+</p:notes>
+</file>
+
+<file path=ppt/notesSlides/notesSlide20.xml><?xml version="1.0" encoding="utf-8"?>
+<p:notes xmlns:a="http://schemas.openxmlformats.org/drawingml/2006/main" xmlns:p="http://schemas.openxmlformats.org/presentationml/2006/main" xmlns:r="http://schemas.openxmlformats.org/officeDocument/2006/relationships">
+  <p:cSld>
+    <p:spTree>
+      <p:nvGrpSpPr>
+        <p:cNvPr id="1" name=""/>
+        <p:cNvGrpSpPr/>
+        <p:nvPr/>
+      </p:nvGrpSpPr>
+      <p:grpSpPr>
+        <a:xfrm>
+          <a:off x="0" y="0"/>
+          <a:ext cx="0" cy="0"/>
+          <a:chOff x="0" y="0"/>
+          <a:chExt cx="0" cy="0"/>
+        </a:xfrm>
+      </p:grpSpPr>
+      <p:sp>
+        <p:nvSpPr>
+          <p:cNvPr id="2" name="Slide Image Placeholder 1"/>
+          <p:cNvSpPr>
+            <a:spLocks noGrp="1"/>
+          </p:cNvSpPr>
+          <p:nvPr>
+            <p:ph type="sldImg" idx="2"/>
+          </p:nvPr>
+        </p:nvSpPr>
+        <p:spPr/>
+      </p:sp>
+      <p:sp>
+        <p:nvSpPr>
+          <p:cNvPr id="3" name="Notes Placeholder 2"/>
+          <p:cNvSpPr>
+            <a:spLocks noGrp="1"/>
+          </p:cNvSpPr>
+          <p:nvPr>
+            <p:ph type="body" idx="3" sz="quarter"/>
+          </p:nvPr>
+        </p:nvSpPr>
+        <p:spPr/>
+        <p:txBody>
+          <a:bodyPr/>
+          <a:lstStyle/>
+          <a:p>
+            <a:r>
+              <a:t>Wrap up the five findings.</a:t>
+            </a:r>
+          </a:p>
+        </p:txBody>
+      </p:sp>
+      <p:sp>
+        <p:nvSpPr>
+          <p:cNvPr id="4" name="Slide Number Placeholder 3"/>
+          <p:cNvSpPr>
+            <a:spLocks noGrp="1"/>
+          </p:cNvSpPr>
+          <p:nvPr>
+            <p:ph type="sldNum" idx="5" sz="quarter"/>
+          </p:nvPr>
+        </p:nvSpPr>
+        <p:spPr/>
+      </p:sp>
+    </p:spTree>
+  </p:cSld>
+  <p:clrMapOvr>
+    <a:masterClrMapping/>
+  </p:clrMapOvr>
+</p:notes>
+</file>
+
+<file path=ppt/notesSlides/notesSlide21.xml><?xml version="1.0" encoding="utf-8"?>
+<p:notes xmlns:a="http://schemas.openxmlformats.org/drawingml/2006/main" xmlns:p="http://schemas.openxmlformats.org/presentationml/2006/main" xmlns:r="http://schemas.openxmlformats.org/officeDocument/2006/relationships">
+  <p:cSld>
+    <p:spTree>
+      <p:nvGrpSpPr>
+        <p:cNvPr id="1" name=""/>
+        <p:cNvGrpSpPr/>
+        <p:nvPr/>
+      </p:nvGrpSpPr>
+      <p:grpSpPr>
+        <a:xfrm>
+          <a:off x="0" y="0"/>
+          <a:ext cx="0" cy="0"/>
+          <a:chOff x="0" y="0"/>
+          <a:chExt cx="0" cy="0"/>
+        </a:xfrm>
+      </p:grpSpPr>
+      <p:sp>
+        <p:nvSpPr>
+          <p:cNvPr id="2" name="Slide Image Placeholder 1"/>
+          <p:cNvSpPr>
+            <a:spLocks noGrp="1"/>
+          </p:cNvSpPr>
+          <p:nvPr>
+            <p:ph type="sldImg" idx="2"/>
+          </p:nvPr>
+        </p:nvSpPr>
+        <p:spPr/>
+      </p:sp>
+      <p:sp>
+        <p:nvSpPr>
+          <p:cNvPr id="3" name="Notes Placeholder 2"/>
+          <p:cNvSpPr>
+            <a:spLocks noGrp="1"/>
+          </p:cNvSpPr>
+          <p:nvPr>
+            <p:ph type="body" idx="3" sz="quarter"/>
+          </p:nvPr>
+        </p:nvSpPr>
+        <p:spPr/>
+        <p:txBody>
+          <a:bodyPr/>
+          <a:lstStyle/>
+          <a:p>
+            <a:r>
+              <a:t>Limits and next steps. Patching and knockout now fix when the title is read (L24-L50) but not what happens inside those layers. Next: patch single positions after the title, localise the computation inside L24-L50, and repeat on a second model.</a:t>
             </a:r>
           </a:p>
         </p:txBody>
@@ -4945,7 +5229,7 @@
                 </a:solidFill>
                 <a:latin typeface="Caveat"/>
               </a:rPr>
-              <a:t>Which lens reads best?</a:t>
+              <a:t>Stage 11: intervene, do not just read</a:t>
             </a:r>
           </a:p>
         </p:txBody>
@@ -4984,58 +5268,33 @@
                 </a:solidFill>
                 <a:latin typeface="Patrick Hand"/>
               </a:rPr>
-              <a:t>all papers · true title</a:t>
-            </a:r>
-          </a:p>
-        </p:txBody>
-      </p:sp>
-      <p:pic>
-        <p:nvPicPr>
-          <p:cNvPr id="5" name="Picture 4" descr="c4_lens_quality.png"/>
-          <p:cNvPicPr>
-            <a:picLocks noChangeAspect="1"/>
-          </p:cNvPicPr>
-          <p:nvPr/>
-        </p:nvPicPr>
-        <p:blipFill>
-          <a:blip r:embed="rId4"/>
-          <a:stretch>
-            <a:fillRect/>
-          </a:stretch>
-        </p:blipFill>
-        <p:spPr>
-          <a:xfrm>
-            <a:off x="457200" y="1463040"/>
-            <a:ext cx="8412480" cy="3963572"/>
-          </a:xfrm>
-          <a:prstGeom prst="rect">
-            <a:avLst/>
-          </a:prstGeom>
-        </p:spPr>
-      </p:pic>
-      <p:sp>
-        <p:nvSpPr>
-          <p:cNvPr id="6" name="Rectangle 5"/>
+              <a:t>593 target + 593 control papers (balanced within citation bins) · all 9,108 for probe and chain</a:t>
+            </a:r>
+          </a:p>
+        </p:txBody>
+      </p:sp>
+      <p:sp>
+        <p:nvSpPr>
+          <p:cNvPr id="5" name="Rounded Rectangle 4"/>
           <p:cNvSpPr/>
           <p:nvPr/>
         </p:nvSpPr>
         <p:spPr>
-          <a:xfrm rot="21510000">
-            <a:off x="9098280" y="1737360"/>
-            <a:ext cx="2651760" cy="3108960"/>
-          </a:xfrm>
-          <a:prstGeom prst="rect">
-            <a:avLst/>
-          </a:prstGeom>
-          <a:solidFill>
-            <a:srgbClr val="FFF1A8"/>
-          </a:solidFill>
-          <a:ln w="12700">
+          <a:xfrm rot="21540000">
+            <a:off x="822960" y="1737360"/>
+            <a:ext cx="5120640" cy="1828800"/>
+          </a:xfrm>
+          <a:prstGeom prst="roundRect">
+            <a:avLst>
+              <a:gd name="adj" fmla="val 8000"/>
+            </a:avLst>
+          </a:prstGeom>
+          <a:noFill/>
+          <a:ln w="28575">
             <a:solidFill>
-              <a:srgbClr val="E2D37A"/>
+              <a:srgbClr val="E07A2F"/>
             </a:solidFill>
           </a:ln>
-          <a:effectLst/>
         </p:spPr>
         <p:style>
           <a:lnRef idx="1">
@@ -5052,63 +5311,299 @@
           </a:fontRef>
         </p:style>
         <p:txBody>
-          <a:bodyPr rtlCol="0" anchor="t" wrap="square" lIns="201168" rIns="201168" tIns="164592" bIns="164592"/>
-          <a:lstStyle/>
-          <a:p>
-            <a:pPr algn="l">
-              <a:spcAft>
-                <a:spcPts val="900"/>
-              </a:spcAft>
-            </a:pPr>
-            <a:r>
-              <a:rPr sz="1900" b="1">
+          <a:bodyPr rtlCol="0" anchor="ctr" wrap="square" lIns="164592" rIns="164592"/>
+          <a:lstStyle/>
+          <a:p>
+            <a:pPr algn="ctr">
+              <a:spcAft>
+                <a:spcPts val="400"/>
+              </a:spcAft>
+            </a:pPr>
+            <a:r>
+              <a:rPr sz="2000" b="1">
+                <a:solidFill>
+                  <a:srgbClr val="E07A2F"/>
+                </a:solidFill>
+                <a:latin typeface="Patrick Hand"/>
+              </a:rPr>
+              <a:t>patch</a:t>
+            </a:r>
+          </a:p>
+          <a:p>
+            <a:pPr algn="ctr">
+              <a:spcAft>
+                <a:spcPts val="400"/>
+              </a:spcAft>
+            </a:pPr>
+            <a:r>
+              <a:rPr sz="2000" b="0">
+                <a:solidFill>
+                  <a:srgbClr val="E07A2F"/>
+                </a:solidFill>
+                <a:latin typeface="Patrick Hand"/>
+              </a:rPr>
+              <a:t>copy the true-title hidden state into the false-title run at one layer</a:t>
+            </a:r>
+          </a:p>
+        </p:txBody>
+      </p:sp>
+      <p:sp>
+        <p:nvSpPr>
+          <p:cNvPr id="6" name="Rounded Rectangle 5"/>
+          <p:cNvSpPr/>
+          <p:nvPr/>
+        </p:nvSpPr>
+        <p:spPr>
+          <a:xfrm rot="60000">
+            <a:off x="6400800" y="1737360"/>
+            <a:ext cx="5120640" cy="1828800"/>
+          </a:xfrm>
+          <a:prstGeom prst="roundRect">
+            <a:avLst>
+              <a:gd name="adj" fmla="val 8000"/>
+            </a:avLst>
+          </a:prstGeom>
+          <a:noFill/>
+          <a:ln w="28575">
+            <a:solidFill>
+              <a:srgbClr val="3A6EA5"/>
+            </a:solidFill>
+          </a:ln>
+        </p:spPr>
+        <p:style>
+          <a:lnRef idx="1">
+            <a:schemeClr val="accent1"/>
+          </a:lnRef>
+          <a:fillRef idx="3">
+            <a:schemeClr val="accent1"/>
+          </a:fillRef>
+          <a:effectRef idx="2">
+            <a:schemeClr val="accent1"/>
+          </a:effectRef>
+          <a:fontRef idx="minor">
+            <a:schemeClr val="lt1"/>
+          </a:fontRef>
+        </p:style>
+        <p:txBody>
+          <a:bodyPr rtlCol="0" anchor="ctr" wrap="square" lIns="164592" rIns="164592"/>
+          <a:lstStyle/>
+          <a:p>
+            <a:pPr algn="ctr">
+              <a:spcAft>
+                <a:spcPts val="400"/>
+              </a:spcAft>
+            </a:pPr>
+            <a:r>
+              <a:rPr sz="2000" b="1">
+                <a:solidFill>
+                  <a:srgbClr val="3A6EA5"/>
+                </a:solidFill>
+                <a:latin typeface="Patrick Hand"/>
+              </a:rPr>
+              <a:t>knock out</a:t>
+            </a:r>
+          </a:p>
+          <a:p>
+            <a:pPr algn="ctr">
+              <a:spcAft>
+                <a:spcPts val="400"/>
+              </a:spcAft>
+            </a:pPr>
+            <a:r>
+              <a:rPr sz="2000" b="0">
+                <a:solidFill>
+                  <a:srgbClr val="3A6EA5"/>
+                </a:solidFill>
+                <a:latin typeface="Patrick Hand"/>
+              </a:rPr>
+              <a:t>block attention to the title tokens from layer l on</a:t>
+            </a:r>
+          </a:p>
+        </p:txBody>
+      </p:sp>
+      <p:sp>
+        <p:nvSpPr>
+          <p:cNvPr id="7" name="Rounded Rectangle 6"/>
+          <p:cNvSpPr/>
+          <p:nvPr/>
+        </p:nvSpPr>
+        <p:spPr>
+          <a:xfrm rot="21570000">
+            <a:off x="822960" y="3886200"/>
+            <a:ext cx="5120640" cy="1828800"/>
+          </a:xfrm>
+          <a:prstGeom prst="roundRect">
+            <a:avLst>
+              <a:gd name="adj" fmla="val 8000"/>
+            </a:avLst>
+          </a:prstGeom>
+          <a:noFill/>
+          <a:ln w="28575">
+            <a:solidFill>
+              <a:srgbClr val="3C8D5A"/>
+            </a:solidFill>
+          </a:ln>
+        </p:spPr>
+        <p:style>
+          <a:lnRef idx="1">
+            <a:schemeClr val="accent1"/>
+          </a:lnRef>
+          <a:fillRef idx="3">
+            <a:schemeClr val="accent1"/>
+          </a:fillRef>
+          <a:effectRef idx="2">
+            <a:schemeClr val="accent1"/>
+          </a:effectRef>
+          <a:fontRef idx="minor">
+            <a:schemeClr val="lt1"/>
+          </a:fontRef>
+        </p:style>
+        <p:txBody>
+          <a:bodyPr rtlCol="0" anchor="ctr" wrap="square" lIns="164592" rIns="164592"/>
+          <a:lstStyle/>
+          <a:p>
+            <a:pPr algn="ctr">
+              <a:spcAft>
+                <a:spcPts val="400"/>
+              </a:spcAft>
+            </a:pPr>
+            <a:r>
+              <a:rPr sz="2000" b="1">
                 <a:solidFill>
                   <a:srgbClr val="3C8D5A"/>
                 </a:solidFill>
                 <a:latin typeface="Patrick Hand"/>
               </a:rPr>
-              <a:t>Middle layers:</a:t>
-            </a:r>
-          </a:p>
-          <a:p>
-            <a:pPr algn="l">
-              <a:spcAft>
-                <a:spcPts val="900"/>
-              </a:spcAft>
-            </a:pPr>
-            <a:r>
-              <a:rPr sz="1900" b="0">
+              <a:t>probe</a:t>
+            </a:r>
+          </a:p>
+          <a:p>
+            <a:pPr algn="ctr">
+              <a:spcAft>
+                <a:spcPts val="400"/>
+              </a:spcAft>
+            </a:pPr>
+            <a:r>
+              <a:rPr sz="2000" b="0">
+                <a:solidFill>
+                  <a:srgbClr val="3C8D5A"/>
+                </a:solidFill>
+                <a:latin typeface="Patrick Hand"/>
+              </a:rPr>
+              <a:t>linear map from the last title token to the output state</a:t>
+            </a:r>
+          </a:p>
+        </p:txBody>
+      </p:sp>
+      <p:sp>
+        <p:nvSpPr>
+          <p:cNvPr id="8" name="Rounded Rectangle 7"/>
+          <p:cNvSpPr/>
+          <p:nvPr/>
+        </p:nvSpPr>
+        <p:spPr>
+          <a:xfrm rot="48000">
+            <a:off x="6400800" y="3886200"/>
+            <a:ext cx="5120640" cy="1828800"/>
+          </a:xfrm>
+          <a:prstGeom prst="roundRect">
+            <a:avLst>
+              <a:gd name="adj" fmla="val 8000"/>
+            </a:avLst>
+          </a:prstGeom>
+          <a:noFill/>
+          <a:ln w="28575">
+            <a:solidFill>
+              <a:srgbClr val="2B2D42"/>
+            </a:solidFill>
+          </a:ln>
+        </p:spPr>
+        <p:style>
+          <a:lnRef idx="1">
+            <a:schemeClr val="accent1"/>
+          </a:lnRef>
+          <a:fillRef idx="3">
+            <a:schemeClr val="accent1"/>
+          </a:fillRef>
+          <a:effectRef idx="2">
+            <a:schemeClr val="accent1"/>
+          </a:effectRef>
+          <a:fontRef idx="minor">
+            <a:schemeClr val="lt1"/>
+          </a:fontRef>
+        </p:style>
+        <p:txBody>
+          <a:bodyPr rtlCol="0" anchor="ctr" wrap="square" lIns="164592" rIns="164592"/>
+          <a:lstStyle/>
+          <a:p>
+            <a:pPr algn="ctr">
+              <a:spcAft>
+                <a:spcPts val="400"/>
+              </a:spcAft>
+            </a:pPr>
+            <a:r>
+              <a:rPr sz="2000" b="1">
                 <a:solidFill>
                   <a:srgbClr val="2B2D42"/>
                 </a:solidFill>
                 <a:latin typeface="Patrick Hand"/>
               </a:rPr>
-              <a:t>fitA best; at L48 15-18% top-10 vs 1% for logit</a:t>
-            </a:r>
-          </a:p>
-          <a:p>
-            <a:pPr algn="l">
-              <a:spcAft>
-                <a:spcPts val="900"/>
-              </a:spcAft>
-            </a:pPr>
-            <a:r>
-              <a:rPr sz="1900" b="1">
-                <a:solidFill>
-                  <a:srgbClr val="3A6EA5"/>
-                </a:solidFill>
-                <a:latin typeface="Patrick Hand"/>
-              </a:rPr>
-              <a:t>L62:</a:t>
-            </a:r>
-            <a:r>
-              <a:rPr sz="1900" b="0">
+              <a:t>chain</a:t>
+            </a:r>
+          </a:p>
+          <a:p>
+            <a:pPr algn="ctr">
+              <a:spcAft>
+                <a:spcPts val="400"/>
+              </a:spcAft>
+            </a:pPr>
+            <a:r>
+              <a:rPr sz="2000" b="0">
                 <a:solidFill>
                   <a:srgbClr val="2B2D42"/>
                 </a:solidFill>
                 <a:latin typeface="Patrick Hand"/>
               </a:rPr>
-              <a:t> logit lens best (59%)</a:t>
+              <a:t>"Authors: A1, A2, ..." instead of each author alone</a:t>
+            </a:r>
+          </a:p>
+        </p:txBody>
+      </p:sp>
+      <p:sp>
+        <p:nvSpPr>
+          <p:cNvPr id="9" name="TextBox 8"/>
+          <p:cNvSpPr txBox="1"/>
+          <p:nvPr/>
+        </p:nvSpPr>
+        <p:spPr>
+          <a:xfrm>
+            <a:off x="713232" y="6355080"/>
+            <a:ext cx="10789920" cy="320040"/>
+          </a:xfrm>
+          <a:prstGeom prst="rect">
+            <a:avLst/>
+          </a:prstGeom>
+          <a:noFill/>
+        </p:spPr>
+        <p:txBody>
+          <a:bodyPr wrap="square" lIns="0" rIns="0" tIns="0" bIns="0" anchor="t">
+            <a:spAutoFit/>
+          </a:bodyPr>
+          <a:lstStyle/>
+          <a:p>
+            <a:pPr algn="l">
+              <a:spcAft>
+                <a:spcPts val="800"/>
+              </a:spcAft>
+            </a:pPr>
+            <a:r>
+              <a:rPr sz="1400" b="0">
+                <a:solidFill>
+                  <a:srgbClr val="6E7080"/>
+                </a:solidFill>
+                <a:latin typeface="Patrick Hand"/>
+              </a:rPr>
+              <a:t>Score: rank of the correct name token at the model output; "share of the true-false gap" = (intervened - false) / (true - false).</a:t>
             </a:r>
           </a:p>
         </p:txBody>
@@ -5189,7 +5684,7 @@
                 </a:solidFill>
                 <a:latin typeface="Caveat"/>
               </a:rPr>
-              <a:t>Do lenses reveal hidden paper knowledge?</a:t>
+              <a:t>The title is read in L24-L50, early</a:t>
             </a:r>
           </a:p>
         </p:txBody>
@@ -5228,14 +5723,14 @@
                 </a:solidFill>
                 <a:latin typeface="Patrick Hand"/>
               </a:rPr>
-              <a:t>paired differences, 95% CI</a:t>
+              <a:t>model output · share of the true-false gap · CIs about +/-0.02</a:t>
             </a:r>
           </a:p>
         </p:txBody>
       </p:sp>
       <p:pic>
         <p:nvPicPr>
-          <p:cNvPr id="5" name="Picture 4" descr="c5_lens_extra.png"/>
+          <p:cNvPr id="5" name="Picture 4" descr="c12_patch_knockout.png"/>
           <p:cNvPicPr>
             <a:picLocks noChangeAspect="1"/>
           </p:cNvPicPr>
@@ -5250,7 +5745,7 @@
         <p:spPr>
           <a:xfrm>
             <a:off x="457200" y="1463040"/>
-            <a:ext cx="8412480" cy="3963572"/>
+            <a:ext cx="8412480" cy="3968150"/>
           </a:xfrm>
           <a:prstGeom prst="rect">
             <a:avLst/>
@@ -5266,7 +5761,7 @@
         <p:spPr>
           <a:xfrm rot="90000">
             <a:off x="9098280" y="1737360"/>
-            <a:ext cx="2651760" cy="3108960"/>
+            <a:ext cx="2651760" cy="3291840"/>
           </a:xfrm>
           <a:prstGeom prst="rect">
             <a:avLst/>
@@ -5305,22 +5800,56 @@
               </a:spcAft>
             </a:pPr>
             <a:r>
-              <a:rPr sz="1900" b="0">
+              <a:rPr sz="1800" b="1">
+                <a:solidFill>
+                  <a:srgbClr val="E07A2F"/>
+                </a:solidFill>
+                <a:latin typeface="Patrick Hand"/>
+              </a:rPr>
+              <a:t>L52+</a:t>
+            </a:r>
+            <a:r>
+              <a:rPr sz="1800" b="0">
                 <a:solidFill>
                   <a:srgbClr val="2B2D42"/>
                 </a:solidFill>
                 <a:latin typeface="Patrick Hand"/>
               </a:rPr>
-              <a:t>Extra signal: </a:t>
-            </a:r>
-            <a:r>
-              <a:rPr sz="1900" b="1">
+              <a:t>: title no longer needed</a:t>
+            </a:r>
+          </a:p>
+          <a:p>
+            <a:pPr algn="l">
+              <a:spcAft>
+                <a:spcPts val="900"/>
+              </a:spcAft>
+            </a:pPr>
+            <a:r>
+              <a:rPr sz="1800" b="0">
                 <a:solidFill>
                   <a:srgbClr val="2B2D42"/>
                 </a:solidFill>
                 <a:latin typeface="Patrick Hand"/>
               </a:rPr>
-              <a:t>+0.01 to +0.03</a:t>
+              <a:t>info moved to the tokens </a:t>
+            </a:r>
+            <a:r>
+              <a:rPr sz="1800" b="1">
+                <a:solidFill>
+                  <a:srgbClr val="2B2D42"/>
+                </a:solidFill>
+                <a:latin typeface="Patrick Hand"/>
+              </a:rPr>
+              <a:t>right after</a:t>
+            </a:r>
+            <a:r>
+              <a:rPr sz="1800" b="0">
+                <a:solidFill>
+                  <a:srgbClr val="2B2D42"/>
+                </a:solidFill>
+                <a:latin typeface="Patrick Hand"/>
+              </a:rPr>
+              <a:t> the title</a:t>
             </a:r>
           </a:p>
           <a:p>
@@ -5330,38 +5859,13 @@
               </a:spcAft>
             </a:pPr>
             <a:r>
-              <a:rPr sz="1900" b="0">
+              <a:rPr sz="1800" b="0">
                 <a:solidFill>
                   <a:srgbClr val="2B2D42"/>
                 </a:solidFill>
                 <a:latin typeface="Patrick Hand"/>
               </a:rPr>
-              <a:t>vs ~0.44 at L62</a:t>
-            </a:r>
-          </a:p>
-          <a:p>
-            <a:pPr algn="l">
-              <a:spcAft>
-                <a:spcPts val="900"/>
-              </a:spcAft>
-            </a:pPr>
-            <a:r>
-              <a:rPr sz="1900" b="1">
-                <a:solidFill>
-                  <a:srgbClr val="E07A2F"/>
-                </a:solidFill>
-                <a:latin typeface="Patrick Hand"/>
-              </a:rPr>
-              <a:t>Not bigger for target</a:t>
-            </a:r>
-            <a:r>
-              <a:rPr sz="1900" b="0">
-                <a:solidFill>
-                  <a:srgbClr val="2B2D42"/>
-                </a:solidFill>
-                <a:latin typeface="Patrick Hand"/>
-              </a:rPr>
-              <a:t> (even negative at L48-56)</a:t>
+              <a:t>same timing for target and control</a:t>
             </a:r>
           </a:p>
         </p:txBody>
@@ -5442,7 +5946,7 @@
                 </a:solidFill>
                 <a:latin typeface="Caveat"/>
               </a:rPr>
-              <a:t>More citations, more paper knowledge</a:t>
+              <a:t>Not readable at the title token itself</a:t>
             </a:r>
           </a:p>
         </p:txBody>
@@ -5481,14 +5985,14 @@
                 </a:solidFill>
                 <a:latin typeface="Patrick Hand"/>
               </a:rPr>
-              <a:t>model output · bins with &lt; 10 papers omitted</a:t>
+              <a:t>title-specific signal at the last title token · all 9,108 papers</a:t>
             </a:r>
           </a:p>
         </p:txBody>
       </p:sp>
       <p:pic>
         <p:nvPicPr>
-          <p:cNvPr id="5" name="Picture 4" descr="c6_citation.png"/>
+          <p:cNvPr id="5" name="Picture 4" descr="c13_title_position.png"/>
           <p:cNvPicPr>
             <a:picLocks noChangeAspect="1"/>
           </p:cNvPicPr>
@@ -5503,7 +6007,7 @@
         <p:spPr>
           <a:xfrm>
             <a:off x="457200" y="1463040"/>
-            <a:ext cx="8412480" cy="3894666"/>
+            <a:ext cx="8412480" cy="3968150"/>
           </a:xfrm>
           <a:prstGeom prst="rect">
             <a:avLst/>
@@ -5519,7 +6023,7 @@
         <p:spPr>
           <a:xfrm rot="21510000">
             <a:off x="9098280" y="1737360"/>
-            <a:ext cx="2651760" cy="3108960"/>
+            <a:ext cx="2651760" cy="3291840"/>
           </a:xfrm>
           <a:prstGeom prst="rect">
             <a:avLst/>
@@ -5564,16 +6068,16 @@
                 </a:solidFill>
                 <a:latin typeface="Patrick Hand"/>
               </a:rPr>
-              <a:t>Target: </a:t>
+              <a:t>lenses: </a:t>
             </a:r>
             <a:r>
               <a:rPr sz="1800" b="1">
                 <a:solidFill>
-                  <a:srgbClr val="E07A2F"/>
-                </a:solidFill>
-                <a:latin typeface="Patrick Hand"/>
-              </a:rPr>
-              <a:t>+0.35 -&gt; +0.64</a:t>
+                  <a:srgbClr val="2B2D42"/>
+                </a:solidFill>
+                <a:latin typeface="Patrick Hand"/>
+              </a:rPr>
+              <a:t>~0.01-0.03</a:t>
             </a:r>
           </a:p>
           <a:p>
@@ -5589,7 +6093,16 @@
                 </a:solidFill>
                 <a:latin typeface="Patrick Hand"/>
               </a:rPr>
-              <a:t>Spearman (title-specific)</a:t>
+              <a:t>probe: </a:t>
+            </a:r>
+            <a:r>
+              <a:rPr sz="1800" b="1">
+                <a:solidFill>
+                  <a:srgbClr val="3C8D5A"/>
+                </a:solidFill>
+                <a:latin typeface="Patrick Hand"/>
+              </a:rPr>
+              <a:t>0.04 -&gt; 0.08</a:t>
             </a:r>
           </a:p>
           <a:p>
@@ -5599,38 +6112,13 @@
               </a:spcAft>
             </a:pPr>
             <a:r>
-              <a:rPr sz="1800" b="1">
+              <a:rPr sz="1800" b="0">
                 <a:solidFill>
                   <a:srgbClr val="2B2D42"/>
                 </a:solidFill>
                 <a:latin typeface="Patrick Hand"/>
               </a:rPr>
-              <a:t>0.45</a:t>
-            </a:r>
-            <a:r>
-              <a:rPr sz="1800" b="0">
-                <a:solidFill>
-                  <a:srgbClr val="2B2D42"/>
-                </a:solidFill>
-                <a:latin typeface="Patrick Hand"/>
-              </a:rPr>
-              <a:t> all · 0.33 target · 0.19 control</a:t>
-            </a:r>
-          </a:p>
-          <a:p>
-            <a:pPr algn="l">
-              <a:spcAft>
-                <a:spcPts val="900"/>
-              </a:spcAft>
-            </a:pPr>
-            <a:r>
-              <a:rPr sz="1800" b="0">
-                <a:solidFill>
-                  <a:srgbClr val="2B2D42"/>
-                </a:solidFill>
-                <a:latin typeface="Patrick Hand"/>
-              </a:rPr>
-              <a:t>Target &gt; control in every bin</a:t>
+              <a:t>target a bit higher; may include topic -&gt; name associations</a:t>
             </a:r>
           </a:p>
         </p:txBody>
@@ -5711,7 +6199,7 @@
                 </a:solidFill>
                 <a:latin typeface="Caveat"/>
               </a:rPr>
-              <a:t>First token or the rest of the name?</a:t>
+              <a:t>Co-authors help, and partly replace the title</a:t>
             </a:r>
           </a:p>
         </p:txBody>
@@ -5750,14 +6238,14 @@
                 </a:solidFill>
                 <a:latin typeface="Patrick Hand"/>
               </a:rPr>
-              <a:t>model output · split by name format</a:t>
+              <a:t>model output · all 9,108 papers · 95% CI</a:t>
             </a:r>
           </a:p>
         </p:txBody>
       </p:sp>
       <p:pic>
         <p:nvPicPr>
-          <p:cNvPr id="5" name="Picture 4" descr="c7_format_position.png"/>
+          <p:cNvPr id="5" name="Picture 4" descr="c14_author_chain.png"/>
           <p:cNvPicPr>
             <a:picLocks noChangeAspect="1"/>
           </p:cNvPicPr>
@@ -5772,7 +6260,7 @@
         <p:spPr>
           <a:xfrm>
             <a:off x="457200" y="1463040"/>
-            <a:ext cx="8412480" cy="3963572"/>
+            <a:ext cx="8412480" cy="3968150"/>
           </a:xfrm>
           <a:prstGeom prst="rect">
             <a:avLst/>
@@ -5788,7 +6276,7 @@
         <p:spPr>
           <a:xfrm rot="90000">
             <a:off x="9098280" y="1737360"/>
-            <a:ext cx="2651760" cy="3108960"/>
+            <a:ext cx="2651760" cy="3291840"/>
           </a:xfrm>
           <a:prstGeom prst="rect">
             <a:avLst/>
@@ -5827,22 +6315,22 @@
               </a:spcAft>
             </a:pPr>
             <a:r>
-              <a:rPr sz="1900" b="1">
-                <a:solidFill>
-                  <a:srgbClr val="3A6EA5"/>
-                </a:solidFill>
-                <a:latin typeface="Patrick Hand"/>
-              </a:rPr>
-              <a:t>Initial:</a:t>
-            </a:r>
-            <a:r>
-              <a:rPr sz="1900" b="0">
+              <a:rPr sz="1800" b="0">
                 <a:solidFill>
                   <a:srgbClr val="2B2D42"/>
                 </a:solidFill>
                 <a:latin typeface="Patrick Hand"/>
               </a:rPr>
-              <a:t> carries little; signal is on the surname</a:t>
+              <a:t>later authors </a:t>
+            </a:r>
+            <a:r>
+              <a:rPr sz="1800" b="1">
+                <a:solidFill>
+                  <a:srgbClr val="E07A2F"/>
+                </a:solidFill>
+                <a:latin typeface="Patrick Hand"/>
+              </a:rPr>
+              <a:t>+0.17 to +0.23</a:t>
             </a:r>
           </a:p>
           <a:p>
@@ -5852,22 +6340,38 @@
               </a:spcAft>
             </a:pPr>
             <a:r>
-              <a:rPr sz="1900" b="1">
-                <a:solidFill>
-                  <a:srgbClr val="E07A2F"/>
-                </a:solidFill>
-                <a:latin typeface="Patrick Hand"/>
-              </a:rPr>
-              <a:t>Full given name:</a:t>
-            </a:r>
-            <a:r>
-              <a:rPr sz="1900" b="0">
+              <a:rPr sz="1800" b="0">
                 <a:solidFill>
                   <a:srgbClr val="2B2D42"/>
                 </a:solidFill>
                 <a:latin typeface="Patrick Hand"/>
               </a:rPr>
-              <a:t> carries about as much as the surname</a:t>
+              <a:t>title-specific part </a:t>
+            </a:r>
+            <a:r>
+              <a:rPr sz="1800" b="1">
+                <a:solidFill>
+                  <a:srgbClr val="2B2D42"/>
+                </a:solidFill>
+                <a:latin typeface="Patrick Hand"/>
+              </a:rPr>
+              <a:t>shrinks</a:t>
+            </a:r>
+          </a:p>
+          <a:p>
+            <a:pPr algn="l">
+              <a:spcAft>
+                <a:spcPts val="900"/>
+              </a:spcAft>
+            </a:pPr>
+            <a:r>
+              <a:rPr sz="1800" b="0">
+                <a:solidFill>
+                  <a:srgbClr val="2B2D42"/>
+                </a:solidFill>
+                <a:latin typeface="Patrick Hand"/>
+              </a:rPr>
+              <a:t>target &gt; control still</a:t>
             </a:r>
           </a:p>
         </p:txBody>
@@ -5948,7 +6452,7 @@
                 </a:solidFill>
                 <a:latin typeface="Caveat"/>
               </a:rPr>
-              <a:t>Knowing the given name helps with the surname</a:t>
+              <a:t>Which lens reads best?</a:t>
             </a:r>
           </a:p>
         </p:txBody>
@@ -5987,14 +6491,14 @@
                 </a:solidFill>
                 <a:latin typeface="Patrick Hand"/>
               </a:rPr>
-              <a:t>true title · later words when the first word is / is not in the top 10</a:t>
+              <a:t>all papers · true title</a:t>
             </a:r>
           </a:p>
         </p:txBody>
       </p:sp>
       <p:pic>
         <p:nvPicPr>
-          <p:cNvPr id="5" name="Picture 4" descr="c8_first_word_helps.png"/>
+          <p:cNvPr id="5" name="Picture 4" descr="c4_lens_quality.png"/>
           <p:cNvPicPr>
             <a:picLocks noChangeAspect="1"/>
           </p:cNvPicPr>
@@ -6008,8 +6512,8 @@
         </p:blipFill>
         <p:spPr>
           <a:xfrm>
-            <a:off x="548640" y="1463040"/>
-            <a:ext cx="7315200" cy="4354285"/>
+            <a:off x="457200" y="1463040"/>
+            <a:ext cx="8412480" cy="3963572"/>
           </a:xfrm>
           <a:prstGeom prst="rect">
             <a:avLst/>
@@ -6024,8 +6528,8 @@
         </p:nvSpPr>
         <p:spPr>
           <a:xfrm rot="21510000">
-            <a:off x="8229600" y="1737360"/>
-            <a:ext cx="3383280" cy="3108960"/>
+            <a:off x="9098280" y="1737360"/>
+            <a:ext cx="2651760" cy="3108960"/>
           </a:xfrm>
           <a:prstGeom prst="rect">
             <a:avLst/>
@@ -6066,11 +6570,11 @@
             <a:r>
               <a:rPr sz="1900" b="1">
                 <a:solidFill>
-                  <a:srgbClr val="E07A2F"/>
-                </a:solidFill>
-                <a:latin typeface="Patrick Hand"/>
-              </a:rPr>
-              <a:t>Given name in top 10</a:t>
+                  <a:srgbClr val="3C8D5A"/>
+                </a:solidFill>
+                <a:latin typeface="Patrick Hand"/>
+              </a:rPr>
+              <a:t>Middle layers:</a:t>
             </a:r>
           </a:p>
           <a:p>
@@ -6086,7 +6590,7 @@
                 </a:solidFill>
                 <a:latin typeface="Patrick Hand"/>
               </a:rPr>
-              <a:t>surname +0.22 (output)</a:t>
+              <a:t>fitA best; at L48 15-18% top-10 vs 1% for logit</a:t>
             </a:r>
           </a:p>
           <a:p>
@@ -6096,38 +6600,22 @@
               </a:spcAft>
             </a:pPr>
             <a:r>
+              <a:rPr sz="1900" b="1">
+                <a:solidFill>
+                  <a:srgbClr val="3A6EA5"/>
+                </a:solidFill>
+                <a:latin typeface="Patrick Hand"/>
+              </a:rPr>
+              <a:t>L62:</a:t>
+            </a:r>
+            <a:r>
               <a:rPr sz="1900" b="0">
                 <a:solidFill>
                   <a:srgbClr val="2B2D42"/>
                 </a:solidFill>
                 <a:latin typeface="Patrick Hand"/>
               </a:rPr>
-              <a:t>+0.32 (logit L62)</a:t>
-            </a:r>
-          </a:p>
-          <a:p>
-            <a:pPr algn="l">
-              <a:spcAft>
-                <a:spcPts val="900"/>
-              </a:spcAft>
-            </a:pPr>
-            <a:r>
-              <a:rPr sz="1900" b="1">
-                <a:solidFill>
-                  <a:srgbClr val="3A6EA5"/>
-                </a:solidFill>
-                <a:latin typeface="Patrick Hand"/>
-              </a:rPr>
-              <a:t>Initial in top 10</a:t>
-            </a:r>
-            <a:r>
-              <a:rPr sz="1900" b="0">
-                <a:solidFill>
-                  <a:srgbClr val="2B2D42"/>
-                </a:solidFill>
-                <a:latin typeface="Patrick Hand"/>
-              </a:rPr>
-              <a:t>: no help</a:t>
+              <a:t> logit lens best (59%)</a:t>
             </a:r>
           </a:p>
         </p:txBody>
@@ -6208,7 +6696,7 @@
                 </a:solidFill>
                 <a:latin typeface="Caveat"/>
               </a:rPr>
-              <a:t>Where the signal sits, and a dose-response</a:t>
+              <a:t>Do lenses reveal hidden paper knowledge?</a:t>
             </a:r>
           </a:p>
         </p:txBody>
@@ -6247,14 +6735,14 @@
                 </a:solidFill>
                 <a:latin typeface="Patrick Hand"/>
               </a:rPr>
-              <a:t>model output</a:t>
+              <a:t>paired differences, 95% CI</a:t>
             </a:r>
           </a:p>
         </p:txBody>
       </p:sp>
       <p:pic>
         <p:nvPicPr>
-          <p:cNvPr id="5" name="Picture 4" descr="c9_roles.png"/>
+          <p:cNvPr id="5" name="Picture 4" descr="c5_lens_extra.png"/>
           <p:cNvPicPr>
             <a:picLocks noChangeAspect="1"/>
           </p:cNvPicPr>
@@ -6268,73 +6756,119 @@
         </p:blipFill>
         <p:spPr>
           <a:xfrm>
-            <a:off x="365760" y="1463040"/>
-            <a:ext cx="6675120" cy="3973285"/>
+            <a:off x="457200" y="1463040"/>
+            <a:ext cx="8412480" cy="3963572"/>
           </a:xfrm>
           <a:prstGeom prst="rect">
             <a:avLst/>
           </a:prstGeom>
         </p:spPr>
       </p:pic>
-      <p:pic>
-        <p:nvPicPr>
-          <p:cNvPr id="6" name="Picture 5" descr="c10_graded.png"/>
-          <p:cNvPicPr>
-            <a:picLocks noChangeAspect="1"/>
-          </p:cNvPicPr>
-          <p:nvPr/>
-        </p:nvPicPr>
-        <p:blipFill>
-          <a:blip r:embed="rId5"/>
-          <a:stretch>
-            <a:fillRect/>
-          </a:stretch>
-        </p:blipFill>
-        <p:spPr>
-          <a:xfrm>
-            <a:off x="7223760" y="1737360"/>
-            <a:ext cx="4572000" cy="3282553"/>
-          </a:xfrm>
-          <a:prstGeom prst="rect">
-            <a:avLst/>
-          </a:prstGeom>
-        </p:spPr>
-      </p:pic>
-      <p:sp>
-        <p:nvSpPr>
-          <p:cNvPr id="7" name="TextBox 6"/>
-          <p:cNvSpPr txBox="1"/>
-          <p:nvPr/>
-        </p:nvSpPr>
-        <p:spPr>
-          <a:xfrm>
-            <a:off x="713232" y="6355080"/>
-            <a:ext cx="10789920" cy="320040"/>
-          </a:xfrm>
-          <a:prstGeom prst="rect">
-            <a:avLst/>
-          </a:prstGeom>
-          <a:noFill/>
-        </p:spPr>
-        <p:txBody>
-          <a:bodyPr wrap="square" lIns="0" rIns="0" tIns="0" bIns="0" anchor="t">
-            <a:spAutoFit/>
-          </a:bodyPr>
-          <a:lstStyle/>
-          <a:p>
-            <a:pPr algn="l">
-              <a:spcAft>
-                <a:spcPts val="800"/>
-              </a:spcAft>
-            </a:pPr>
-            <a:r>
-              <a:rPr sz="1400" b="0">
-                <a:solidFill>
-                  <a:srgbClr val="6E7080"/>
-                </a:solidFill>
-                <a:latin typeface="Patrick Hand"/>
-              </a:rPr>
-              <a:t>Right: R0/R1 papers, centred within citation bin; Spearman rho = 0.27, p &lt; 0.001.</a:t>
+      <p:sp>
+        <p:nvSpPr>
+          <p:cNvPr id="6" name="Rectangle 5"/>
+          <p:cNvSpPr/>
+          <p:nvPr/>
+        </p:nvSpPr>
+        <p:spPr>
+          <a:xfrm rot="90000">
+            <a:off x="9098280" y="1737360"/>
+            <a:ext cx="2651760" cy="3108960"/>
+          </a:xfrm>
+          <a:prstGeom prst="rect">
+            <a:avLst/>
+          </a:prstGeom>
+          <a:solidFill>
+            <a:srgbClr val="FFF1A8"/>
+          </a:solidFill>
+          <a:ln w="12700">
+            <a:solidFill>
+              <a:srgbClr val="E2D37A"/>
+            </a:solidFill>
+          </a:ln>
+          <a:effectLst/>
+        </p:spPr>
+        <p:style>
+          <a:lnRef idx="1">
+            <a:schemeClr val="accent1"/>
+          </a:lnRef>
+          <a:fillRef idx="3">
+            <a:schemeClr val="accent1"/>
+          </a:fillRef>
+          <a:effectRef idx="2">
+            <a:schemeClr val="accent1"/>
+          </a:effectRef>
+          <a:fontRef idx="minor">
+            <a:schemeClr val="lt1"/>
+          </a:fontRef>
+        </p:style>
+        <p:txBody>
+          <a:bodyPr rtlCol="0" anchor="t" wrap="square" lIns="201168" rIns="201168" tIns="164592" bIns="164592"/>
+          <a:lstStyle/>
+          <a:p>
+            <a:pPr algn="l">
+              <a:spcAft>
+                <a:spcPts val="900"/>
+              </a:spcAft>
+            </a:pPr>
+            <a:r>
+              <a:rPr sz="1900" b="0">
+                <a:solidFill>
+                  <a:srgbClr val="2B2D42"/>
+                </a:solidFill>
+                <a:latin typeface="Patrick Hand"/>
+              </a:rPr>
+              <a:t>Extra signal: </a:t>
+            </a:r>
+            <a:r>
+              <a:rPr sz="1900" b="1">
+                <a:solidFill>
+                  <a:srgbClr val="2B2D42"/>
+                </a:solidFill>
+                <a:latin typeface="Patrick Hand"/>
+              </a:rPr>
+              <a:t>+0.01 to +0.03</a:t>
+            </a:r>
+          </a:p>
+          <a:p>
+            <a:pPr algn="l">
+              <a:spcAft>
+                <a:spcPts val="900"/>
+              </a:spcAft>
+            </a:pPr>
+            <a:r>
+              <a:rPr sz="1900" b="0">
+                <a:solidFill>
+                  <a:srgbClr val="2B2D42"/>
+                </a:solidFill>
+                <a:latin typeface="Patrick Hand"/>
+              </a:rPr>
+              <a:t>vs ~0.44 at L62</a:t>
+            </a:r>
+          </a:p>
+          <a:p>
+            <a:pPr algn="l">
+              <a:spcAft>
+                <a:spcPts val="900"/>
+              </a:spcAft>
+            </a:pPr>
+            <a:r>
+              <a:rPr sz="1900" b="1">
+                <a:solidFill>
+                  <a:srgbClr val="E07A2F"/>
+                </a:solidFill>
+                <a:latin typeface="Patrick Hand"/>
+              </a:rPr>
+              <a:t>Not bigger for target</a:t>
+            </a:r>
+            <a:r>
+              <a:rPr sz="1900" b="0">
+                <a:solidFill>
+                  <a:srgbClr val="2B2D42"/>
+                </a:solidFill>
+                <a:latin typeface="Patrick Hand"/>
+              </a:rPr>
+              <a:t> (even negative at L48-56)</a:t>
             </a:r>
           </a:p>
         </p:txBody>
@@ -6415,7 +6949,7 @@
                 </a:solidFill>
                 <a:latin typeface="Caveat"/>
               </a:rPr>
-              <a:t>What we learned</a:t>
+              <a:t>More citations, more paper knowledge</a:t>
             </a:r>
           </a:p>
         </p:txBody>
@@ -6428,8 +6962,8 @@
         </p:nvSpPr>
         <p:spPr>
           <a:xfrm>
-            <a:off x="822960" y="1417320"/>
-            <a:ext cx="2834640" cy="822960"/>
+            <a:off x="713232" y="987552"/>
+            <a:ext cx="10881360" cy="411480"/>
           </a:xfrm>
           <a:prstGeom prst="rect">
             <a:avLst/>
@@ -6448,364 +6982,162 @@
               </a:spcAft>
             </a:pPr>
             <a:r>
-              <a:rPr sz="3000" b="1">
+              <a:rPr sz="1900" b="0">
+                <a:solidFill>
+                  <a:srgbClr val="6E7080"/>
+                </a:solidFill>
+                <a:latin typeface="Patrick Hand"/>
+              </a:rPr>
+              <a:t>model output · bins with &lt; 10 papers omitted</a:t>
+            </a:r>
+          </a:p>
+        </p:txBody>
+      </p:sp>
+      <p:pic>
+        <p:nvPicPr>
+          <p:cNvPr id="5" name="Picture 4" descr="c6_citation.png"/>
+          <p:cNvPicPr>
+            <a:picLocks noChangeAspect="1"/>
+          </p:cNvPicPr>
+          <p:nvPr/>
+        </p:nvPicPr>
+        <p:blipFill>
+          <a:blip r:embed="rId4"/>
+          <a:stretch>
+            <a:fillRect/>
+          </a:stretch>
+        </p:blipFill>
+        <p:spPr>
+          <a:xfrm>
+            <a:off x="457200" y="1463040"/>
+            <a:ext cx="8412480" cy="3894666"/>
+          </a:xfrm>
+          <a:prstGeom prst="rect">
+            <a:avLst/>
+          </a:prstGeom>
+        </p:spPr>
+      </p:pic>
+      <p:sp>
+        <p:nvSpPr>
+          <p:cNvPr id="6" name="Rectangle 5"/>
+          <p:cNvSpPr/>
+          <p:nvPr/>
+        </p:nvSpPr>
+        <p:spPr>
+          <a:xfrm rot="21510000">
+            <a:off x="9098280" y="1737360"/>
+            <a:ext cx="2651760" cy="3108960"/>
+          </a:xfrm>
+          <a:prstGeom prst="rect">
+            <a:avLst/>
+          </a:prstGeom>
+          <a:solidFill>
+            <a:srgbClr val="FFF1A8"/>
+          </a:solidFill>
+          <a:ln w="12700">
+            <a:solidFill>
+              <a:srgbClr val="E2D37A"/>
+            </a:solidFill>
+          </a:ln>
+          <a:effectLst/>
+        </p:spPr>
+        <p:style>
+          <a:lnRef idx="1">
+            <a:schemeClr val="accent1"/>
+          </a:lnRef>
+          <a:fillRef idx="3">
+            <a:schemeClr val="accent1"/>
+          </a:fillRef>
+          <a:effectRef idx="2">
+            <a:schemeClr val="accent1"/>
+          </a:effectRef>
+          <a:fontRef idx="minor">
+            <a:schemeClr val="lt1"/>
+          </a:fontRef>
+        </p:style>
+        <p:txBody>
+          <a:bodyPr rtlCol="0" anchor="t" wrap="square" lIns="201168" rIns="201168" tIns="164592" bIns="164592"/>
+          <a:lstStyle/>
+          <a:p>
+            <a:pPr algn="l">
+              <a:spcAft>
+                <a:spcPts val="900"/>
+              </a:spcAft>
+            </a:pPr>
+            <a:r>
+              <a:rPr sz="1800" b="0">
+                <a:solidFill>
+                  <a:srgbClr val="2B2D42"/>
+                </a:solidFill>
+                <a:latin typeface="Patrick Hand"/>
+              </a:rPr>
+              <a:t>Target: </a:t>
+            </a:r>
+            <a:r>
+              <a:rPr sz="1800" b="1">
                 <a:solidFill>
                   <a:srgbClr val="E07A2F"/>
                 </a:solidFill>
-                <a:latin typeface="Caveat"/>
-              </a:rPr>
-              <a:t>Late</a:t>
-            </a:r>
-          </a:p>
-        </p:txBody>
-      </p:sp>
-      <p:sp>
-        <p:nvSpPr>
-          <p:cNvPr id="5" name="TextBox 4"/>
-          <p:cNvSpPr txBox="1"/>
-          <p:nvPr/>
-        </p:nvSpPr>
-        <p:spPr>
-          <a:xfrm>
-            <a:off x="3657600" y="1527048"/>
-            <a:ext cx="7863840" cy="822960"/>
-          </a:xfrm>
-          <a:prstGeom prst="rect">
-            <a:avLst/>
-          </a:prstGeom>
-          <a:noFill/>
-        </p:spPr>
-        <p:txBody>
-          <a:bodyPr wrap="square" lIns="0" rIns="0" tIns="0" bIns="0" anchor="t">
-            <a:spAutoFit/>
-          </a:bodyPr>
-          <a:lstStyle/>
-          <a:p>
-            <a:pPr algn="l">
-              <a:spcAft>
-                <a:spcPts val="800"/>
-              </a:spcAft>
-            </a:pPr>
-            <a:r>
-              <a:rPr sz="2200" b="0">
+                <a:latin typeface="Patrick Hand"/>
+              </a:rPr>
+              <a:t>+0.35 -&gt; +0.64</a:t>
+            </a:r>
+          </a:p>
+          <a:p>
+            <a:pPr algn="l">
+              <a:spcAft>
+                <a:spcPts val="900"/>
+              </a:spcAft>
+            </a:pPr>
+            <a:r>
+              <a:rPr sz="1800" b="0">
                 <a:solidFill>
                   <a:srgbClr val="2B2D42"/>
                 </a:solidFill>
                 <a:latin typeface="Patrick Hand"/>
               </a:rPr>
-              <a:t>Paper-specific author knowledge builds up from about L50, fastest over L57-L61, peaking at L61-L62.</a:t>
-            </a:r>
-          </a:p>
-        </p:txBody>
-      </p:sp>
-      <p:sp>
-        <p:nvSpPr>
-          <p:cNvPr id="6" name="TextBox 5"/>
-          <p:cNvSpPr txBox="1"/>
-          <p:nvPr/>
-        </p:nvSpPr>
-        <p:spPr>
-          <a:xfrm>
-            <a:off x="822960" y="2377440"/>
-            <a:ext cx="2834640" cy="822960"/>
-          </a:xfrm>
-          <a:prstGeom prst="rect">
-            <a:avLst/>
-          </a:prstGeom>
-          <a:noFill/>
-        </p:spPr>
-        <p:txBody>
-          <a:bodyPr wrap="square" lIns="0" rIns="0" tIns="0" bIns="0" anchor="t">
-            <a:spAutoFit/>
-          </a:bodyPr>
-          <a:lstStyle/>
-          <a:p>
-            <a:pPr algn="l">
-              <a:spcAft>
-                <a:spcPts val="800"/>
-              </a:spcAft>
-            </a:pPr>
-            <a:r>
-              <a:rPr sz="3000" b="1">
-                <a:solidFill>
-                  <a:srgbClr val="3A6EA5"/>
-                </a:solidFill>
-                <a:latin typeface="Caveat"/>
-              </a:rPr>
-              <a:t>No head start</a:t>
-            </a:r>
-          </a:p>
-        </p:txBody>
-      </p:sp>
-      <p:sp>
-        <p:nvSpPr>
-          <p:cNvPr id="7" name="TextBox 6"/>
-          <p:cNvSpPr txBox="1"/>
-          <p:nvPr/>
-        </p:nvSpPr>
-        <p:spPr>
-          <a:xfrm>
-            <a:off x="3657600" y="2487168"/>
-            <a:ext cx="7863840" cy="822960"/>
-          </a:xfrm>
-          <a:prstGeom prst="rect">
-            <a:avLst/>
-          </a:prstGeom>
-          <a:noFill/>
-        </p:spPr>
-        <p:txBody>
-          <a:bodyPr wrap="square" lIns="0" rIns="0" tIns="0" bIns="0" anchor="t">
-            <a:spAutoFit/>
-          </a:bodyPr>
-          <a:lstStyle/>
-          <a:p>
-            <a:pPr algn="l">
-              <a:spcAft>
-                <a:spcPts val="800"/>
-              </a:spcAft>
-            </a:pPr>
-            <a:r>
-              <a:rPr sz="2200" b="0">
+              <a:t>Spearman (title-specific)</a:t>
+            </a:r>
+          </a:p>
+          <a:p>
+            <a:pPr algn="l">
+              <a:spcAft>
+                <a:spcPts val="900"/>
+              </a:spcAft>
+            </a:pPr>
+            <a:r>
+              <a:rPr sz="1800" b="1">
                 <a:solidFill>
                   <a:srgbClr val="2B2D42"/>
                 </a:solidFill>
                 <a:latin typeface="Patrick Hand"/>
               </a:rPr>
-              <a:t>Target papers are not ahead of control in middle layers; the +0.21 gap is at the end.</a:t>
-            </a:r>
-          </a:p>
-        </p:txBody>
-      </p:sp>
-      <p:sp>
-        <p:nvSpPr>
-          <p:cNvPr id="8" name="TextBox 7"/>
-          <p:cNvSpPr txBox="1"/>
-          <p:nvPr/>
-        </p:nvSpPr>
-        <p:spPr>
-          <a:xfrm>
-            <a:off x="822960" y="3337560"/>
-            <a:ext cx="2834640" cy="822960"/>
-          </a:xfrm>
-          <a:prstGeom prst="rect">
-            <a:avLst/>
-          </a:prstGeom>
-          <a:noFill/>
-        </p:spPr>
-        <p:txBody>
-          <a:bodyPr wrap="square" lIns="0" rIns="0" tIns="0" bIns="0" anchor="t">
-            <a:spAutoFit/>
-          </a:bodyPr>
-          <a:lstStyle/>
-          <a:p>
-            <a:pPr algn="l">
-              <a:spcAft>
-                <a:spcPts val="800"/>
-              </a:spcAft>
-            </a:pPr>
-            <a:r>
-              <a:rPr sz="3000" b="1">
-                <a:solidFill>
-                  <a:srgbClr val="3C8D5A"/>
-                </a:solidFill>
-                <a:latin typeface="Caveat"/>
-              </a:rPr>
-              <a:t>Real knowledge</a:t>
-            </a:r>
-          </a:p>
-        </p:txBody>
-      </p:sp>
-      <p:sp>
-        <p:nvSpPr>
-          <p:cNvPr id="9" name="TextBox 8"/>
-          <p:cNvSpPr txBox="1"/>
-          <p:nvPr/>
-        </p:nvSpPr>
-        <p:spPr>
-          <a:xfrm>
-            <a:off x="3657600" y="3447288"/>
-            <a:ext cx="7863840" cy="822960"/>
-          </a:xfrm>
-          <a:prstGeom prst="rect">
-            <a:avLst/>
-          </a:prstGeom>
-          <a:noFill/>
-        </p:spPr>
-        <p:txBody>
-          <a:bodyPr wrap="square" lIns="0" rIns="0" tIns="0" bIns="0" anchor="t">
-            <a:spAutoFit/>
-          </a:bodyPr>
-          <a:lstStyle/>
-          <a:p>
-            <a:pPr algn="l">
-              <a:spcAft>
-                <a:spcPts val="800"/>
-              </a:spcAft>
-            </a:pPr>
-            <a:r>
-              <a:rPr sz="2200" b="0">
+              <a:t>0.45</a:t>
+            </a:r>
+            <a:r>
+              <a:rPr sz="1800" b="0">
                 <a:solidFill>
                   <a:srgbClr val="2B2D42"/>
                 </a:solidFill>
                 <a:latin typeface="Patrick Hand"/>
               </a:rPr>
-              <a:t>The gap is title-specific and grows with citations, so it is not name guessing.</a:t>
-            </a:r>
-          </a:p>
-        </p:txBody>
-      </p:sp>
-      <p:sp>
-        <p:nvSpPr>
-          <p:cNvPr id="10" name="TextBox 9"/>
-          <p:cNvSpPr txBox="1"/>
-          <p:nvPr/>
-        </p:nvSpPr>
-        <p:spPr>
-          <a:xfrm>
-            <a:off x="822960" y="4297680"/>
-            <a:ext cx="2834640" cy="822960"/>
-          </a:xfrm>
-          <a:prstGeom prst="rect">
-            <a:avLst/>
-          </a:prstGeom>
-          <a:noFill/>
-        </p:spPr>
-        <p:txBody>
-          <a:bodyPr wrap="square" lIns="0" rIns="0" tIns="0" bIns="0" anchor="t">
-            <a:spAutoFit/>
-          </a:bodyPr>
-          <a:lstStyle/>
-          <a:p>
-            <a:pPr algn="l">
-              <a:spcAft>
-                <a:spcPts val="800"/>
-              </a:spcAft>
-            </a:pPr>
-            <a:r>
-              <a:rPr sz="3000" b="1">
+              <a:t> all · 0.33 target · 0.19 control</a:t>
+            </a:r>
+          </a:p>
+          <a:p>
+            <a:pPr algn="l">
+              <a:spcAft>
+                <a:spcPts val="900"/>
+              </a:spcAft>
+            </a:pPr>
+            <a:r>
+              <a:rPr sz="1800" b="0">
                 <a:solidFill>
                   <a:srgbClr val="2B2D42"/>
                 </a:solidFill>
-                <a:latin typeface="Caveat"/>
-              </a:rPr>
-              <a:t>Lenses agree</a:t>
-            </a:r>
-          </a:p>
-        </p:txBody>
-      </p:sp>
-      <p:sp>
-        <p:nvSpPr>
-          <p:cNvPr id="11" name="TextBox 10"/>
-          <p:cNvSpPr txBox="1"/>
-          <p:nvPr/>
-        </p:nvSpPr>
-        <p:spPr>
-          <a:xfrm>
-            <a:off x="3657600" y="4407408"/>
-            <a:ext cx="7863840" cy="822960"/>
-          </a:xfrm>
-          <a:prstGeom prst="rect">
-            <a:avLst/>
-          </a:prstGeom>
-          <a:noFill/>
-        </p:spPr>
-        <p:txBody>
-          <a:bodyPr wrap="square" lIns="0" rIns="0" tIns="0" bIns="0" anchor="t">
-            <a:spAutoFit/>
-          </a:bodyPr>
-          <a:lstStyle/>
-          <a:p>
-            <a:pPr algn="l">
-              <a:spcAft>
-                <a:spcPts val="800"/>
-              </a:spcAft>
-            </a:pPr>
-            <a:r>
-              <a:rPr sz="2200" b="0">
-                <a:solidFill>
-                  <a:srgbClr val="2B2D42"/>
-                </a:solidFill>
-                <a:latin typeface="Patrick Hand"/>
-              </a:rPr>
-              <a:t>Jacobian lenses read more in middle layers, but nothing target-specific.</a:t>
-            </a:r>
-          </a:p>
-        </p:txBody>
-      </p:sp>
-      <p:sp>
-        <p:nvSpPr>
-          <p:cNvPr id="12" name="TextBox 11"/>
-          <p:cNvSpPr txBox="1"/>
-          <p:nvPr/>
-        </p:nvSpPr>
-        <p:spPr>
-          <a:xfrm>
-            <a:off x="822960" y="5257800"/>
-            <a:ext cx="2834640" cy="822960"/>
-          </a:xfrm>
-          <a:prstGeom prst="rect">
-            <a:avLst/>
-          </a:prstGeom>
-          <a:noFill/>
-        </p:spPr>
-        <p:txBody>
-          <a:bodyPr wrap="square" lIns="0" rIns="0" tIns="0" bIns="0" anchor="t">
-            <a:spAutoFit/>
-          </a:bodyPr>
-          <a:lstStyle/>
-          <a:p>
-            <a:pPr algn="l">
-              <a:spcAft>
-                <a:spcPts val="800"/>
-              </a:spcAft>
-            </a:pPr>
-            <a:r>
-              <a:rPr sz="3000" b="1">
-                <a:solidFill>
-                  <a:srgbClr val="E07A2F"/>
-                </a:solidFill>
-                <a:latin typeface="Caveat"/>
-              </a:rPr>
-              <a:t>Name format</a:t>
-            </a:r>
-          </a:p>
-        </p:txBody>
-      </p:sp>
-      <p:sp>
-        <p:nvSpPr>
-          <p:cNvPr id="13" name="TextBox 12"/>
-          <p:cNvSpPr txBox="1"/>
-          <p:nvPr/>
-        </p:nvSpPr>
-        <p:spPr>
-          <a:xfrm>
-            <a:off x="3657600" y="5367528"/>
-            <a:ext cx="7863840" cy="822960"/>
-          </a:xfrm>
-          <a:prstGeom prst="rect">
-            <a:avLst/>
-          </a:prstGeom>
-          <a:noFill/>
-        </p:spPr>
-        <p:txBody>
-          <a:bodyPr wrap="square" lIns="0" rIns="0" tIns="0" bIns="0" anchor="t">
-            <a:spAutoFit/>
-          </a:bodyPr>
-          <a:lstStyle/>
-          <a:p>
-            <a:pPr algn="l">
-              <a:spcAft>
-                <a:spcPts val="800"/>
-              </a:spcAft>
-            </a:pPr>
-            <a:r>
-              <a:rPr sz="2200" b="0">
-                <a:solidFill>
-                  <a:srgbClr val="2B2D42"/>
-                </a:solidFill>
-                <a:latin typeface="Patrick Hand"/>
-              </a:rPr>
-              <a:t>Initials carry little; full given names carry as much as surnames and help predict them.</a:t>
+                <a:latin typeface="Patrick Hand"/>
+              </a:rPr>
+              <a:t>Target &gt; control in every bin</a:t>
             </a:r>
           </a:p>
         </p:txBody>
@@ -6886,7 +7218,7 @@
                 </a:solidFill>
                 <a:latin typeface="Caveat"/>
               </a:rPr>
-              <a:t>Caveats and next steps</a:t>
+              <a:t>First token or the rest of the name?</a:t>
             </a:r>
           </a:p>
         </p:txBody>
@@ -6899,8 +7231,8 @@
         </p:nvSpPr>
         <p:spPr>
           <a:xfrm>
-            <a:off x="822960" y="1463040"/>
-            <a:ext cx="5486400" cy="4389120"/>
+            <a:off x="713232" y="987552"/>
+            <a:ext cx="10881360" cy="411480"/>
           </a:xfrm>
           <a:prstGeom prst="rect">
             <a:avLst/>
@@ -6915,95 +7247,55 @@
           <a:p>
             <a:pPr algn="l">
               <a:spcAft>
-                <a:spcPts val="1000"/>
-              </a:spcAft>
-            </a:pPr>
-            <a:r>
-              <a:rPr sz="2100" b="1">
-                <a:solidFill>
-                  <a:srgbClr val="2B2D42"/>
-                </a:solidFill>
-                <a:latin typeface="Patrick Hand"/>
-              </a:rPr>
-              <a:t>Caveats</a:t>
-            </a:r>
-          </a:p>
-          <a:p>
-            <a:pPr algn="l">
-              <a:spcAft>
-                <a:spcPts val="1000"/>
-              </a:spcAft>
-            </a:pPr>
-            <a:r>
-              <a:rPr sz="2100" b="0">
-                <a:solidFill>
-                  <a:srgbClr val="2B2D42"/>
-                </a:solidFill>
-                <a:latin typeface="Patrick Hand"/>
-              </a:rPr>
-              <a:t>- Correlational: shows where info is readable, not where it is made</a:t>
-            </a:r>
-          </a:p>
-          <a:p>
-            <a:pPr algn="l">
-              <a:spcAft>
-                <a:spcPts val="1000"/>
-              </a:spcAft>
-            </a:pPr>
-            <a:r>
-              <a:rPr sz="2100" b="0">
-                <a:solidFill>
-                  <a:srgbClr val="2B2D42"/>
-                </a:solidFill>
-                <a:latin typeface="Patrick Hand"/>
-              </a:rPr>
-              <a:t>- Parity tolerance raised 0.25 -&gt; 0.5 after the fact</a:t>
-            </a:r>
-          </a:p>
-          <a:p>
-            <a:pPr algn="l">
-              <a:spcAft>
-                <a:spcPts val="1000"/>
-              </a:spcAft>
-            </a:pPr>
-            <a:r>
-              <a:rPr sz="2100" b="0">
-                <a:solidFill>
-                  <a:srgbClr val="2B2D42"/>
-                </a:solidFill>
-                <a:latin typeface="Patrick Hand"/>
-              </a:rPr>
-              <a:t>- Groups are model-specific; low-citation "recognition" is near chance</a:t>
-            </a:r>
-          </a:p>
-          <a:p>
-            <a:pPr algn="l">
-              <a:spcAft>
-                <a:spcPts val="1000"/>
-              </a:spcAft>
-            </a:pPr>
-            <a:r>
-              <a:rPr sz="2100" b="0">
-                <a:solidFill>
-                  <a:srgbClr val="2B2D42"/>
-                </a:solidFill>
-                <a:latin typeface="Patrick Hand"/>
-              </a:rPr>
-              <a:t>- Few control papers above 1,000 citations</a:t>
-            </a:r>
-          </a:p>
-        </p:txBody>
-      </p:sp>
-      <p:sp>
-        <p:nvSpPr>
-          <p:cNvPr id="5" name="Rectangle 4"/>
+                <a:spcPts val="800"/>
+              </a:spcAft>
+            </a:pPr>
+            <a:r>
+              <a:rPr sz="1900" b="0">
+                <a:solidFill>
+                  <a:srgbClr val="6E7080"/>
+                </a:solidFill>
+                <a:latin typeface="Patrick Hand"/>
+              </a:rPr>
+              <a:t>model output · split by name format</a:t>
+            </a:r>
+          </a:p>
+        </p:txBody>
+      </p:sp>
+      <p:pic>
+        <p:nvPicPr>
+          <p:cNvPr id="5" name="Picture 4" descr="c7_format_position.png"/>
+          <p:cNvPicPr>
+            <a:picLocks noChangeAspect="1"/>
+          </p:cNvPicPr>
+          <p:nvPr/>
+        </p:nvPicPr>
+        <p:blipFill>
+          <a:blip r:embed="rId4"/>
+          <a:stretch>
+            <a:fillRect/>
+          </a:stretch>
+        </p:blipFill>
+        <p:spPr>
+          <a:xfrm>
+            <a:off x="457200" y="1463040"/>
+            <a:ext cx="8412480" cy="3963572"/>
+          </a:xfrm>
+          <a:prstGeom prst="rect">
+            <a:avLst/>
+          </a:prstGeom>
+        </p:spPr>
+      </p:pic>
+      <p:sp>
+        <p:nvSpPr>
+          <p:cNvPr id="6" name="Rectangle 5"/>
           <p:cNvSpPr/>
           <p:nvPr/>
         </p:nvSpPr>
         <p:spPr>
           <a:xfrm rot="90000">
-            <a:off x="6766560" y="1554480"/>
-            <a:ext cx="4663440" cy="3291840"/>
+            <a:off x="9098280" y="1737360"/>
+            <a:ext cx="2651760" cy="3108960"/>
           </a:xfrm>
           <a:prstGeom prst="rect">
             <a:avLst/>
@@ -7044,11 +7336,20 @@
             <a:r>
               <a:rPr sz="1900" b="1">
                 <a:solidFill>
+                  <a:srgbClr val="3A6EA5"/>
+                </a:solidFill>
+                <a:latin typeface="Patrick Hand"/>
+              </a:rPr>
+              <a:t>Initial:</a:t>
+            </a:r>
+            <a:r>
+              <a:rPr sz="1900" b="0">
+                <a:solidFill>
                   <a:srgbClr val="2B2D42"/>
                 </a:solidFill>
                 <a:latin typeface="Patrick Hand"/>
               </a:rPr>
-              <a:t>Next</a:t>
+              <a:t> carries little; signal is on the surname</a:t>
             </a:r>
           </a:p>
           <a:p>
@@ -7058,15 +7359,211 @@
               </a:spcAft>
             </a:pPr>
             <a:r>
+              <a:rPr sz="1900" b="1">
+                <a:solidFill>
+                  <a:srgbClr val="E07A2F"/>
+                </a:solidFill>
+                <a:latin typeface="Patrick Hand"/>
+              </a:rPr>
+              <a:t>Full given name:</a:t>
+            </a:r>
+            <a:r>
               <a:rPr sz="1900" b="0">
                 <a:solidFill>
                   <a:srgbClr val="2B2D42"/>
                 </a:solidFill>
                 <a:latin typeface="Patrick Hand"/>
               </a:rPr>
-              <a:t>1. Patch the true-title state at L56 into a false-title run: are the right authors rescued?</a:t>
-            </a:r>
-          </a:p>
+              <a:t> carries about as much as the surname</a:t>
+            </a:r>
+          </a:p>
+        </p:txBody>
+      </p:sp>
+    </p:spTree>
+  </p:cSld>
+  <p:clrMapOvr>
+    <a:masterClrMapping/>
+  </p:clrMapOvr>
+</p:sld>
+</file>
+
+<file path=ppt/slides/slide18.xml><?xml version="1.0" encoding="utf-8"?>
+<p:sld xmlns:a="http://schemas.openxmlformats.org/drawingml/2006/main" xmlns:p="http://schemas.openxmlformats.org/presentationml/2006/main" xmlns:r="http://schemas.openxmlformats.org/officeDocument/2006/relationships">
+  <p:cSld>
+    <p:spTree>
+      <p:nvGrpSpPr>
+        <p:cNvPr id="1" name=""/>
+        <p:cNvGrpSpPr/>
+        <p:nvPr/>
+      </p:nvGrpSpPr>
+      <p:grpSpPr/>
+      <p:pic>
+        <p:nvPicPr>
+          <p:cNvPr id="2" name="Picture 1" descr="paper.png"/>
+          <p:cNvPicPr>
+            <a:picLocks noChangeAspect="1"/>
+          </p:cNvPicPr>
+          <p:nvPr/>
+        </p:nvPicPr>
+        <p:blipFill>
+          <a:blip r:embed="rId2"/>
+          <a:stretch>
+            <a:fillRect/>
+          </a:stretch>
+        </p:blipFill>
+        <p:spPr>
+          <a:xfrm>
+            <a:off x="0" y="0"/>
+            <a:ext cx="12191695" cy="6858000"/>
+          </a:xfrm>
+          <a:prstGeom prst="rect">
+            <a:avLst/>
+          </a:prstGeom>
+        </p:spPr>
+      </p:pic>
+      <p:sp>
+        <p:nvSpPr>
+          <p:cNvPr id="3" name="TextBox 2"/>
+          <p:cNvSpPr txBox="1"/>
+          <p:nvPr/>
+        </p:nvSpPr>
+        <p:spPr>
+          <a:xfrm>
+            <a:off x="685800" y="274320"/>
+            <a:ext cx="10881360" cy="822960"/>
+          </a:xfrm>
+          <a:prstGeom prst="rect">
+            <a:avLst/>
+          </a:prstGeom>
+          <a:noFill/>
+        </p:spPr>
+        <p:txBody>
+          <a:bodyPr wrap="square" lIns="0" rIns="0" tIns="0" bIns="0" anchor="t">
+            <a:spAutoFit/>
+          </a:bodyPr>
+          <a:lstStyle/>
+          <a:p>
+            <a:pPr algn="l">
+              <a:spcAft>
+                <a:spcPts val="800"/>
+              </a:spcAft>
+            </a:pPr>
+            <a:r>
+              <a:rPr sz="4600" b="1">
+                <a:solidFill>
+                  <a:srgbClr val="2B2D42"/>
+                </a:solidFill>
+                <a:latin typeface="Caveat"/>
+              </a:rPr>
+              <a:t>Knowing the given name helps with the surname</a:t>
+            </a:r>
+          </a:p>
+        </p:txBody>
+      </p:sp>
+      <p:sp>
+        <p:nvSpPr>
+          <p:cNvPr id="4" name="TextBox 3"/>
+          <p:cNvSpPr txBox="1"/>
+          <p:nvPr/>
+        </p:nvSpPr>
+        <p:spPr>
+          <a:xfrm>
+            <a:off x="713232" y="987552"/>
+            <a:ext cx="10881360" cy="411480"/>
+          </a:xfrm>
+          <a:prstGeom prst="rect">
+            <a:avLst/>
+          </a:prstGeom>
+          <a:noFill/>
+        </p:spPr>
+        <p:txBody>
+          <a:bodyPr wrap="square" lIns="0" rIns="0" tIns="0" bIns="0" anchor="t">
+            <a:spAutoFit/>
+          </a:bodyPr>
+          <a:lstStyle/>
+          <a:p>
+            <a:pPr algn="l">
+              <a:spcAft>
+                <a:spcPts val="800"/>
+              </a:spcAft>
+            </a:pPr>
+            <a:r>
+              <a:rPr sz="1900" b="0">
+                <a:solidFill>
+                  <a:srgbClr val="6E7080"/>
+                </a:solidFill>
+                <a:latin typeface="Patrick Hand"/>
+              </a:rPr>
+              <a:t>true title · later words when the first word is / is not in the top 10</a:t>
+            </a:r>
+          </a:p>
+        </p:txBody>
+      </p:sp>
+      <p:pic>
+        <p:nvPicPr>
+          <p:cNvPr id="5" name="Picture 4" descr="c8_first_word_helps.png"/>
+          <p:cNvPicPr>
+            <a:picLocks noChangeAspect="1"/>
+          </p:cNvPicPr>
+          <p:nvPr/>
+        </p:nvPicPr>
+        <p:blipFill>
+          <a:blip r:embed="rId4"/>
+          <a:stretch>
+            <a:fillRect/>
+          </a:stretch>
+        </p:blipFill>
+        <p:spPr>
+          <a:xfrm>
+            <a:off x="548640" y="1463040"/>
+            <a:ext cx="7315200" cy="4354285"/>
+          </a:xfrm>
+          <a:prstGeom prst="rect">
+            <a:avLst/>
+          </a:prstGeom>
+        </p:spPr>
+      </p:pic>
+      <p:sp>
+        <p:nvSpPr>
+          <p:cNvPr id="6" name="Rectangle 5"/>
+          <p:cNvSpPr/>
+          <p:nvPr/>
+        </p:nvSpPr>
+        <p:spPr>
+          <a:xfrm rot="21510000">
+            <a:off x="8229600" y="1737360"/>
+            <a:ext cx="3383280" cy="3108960"/>
+          </a:xfrm>
+          <a:prstGeom prst="rect">
+            <a:avLst/>
+          </a:prstGeom>
+          <a:solidFill>
+            <a:srgbClr val="FFF1A8"/>
+          </a:solidFill>
+          <a:ln w="12700">
+            <a:solidFill>
+              <a:srgbClr val="E2D37A"/>
+            </a:solidFill>
+          </a:ln>
+          <a:effectLst/>
+        </p:spPr>
+        <p:style>
+          <a:lnRef idx="1">
+            <a:schemeClr val="accent1"/>
+          </a:lnRef>
+          <a:fillRef idx="3">
+            <a:schemeClr val="accent1"/>
+          </a:fillRef>
+          <a:effectRef idx="2">
+            <a:schemeClr val="accent1"/>
+          </a:effectRef>
+          <a:fontRef idx="minor">
+            <a:schemeClr val="lt1"/>
+          </a:fontRef>
+        </p:style>
+        <p:txBody>
+          <a:bodyPr rtlCol="0" anchor="t" wrap="square" lIns="201168" rIns="201168" tIns="164592" bIns="164592"/>
+          <a:lstStyle/>
           <a:p>
             <a:pPr algn="l">
               <a:spcAft>
@@ -7074,13 +7571,29 @@
               </a:spcAft>
             </a:pPr>
             <a:r>
+              <a:rPr sz="1900" b="1">
+                <a:solidFill>
+                  <a:srgbClr val="E07A2F"/>
+                </a:solidFill>
+                <a:latin typeface="Patrick Hand"/>
+              </a:rPr>
+              <a:t>Given name in top 10</a:t>
+            </a:r>
+          </a:p>
+          <a:p>
+            <a:pPr algn="l">
+              <a:spcAft>
+                <a:spcPts val="900"/>
+              </a:spcAft>
+            </a:pPr>
+            <a:r>
               <a:rPr sz="1900" b="0">
                 <a:solidFill>
                   <a:srgbClr val="2B2D42"/>
                 </a:solidFill>
                 <a:latin typeface="Patrick Hand"/>
               </a:rPr>
-              <a:t>2. Score each author after the previous one: does the first author help with co-authors?</a:t>
+              <a:t>surname +0.22 (output)</a:t>
             </a:r>
           </a:p>
           <a:p>
@@ -7096,7 +7609,239 @@
                 </a:solidFill>
                 <a:latin typeface="Patrick Hand"/>
               </a:rPr>
-              <a:t>3. Block attention to the title tokens at L50-L61: where is the paper read from?</a:t>
+              <a:t>+0.32 (logit L62)</a:t>
+            </a:r>
+          </a:p>
+          <a:p>
+            <a:pPr algn="l">
+              <a:spcAft>
+                <a:spcPts val="900"/>
+              </a:spcAft>
+            </a:pPr>
+            <a:r>
+              <a:rPr sz="1900" b="1">
+                <a:solidFill>
+                  <a:srgbClr val="3A6EA5"/>
+                </a:solidFill>
+                <a:latin typeface="Patrick Hand"/>
+              </a:rPr>
+              <a:t>Initial in top 10</a:t>
+            </a:r>
+            <a:r>
+              <a:rPr sz="1900" b="0">
+                <a:solidFill>
+                  <a:srgbClr val="2B2D42"/>
+                </a:solidFill>
+                <a:latin typeface="Patrick Hand"/>
+              </a:rPr>
+              <a:t>: no help</a:t>
+            </a:r>
+          </a:p>
+        </p:txBody>
+      </p:sp>
+    </p:spTree>
+  </p:cSld>
+  <p:clrMapOvr>
+    <a:masterClrMapping/>
+  </p:clrMapOvr>
+</p:sld>
+</file>
+
+<file path=ppt/slides/slide19.xml><?xml version="1.0" encoding="utf-8"?>
+<p:sld xmlns:a="http://schemas.openxmlformats.org/drawingml/2006/main" xmlns:p="http://schemas.openxmlformats.org/presentationml/2006/main" xmlns:r="http://schemas.openxmlformats.org/officeDocument/2006/relationships">
+  <p:cSld>
+    <p:spTree>
+      <p:nvGrpSpPr>
+        <p:cNvPr id="1" name=""/>
+        <p:cNvGrpSpPr/>
+        <p:nvPr/>
+      </p:nvGrpSpPr>
+      <p:grpSpPr/>
+      <p:pic>
+        <p:nvPicPr>
+          <p:cNvPr id="2" name="Picture 1" descr="paper.png"/>
+          <p:cNvPicPr>
+            <a:picLocks noChangeAspect="1"/>
+          </p:cNvPicPr>
+          <p:nvPr/>
+        </p:nvPicPr>
+        <p:blipFill>
+          <a:blip r:embed="rId2"/>
+          <a:stretch>
+            <a:fillRect/>
+          </a:stretch>
+        </p:blipFill>
+        <p:spPr>
+          <a:xfrm>
+            <a:off x="0" y="0"/>
+            <a:ext cx="12191695" cy="6858000"/>
+          </a:xfrm>
+          <a:prstGeom prst="rect">
+            <a:avLst/>
+          </a:prstGeom>
+        </p:spPr>
+      </p:pic>
+      <p:sp>
+        <p:nvSpPr>
+          <p:cNvPr id="3" name="TextBox 2"/>
+          <p:cNvSpPr txBox="1"/>
+          <p:nvPr/>
+        </p:nvSpPr>
+        <p:spPr>
+          <a:xfrm>
+            <a:off x="685800" y="274320"/>
+            <a:ext cx="10881360" cy="822960"/>
+          </a:xfrm>
+          <a:prstGeom prst="rect">
+            <a:avLst/>
+          </a:prstGeom>
+          <a:noFill/>
+        </p:spPr>
+        <p:txBody>
+          <a:bodyPr wrap="square" lIns="0" rIns="0" tIns="0" bIns="0" anchor="t">
+            <a:spAutoFit/>
+          </a:bodyPr>
+          <a:lstStyle/>
+          <a:p>
+            <a:pPr algn="l">
+              <a:spcAft>
+                <a:spcPts val="800"/>
+              </a:spcAft>
+            </a:pPr>
+            <a:r>
+              <a:rPr sz="4600" b="1">
+                <a:solidFill>
+                  <a:srgbClr val="2B2D42"/>
+                </a:solidFill>
+                <a:latin typeface="Caveat"/>
+              </a:rPr>
+              <a:t>Where the signal sits, and a dose-response</a:t>
+            </a:r>
+          </a:p>
+        </p:txBody>
+      </p:sp>
+      <p:sp>
+        <p:nvSpPr>
+          <p:cNvPr id="4" name="TextBox 3"/>
+          <p:cNvSpPr txBox="1"/>
+          <p:nvPr/>
+        </p:nvSpPr>
+        <p:spPr>
+          <a:xfrm>
+            <a:off x="713232" y="987552"/>
+            <a:ext cx="10881360" cy="411480"/>
+          </a:xfrm>
+          <a:prstGeom prst="rect">
+            <a:avLst/>
+          </a:prstGeom>
+          <a:noFill/>
+        </p:spPr>
+        <p:txBody>
+          <a:bodyPr wrap="square" lIns="0" rIns="0" tIns="0" bIns="0" anchor="t">
+            <a:spAutoFit/>
+          </a:bodyPr>
+          <a:lstStyle/>
+          <a:p>
+            <a:pPr algn="l">
+              <a:spcAft>
+                <a:spcPts val="800"/>
+              </a:spcAft>
+            </a:pPr>
+            <a:r>
+              <a:rPr sz="1900" b="0">
+                <a:solidFill>
+                  <a:srgbClr val="6E7080"/>
+                </a:solidFill>
+                <a:latin typeface="Patrick Hand"/>
+              </a:rPr>
+              <a:t>model output</a:t>
+            </a:r>
+          </a:p>
+        </p:txBody>
+      </p:sp>
+      <p:pic>
+        <p:nvPicPr>
+          <p:cNvPr id="5" name="Picture 4" descr="c9_roles.png"/>
+          <p:cNvPicPr>
+            <a:picLocks noChangeAspect="1"/>
+          </p:cNvPicPr>
+          <p:nvPr/>
+        </p:nvPicPr>
+        <p:blipFill>
+          <a:blip r:embed="rId4"/>
+          <a:stretch>
+            <a:fillRect/>
+          </a:stretch>
+        </p:blipFill>
+        <p:spPr>
+          <a:xfrm>
+            <a:off x="365760" y="1463040"/>
+            <a:ext cx="6675120" cy="3973285"/>
+          </a:xfrm>
+          <a:prstGeom prst="rect">
+            <a:avLst/>
+          </a:prstGeom>
+        </p:spPr>
+      </p:pic>
+      <p:pic>
+        <p:nvPicPr>
+          <p:cNvPr id="6" name="Picture 5" descr="c10_graded.png"/>
+          <p:cNvPicPr>
+            <a:picLocks noChangeAspect="1"/>
+          </p:cNvPicPr>
+          <p:nvPr/>
+        </p:nvPicPr>
+        <p:blipFill>
+          <a:blip r:embed="rId5"/>
+          <a:stretch>
+            <a:fillRect/>
+          </a:stretch>
+        </p:blipFill>
+        <p:spPr>
+          <a:xfrm>
+            <a:off x="7223760" y="1737360"/>
+            <a:ext cx="4572000" cy="3282553"/>
+          </a:xfrm>
+          <a:prstGeom prst="rect">
+            <a:avLst/>
+          </a:prstGeom>
+        </p:spPr>
+      </p:pic>
+      <p:sp>
+        <p:nvSpPr>
+          <p:cNvPr id="7" name="TextBox 6"/>
+          <p:cNvSpPr txBox="1"/>
+          <p:nvPr/>
+        </p:nvSpPr>
+        <p:spPr>
+          <a:xfrm>
+            <a:off x="713232" y="6355080"/>
+            <a:ext cx="10789920" cy="320040"/>
+          </a:xfrm>
+          <a:prstGeom prst="rect">
+            <a:avLst/>
+          </a:prstGeom>
+          <a:noFill/>
+        </p:spPr>
+        <p:txBody>
+          <a:bodyPr wrap="square" lIns="0" rIns="0" tIns="0" bIns="0" anchor="t">
+            <a:spAutoFit/>
+          </a:bodyPr>
+          <a:lstStyle/>
+          <a:p>
+            <a:pPr algn="l">
+              <a:spcAft>
+                <a:spcPts val="800"/>
+              </a:spcAft>
+            </a:pPr>
+            <a:r>
+              <a:rPr sz="1400" b="0">
+                <a:solidFill>
+                  <a:srgbClr val="6E7080"/>
+                </a:solidFill>
+                <a:latin typeface="Patrick Hand"/>
+              </a:rPr>
+              <a:t>Right: R0/R1 papers, centred within citation bin; Spearman rho = 0.27, p &lt; 0.001.</a:t>
             </a:r>
           </a:p>
         </p:txBody>
@@ -7508,6 +8253,846 @@
                 <a:latin typeface="Patrick Hand"/>
               </a:rPr>
               <a:t>So: at which layer does target pull ahead of control?</a:t>
+            </a:r>
+          </a:p>
+        </p:txBody>
+      </p:sp>
+    </p:spTree>
+  </p:cSld>
+  <p:clrMapOvr>
+    <a:masterClrMapping/>
+  </p:clrMapOvr>
+</p:sld>
+</file>
+
+<file path=ppt/slides/slide20.xml><?xml version="1.0" encoding="utf-8"?>
+<p:sld xmlns:a="http://schemas.openxmlformats.org/drawingml/2006/main" xmlns:p="http://schemas.openxmlformats.org/presentationml/2006/main" xmlns:r="http://schemas.openxmlformats.org/officeDocument/2006/relationships">
+  <p:cSld>
+    <p:spTree>
+      <p:nvGrpSpPr>
+        <p:cNvPr id="1" name=""/>
+        <p:cNvGrpSpPr/>
+        <p:nvPr/>
+      </p:nvGrpSpPr>
+      <p:grpSpPr/>
+      <p:pic>
+        <p:nvPicPr>
+          <p:cNvPr id="2" name="Picture 1" descr="paper.png"/>
+          <p:cNvPicPr>
+            <a:picLocks noChangeAspect="1"/>
+          </p:cNvPicPr>
+          <p:nvPr/>
+        </p:nvPicPr>
+        <p:blipFill>
+          <a:blip r:embed="rId2"/>
+          <a:stretch>
+            <a:fillRect/>
+          </a:stretch>
+        </p:blipFill>
+        <p:spPr>
+          <a:xfrm>
+            <a:off x="0" y="0"/>
+            <a:ext cx="12191695" cy="6858000"/>
+          </a:xfrm>
+          <a:prstGeom prst="rect">
+            <a:avLst/>
+          </a:prstGeom>
+        </p:spPr>
+      </p:pic>
+      <p:sp>
+        <p:nvSpPr>
+          <p:cNvPr id="3" name="TextBox 2"/>
+          <p:cNvSpPr txBox="1"/>
+          <p:nvPr/>
+        </p:nvSpPr>
+        <p:spPr>
+          <a:xfrm>
+            <a:off x="685800" y="274320"/>
+            <a:ext cx="10881360" cy="822960"/>
+          </a:xfrm>
+          <a:prstGeom prst="rect">
+            <a:avLst/>
+          </a:prstGeom>
+          <a:noFill/>
+        </p:spPr>
+        <p:txBody>
+          <a:bodyPr wrap="square" lIns="0" rIns="0" tIns="0" bIns="0" anchor="t">
+            <a:spAutoFit/>
+          </a:bodyPr>
+          <a:lstStyle/>
+          <a:p>
+            <a:pPr algn="l">
+              <a:spcAft>
+                <a:spcPts val="800"/>
+              </a:spcAft>
+            </a:pPr>
+            <a:r>
+              <a:rPr sz="4600" b="1">
+                <a:solidFill>
+                  <a:srgbClr val="2B2D42"/>
+                </a:solidFill>
+                <a:latin typeface="Caveat"/>
+              </a:rPr>
+              <a:t>What we learned</a:t>
+            </a:r>
+          </a:p>
+        </p:txBody>
+      </p:sp>
+      <p:sp>
+        <p:nvSpPr>
+          <p:cNvPr id="4" name="TextBox 3"/>
+          <p:cNvSpPr txBox="1"/>
+          <p:nvPr/>
+        </p:nvSpPr>
+        <p:spPr>
+          <a:xfrm>
+            <a:off x="822960" y="1325880"/>
+            <a:ext cx="2834640" cy="777240"/>
+          </a:xfrm>
+          <a:prstGeom prst="rect">
+            <a:avLst/>
+          </a:prstGeom>
+          <a:noFill/>
+        </p:spPr>
+        <p:txBody>
+          <a:bodyPr wrap="square" lIns="0" rIns="0" tIns="0" bIns="0" anchor="t">
+            <a:spAutoFit/>
+          </a:bodyPr>
+          <a:lstStyle/>
+          <a:p>
+            <a:pPr algn="l">
+              <a:spcAft>
+                <a:spcPts val="800"/>
+              </a:spcAft>
+            </a:pPr>
+            <a:r>
+              <a:rPr sz="2800" b="1">
+                <a:solidFill>
+                  <a:srgbClr val="E07A2F"/>
+                </a:solidFill>
+                <a:latin typeface="Caveat"/>
+              </a:rPr>
+              <a:t>Late</a:t>
+            </a:r>
+          </a:p>
+        </p:txBody>
+      </p:sp>
+      <p:sp>
+        <p:nvSpPr>
+          <p:cNvPr id="5" name="TextBox 4"/>
+          <p:cNvSpPr txBox="1"/>
+          <p:nvPr/>
+        </p:nvSpPr>
+        <p:spPr>
+          <a:xfrm>
+            <a:off x="3657600" y="1417320"/>
+            <a:ext cx="7863840" cy="777240"/>
+          </a:xfrm>
+          <a:prstGeom prst="rect">
+            <a:avLst/>
+          </a:prstGeom>
+          <a:noFill/>
+        </p:spPr>
+        <p:txBody>
+          <a:bodyPr wrap="square" lIns="0" rIns="0" tIns="0" bIns="0" anchor="t">
+            <a:spAutoFit/>
+          </a:bodyPr>
+          <a:lstStyle/>
+          <a:p>
+            <a:pPr algn="l">
+              <a:spcAft>
+                <a:spcPts val="800"/>
+              </a:spcAft>
+            </a:pPr>
+            <a:r>
+              <a:rPr sz="2000" b="0">
+                <a:solidFill>
+                  <a:srgbClr val="2B2D42"/>
+                </a:solidFill>
+                <a:latin typeface="Patrick Hand"/>
+              </a:rPr>
+              <a:t>Paper-specific author knowledge builds up from about L50, fastest over L57-L61, peaking at L61-L62.</a:t>
+            </a:r>
+          </a:p>
+        </p:txBody>
+      </p:sp>
+      <p:sp>
+        <p:nvSpPr>
+          <p:cNvPr id="6" name="TextBox 5"/>
+          <p:cNvSpPr txBox="1"/>
+          <p:nvPr/>
+        </p:nvSpPr>
+        <p:spPr>
+          <a:xfrm>
+            <a:off x="822960" y="2167128"/>
+            <a:ext cx="2834640" cy="777240"/>
+          </a:xfrm>
+          <a:prstGeom prst="rect">
+            <a:avLst/>
+          </a:prstGeom>
+          <a:noFill/>
+        </p:spPr>
+        <p:txBody>
+          <a:bodyPr wrap="square" lIns="0" rIns="0" tIns="0" bIns="0" anchor="t">
+            <a:spAutoFit/>
+          </a:bodyPr>
+          <a:lstStyle/>
+          <a:p>
+            <a:pPr algn="l">
+              <a:spcAft>
+                <a:spcPts val="800"/>
+              </a:spcAft>
+            </a:pPr>
+            <a:r>
+              <a:rPr sz="2800" b="1">
+                <a:solidFill>
+                  <a:srgbClr val="3C8D5A"/>
+                </a:solidFill>
+                <a:latin typeface="Caveat"/>
+              </a:rPr>
+              <a:t>Read early</a:t>
+            </a:r>
+          </a:p>
+        </p:txBody>
+      </p:sp>
+      <p:sp>
+        <p:nvSpPr>
+          <p:cNvPr id="7" name="TextBox 6"/>
+          <p:cNvSpPr txBox="1"/>
+          <p:nvPr/>
+        </p:nvSpPr>
+        <p:spPr>
+          <a:xfrm>
+            <a:off x="3657600" y="2258568"/>
+            <a:ext cx="7863840" cy="777240"/>
+          </a:xfrm>
+          <a:prstGeom prst="rect">
+            <a:avLst/>
+          </a:prstGeom>
+          <a:noFill/>
+        </p:spPr>
+        <p:txBody>
+          <a:bodyPr wrap="square" lIns="0" rIns="0" tIns="0" bIns="0" anchor="t">
+            <a:spAutoFit/>
+          </a:bodyPr>
+          <a:lstStyle/>
+          <a:p>
+            <a:pPr algn="l">
+              <a:spcAft>
+                <a:spcPts val="800"/>
+              </a:spcAft>
+            </a:pPr>
+            <a:r>
+              <a:rPr sz="2000" b="0">
+                <a:solidFill>
+                  <a:srgbClr val="2B2D42"/>
+                </a:solidFill>
+                <a:latin typeface="Patrick Hand"/>
+              </a:rPr>
+              <a:t>Causally, the title is read in L24-L50 and moved into the tokens after it; after L52 it is no longer needed.</a:t>
+            </a:r>
+          </a:p>
+        </p:txBody>
+      </p:sp>
+      <p:sp>
+        <p:nvSpPr>
+          <p:cNvPr id="8" name="TextBox 7"/>
+          <p:cNvSpPr txBox="1"/>
+          <p:nvPr/>
+        </p:nvSpPr>
+        <p:spPr>
+          <a:xfrm>
+            <a:off x="822960" y="3008376"/>
+            <a:ext cx="2834640" cy="777240"/>
+          </a:xfrm>
+          <a:prstGeom prst="rect">
+            <a:avLst/>
+          </a:prstGeom>
+          <a:noFill/>
+        </p:spPr>
+        <p:txBody>
+          <a:bodyPr wrap="square" lIns="0" rIns="0" tIns="0" bIns="0" anchor="t">
+            <a:spAutoFit/>
+          </a:bodyPr>
+          <a:lstStyle/>
+          <a:p>
+            <a:pPr algn="l">
+              <a:spcAft>
+                <a:spcPts val="800"/>
+              </a:spcAft>
+            </a:pPr>
+            <a:r>
+              <a:rPr sz="2800" b="1">
+                <a:solidFill>
+                  <a:srgbClr val="3A6EA5"/>
+                </a:solidFill>
+                <a:latin typeface="Caveat"/>
+              </a:rPr>
+              <a:t>No head start</a:t>
+            </a:r>
+          </a:p>
+        </p:txBody>
+      </p:sp>
+      <p:sp>
+        <p:nvSpPr>
+          <p:cNvPr id="9" name="TextBox 8"/>
+          <p:cNvSpPr txBox="1"/>
+          <p:nvPr/>
+        </p:nvSpPr>
+        <p:spPr>
+          <a:xfrm>
+            <a:off x="3657600" y="3099816"/>
+            <a:ext cx="7863840" cy="777240"/>
+          </a:xfrm>
+          <a:prstGeom prst="rect">
+            <a:avLst/>
+          </a:prstGeom>
+          <a:noFill/>
+        </p:spPr>
+        <p:txBody>
+          <a:bodyPr wrap="square" lIns="0" rIns="0" tIns="0" bIns="0" anchor="t">
+            <a:spAutoFit/>
+          </a:bodyPr>
+          <a:lstStyle/>
+          <a:p>
+            <a:pPr algn="l">
+              <a:spcAft>
+                <a:spcPts val="800"/>
+              </a:spcAft>
+            </a:pPr>
+            <a:r>
+              <a:rPr sz="2000" b="0">
+                <a:solidFill>
+                  <a:srgbClr val="2B2D42"/>
+                </a:solidFill>
+                <a:latin typeface="Patrick Hand"/>
+              </a:rPr>
+              <a:t>Target papers are not ahead of control in middle layers; the +0.21 gap is at the end.</a:t>
+            </a:r>
+          </a:p>
+        </p:txBody>
+      </p:sp>
+      <p:sp>
+        <p:nvSpPr>
+          <p:cNvPr id="10" name="TextBox 9"/>
+          <p:cNvSpPr txBox="1"/>
+          <p:nvPr/>
+        </p:nvSpPr>
+        <p:spPr>
+          <a:xfrm>
+            <a:off x="822960" y="3849624"/>
+            <a:ext cx="2834640" cy="777240"/>
+          </a:xfrm>
+          <a:prstGeom prst="rect">
+            <a:avLst/>
+          </a:prstGeom>
+          <a:noFill/>
+        </p:spPr>
+        <p:txBody>
+          <a:bodyPr wrap="square" lIns="0" rIns="0" tIns="0" bIns="0" anchor="t">
+            <a:spAutoFit/>
+          </a:bodyPr>
+          <a:lstStyle/>
+          <a:p>
+            <a:pPr algn="l">
+              <a:spcAft>
+                <a:spcPts val="800"/>
+              </a:spcAft>
+            </a:pPr>
+            <a:r>
+              <a:rPr sz="2800" b="1">
+                <a:solidFill>
+                  <a:srgbClr val="3C8D5A"/>
+                </a:solidFill>
+                <a:latin typeface="Caveat"/>
+              </a:rPr>
+              <a:t>Real knowledge</a:t>
+            </a:r>
+          </a:p>
+        </p:txBody>
+      </p:sp>
+      <p:sp>
+        <p:nvSpPr>
+          <p:cNvPr id="11" name="TextBox 10"/>
+          <p:cNvSpPr txBox="1"/>
+          <p:nvPr/>
+        </p:nvSpPr>
+        <p:spPr>
+          <a:xfrm>
+            <a:off x="3657600" y="3941063"/>
+            <a:ext cx="7863840" cy="777240"/>
+          </a:xfrm>
+          <a:prstGeom prst="rect">
+            <a:avLst/>
+          </a:prstGeom>
+          <a:noFill/>
+        </p:spPr>
+        <p:txBody>
+          <a:bodyPr wrap="square" lIns="0" rIns="0" tIns="0" bIns="0" anchor="t">
+            <a:spAutoFit/>
+          </a:bodyPr>
+          <a:lstStyle/>
+          <a:p>
+            <a:pPr algn="l">
+              <a:spcAft>
+                <a:spcPts val="800"/>
+              </a:spcAft>
+            </a:pPr>
+            <a:r>
+              <a:rPr sz="2000" b="0">
+                <a:solidFill>
+                  <a:srgbClr val="2B2D42"/>
+                </a:solidFill>
+                <a:latin typeface="Patrick Hand"/>
+              </a:rPr>
+              <a:t>The gap is title-specific and grows with citations, so it is not name guessing.</a:t>
+            </a:r>
+          </a:p>
+        </p:txBody>
+      </p:sp>
+      <p:sp>
+        <p:nvSpPr>
+          <p:cNvPr id="12" name="TextBox 11"/>
+          <p:cNvSpPr txBox="1"/>
+          <p:nvPr/>
+        </p:nvSpPr>
+        <p:spPr>
+          <a:xfrm>
+            <a:off x="822960" y="4690872"/>
+            <a:ext cx="2834640" cy="777240"/>
+          </a:xfrm>
+          <a:prstGeom prst="rect">
+            <a:avLst/>
+          </a:prstGeom>
+          <a:noFill/>
+        </p:spPr>
+        <p:txBody>
+          <a:bodyPr wrap="square" lIns="0" rIns="0" tIns="0" bIns="0" anchor="t">
+            <a:spAutoFit/>
+          </a:bodyPr>
+          <a:lstStyle/>
+          <a:p>
+            <a:pPr algn="l">
+              <a:spcAft>
+                <a:spcPts val="800"/>
+              </a:spcAft>
+            </a:pPr>
+            <a:r>
+              <a:rPr sz="2800" b="1">
+                <a:solidFill>
+                  <a:srgbClr val="2B2D42"/>
+                </a:solidFill>
+                <a:latin typeface="Caveat"/>
+              </a:rPr>
+              <a:t>Lenses agree</a:t>
+            </a:r>
+          </a:p>
+        </p:txBody>
+      </p:sp>
+      <p:sp>
+        <p:nvSpPr>
+          <p:cNvPr id="13" name="TextBox 12"/>
+          <p:cNvSpPr txBox="1"/>
+          <p:nvPr/>
+        </p:nvSpPr>
+        <p:spPr>
+          <a:xfrm>
+            <a:off x="3657600" y="4782312"/>
+            <a:ext cx="7863840" cy="777240"/>
+          </a:xfrm>
+          <a:prstGeom prst="rect">
+            <a:avLst/>
+          </a:prstGeom>
+          <a:noFill/>
+        </p:spPr>
+        <p:txBody>
+          <a:bodyPr wrap="square" lIns="0" rIns="0" tIns="0" bIns="0" anchor="t">
+            <a:spAutoFit/>
+          </a:bodyPr>
+          <a:lstStyle/>
+          <a:p>
+            <a:pPr algn="l">
+              <a:spcAft>
+                <a:spcPts val="800"/>
+              </a:spcAft>
+            </a:pPr>
+            <a:r>
+              <a:rPr sz="2000" b="0">
+                <a:solidFill>
+                  <a:srgbClr val="2B2D42"/>
+                </a:solidFill>
+                <a:latin typeface="Patrick Hand"/>
+              </a:rPr>
+              <a:t>Jacobian lenses read more in middle layers, but nothing target-specific.</a:t>
+            </a:r>
+          </a:p>
+        </p:txBody>
+      </p:sp>
+      <p:sp>
+        <p:nvSpPr>
+          <p:cNvPr id="14" name="TextBox 13"/>
+          <p:cNvSpPr txBox="1"/>
+          <p:nvPr/>
+        </p:nvSpPr>
+        <p:spPr>
+          <a:xfrm>
+            <a:off x="822960" y="5532120"/>
+            <a:ext cx="2834640" cy="777240"/>
+          </a:xfrm>
+          <a:prstGeom prst="rect">
+            <a:avLst/>
+          </a:prstGeom>
+          <a:noFill/>
+        </p:spPr>
+        <p:txBody>
+          <a:bodyPr wrap="square" lIns="0" rIns="0" tIns="0" bIns="0" anchor="t">
+            <a:spAutoFit/>
+          </a:bodyPr>
+          <a:lstStyle/>
+          <a:p>
+            <a:pPr algn="l">
+              <a:spcAft>
+                <a:spcPts val="800"/>
+              </a:spcAft>
+            </a:pPr>
+            <a:r>
+              <a:rPr sz="2800" b="1">
+                <a:solidFill>
+                  <a:srgbClr val="E07A2F"/>
+                </a:solidFill>
+                <a:latin typeface="Caveat"/>
+              </a:rPr>
+              <a:t>Name format</a:t>
+            </a:r>
+          </a:p>
+        </p:txBody>
+      </p:sp>
+      <p:sp>
+        <p:nvSpPr>
+          <p:cNvPr id="15" name="TextBox 14"/>
+          <p:cNvSpPr txBox="1"/>
+          <p:nvPr/>
+        </p:nvSpPr>
+        <p:spPr>
+          <a:xfrm>
+            <a:off x="3657600" y="5623560"/>
+            <a:ext cx="7863840" cy="777240"/>
+          </a:xfrm>
+          <a:prstGeom prst="rect">
+            <a:avLst/>
+          </a:prstGeom>
+          <a:noFill/>
+        </p:spPr>
+        <p:txBody>
+          <a:bodyPr wrap="square" lIns="0" rIns="0" tIns="0" bIns="0" anchor="t">
+            <a:spAutoFit/>
+          </a:bodyPr>
+          <a:lstStyle/>
+          <a:p>
+            <a:pPr algn="l">
+              <a:spcAft>
+                <a:spcPts val="800"/>
+              </a:spcAft>
+            </a:pPr>
+            <a:r>
+              <a:rPr sz="2000" b="0">
+                <a:solidFill>
+                  <a:srgbClr val="2B2D42"/>
+                </a:solidFill>
+                <a:latin typeface="Patrick Hand"/>
+              </a:rPr>
+              <a:t>Initials carry little; full given names carry as much as surnames and help predict them.</a:t>
+            </a:r>
+          </a:p>
+        </p:txBody>
+      </p:sp>
+    </p:spTree>
+  </p:cSld>
+  <p:clrMapOvr>
+    <a:masterClrMapping/>
+  </p:clrMapOvr>
+</p:sld>
+</file>
+
+<file path=ppt/slides/slide21.xml><?xml version="1.0" encoding="utf-8"?>
+<p:sld xmlns:a="http://schemas.openxmlformats.org/drawingml/2006/main" xmlns:p="http://schemas.openxmlformats.org/presentationml/2006/main" xmlns:r="http://schemas.openxmlformats.org/officeDocument/2006/relationships">
+  <p:cSld>
+    <p:spTree>
+      <p:nvGrpSpPr>
+        <p:cNvPr id="1" name=""/>
+        <p:cNvGrpSpPr/>
+        <p:nvPr/>
+      </p:nvGrpSpPr>
+      <p:grpSpPr/>
+      <p:pic>
+        <p:nvPicPr>
+          <p:cNvPr id="2" name="Picture 1" descr="paper.png"/>
+          <p:cNvPicPr>
+            <a:picLocks noChangeAspect="1"/>
+          </p:cNvPicPr>
+          <p:nvPr/>
+        </p:nvPicPr>
+        <p:blipFill>
+          <a:blip r:embed="rId2"/>
+          <a:stretch>
+            <a:fillRect/>
+          </a:stretch>
+        </p:blipFill>
+        <p:spPr>
+          <a:xfrm>
+            <a:off x="0" y="0"/>
+            <a:ext cx="12191695" cy="6858000"/>
+          </a:xfrm>
+          <a:prstGeom prst="rect">
+            <a:avLst/>
+          </a:prstGeom>
+        </p:spPr>
+      </p:pic>
+      <p:sp>
+        <p:nvSpPr>
+          <p:cNvPr id="3" name="TextBox 2"/>
+          <p:cNvSpPr txBox="1"/>
+          <p:nvPr/>
+        </p:nvSpPr>
+        <p:spPr>
+          <a:xfrm>
+            <a:off x="685800" y="274320"/>
+            <a:ext cx="10881360" cy="822960"/>
+          </a:xfrm>
+          <a:prstGeom prst="rect">
+            <a:avLst/>
+          </a:prstGeom>
+          <a:noFill/>
+        </p:spPr>
+        <p:txBody>
+          <a:bodyPr wrap="square" lIns="0" rIns="0" tIns="0" bIns="0" anchor="t">
+            <a:spAutoFit/>
+          </a:bodyPr>
+          <a:lstStyle/>
+          <a:p>
+            <a:pPr algn="l">
+              <a:spcAft>
+                <a:spcPts val="800"/>
+              </a:spcAft>
+            </a:pPr>
+            <a:r>
+              <a:rPr sz="4600" b="1">
+                <a:solidFill>
+                  <a:srgbClr val="2B2D42"/>
+                </a:solidFill>
+                <a:latin typeface="Caveat"/>
+              </a:rPr>
+              <a:t>Caveats and next steps</a:t>
+            </a:r>
+          </a:p>
+        </p:txBody>
+      </p:sp>
+      <p:sp>
+        <p:nvSpPr>
+          <p:cNvPr id="4" name="TextBox 3"/>
+          <p:cNvSpPr txBox="1"/>
+          <p:nvPr/>
+        </p:nvSpPr>
+        <p:spPr>
+          <a:xfrm>
+            <a:off x="822960" y="1463040"/>
+            <a:ext cx="5486400" cy="4389120"/>
+          </a:xfrm>
+          <a:prstGeom prst="rect">
+            <a:avLst/>
+          </a:prstGeom>
+          <a:noFill/>
+        </p:spPr>
+        <p:txBody>
+          <a:bodyPr wrap="square" lIns="0" rIns="0" tIns="0" bIns="0" anchor="t">
+            <a:spAutoFit/>
+          </a:bodyPr>
+          <a:lstStyle/>
+          <a:p>
+            <a:pPr algn="l">
+              <a:spcAft>
+                <a:spcPts val="1000"/>
+              </a:spcAft>
+            </a:pPr>
+            <a:r>
+              <a:rPr sz="2100" b="1">
+                <a:solidFill>
+                  <a:srgbClr val="2B2D42"/>
+                </a:solidFill>
+                <a:latin typeface="Patrick Hand"/>
+              </a:rPr>
+              <a:t>Caveats</a:t>
+            </a:r>
+          </a:p>
+          <a:p>
+            <a:pPr algn="l">
+              <a:spcAft>
+                <a:spcPts val="1000"/>
+              </a:spcAft>
+            </a:pPr>
+            <a:r>
+              <a:rPr sz="2100" b="0">
+                <a:solidFill>
+                  <a:srgbClr val="2B2D42"/>
+                </a:solidFill>
+                <a:latin typeface="Patrick Hand"/>
+              </a:rPr>
+              <a:t>- Readout is correlational; patching/knockout fix the timing, not the mechanism inside L24-L50</a:t>
+            </a:r>
+          </a:p>
+          <a:p>
+            <a:pPr algn="l">
+              <a:spcAft>
+                <a:spcPts val="1000"/>
+              </a:spcAft>
+            </a:pPr>
+            <a:r>
+              <a:rPr sz="2100" b="0">
+                <a:solidFill>
+                  <a:srgbClr val="2B2D42"/>
+                </a:solidFill>
+                <a:latin typeface="Patrick Hand"/>
+              </a:rPr>
+              <a:t>- Parity tolerance raised 0.25 -&gt; 0.5 after the fact</a:t>
+            </a:r>
+          </a:p>
+          <a:p>
+            <a:pPr algn="l">
+              <a:spcAft>
+                <a:spcPts val="1000"/>
+              </a:spcAft>
+            </a:pPr>
+            <a:r>
+              <a:rPr sz="2100" b="0">
+                <a:solidFill>
+                  <a:srgbClr val="2B2D42"/>
+                </a:solidFill>
+                <a:latin typeface="Patrick Hand"/>
+              </a:rPr>
+              <a:t>- Groups are model-specific; low-citation "recognition" is near chance</a:t>
+            </a:r>
+          </a:p>
+          <a:p>
+            <a:pPr algn="l">
+              <a:spcAft>
+                <a:spcPts val="1000"/>
+              </a:spcAft>
+            </a:pPr>
+            <a:r>
+              <a:rPr sz="2100" b="0">
+                <a:solidFill>
+                  <a:srgbClr val="2B2D42"/>
+                </a:solidFill>
+                <a:latin typeface="Patrick Hand"/>
+              </a:rPr>
+              <a:t>- Few control papers above 1,000 citations</a:t>
+            </a:r>
+          </a:p>
+        </p:txBody>
+      </p:sp>
+      <p:sp>
+        <p:nvSpPr>
+          <p:cNvPr id="5" name="Rectangle 4"/>
+          <p:cNvSpPr/>
+          <p:nvPr/>
+        </p:nvSpPr>
+        <p:spPr>
+          <a:xfrm rot="90000">
+            <a:off x="6766560" y="1554480"/>
+            <a:ext cx="4663440" cy="3291840"/>
+          </a:xfrm>
+          <a:prstGeom prst="rect">
+            <a:avLst/>
+          </a:prstGeom>
+          <a:solidFill>
+            <a:srgbClr val="FFF1A8"/>
+          </a:solidFill>
+          <a:ln w="12700">
+            <a:solidFill>
+              <a:srgbClr val="E2D37A"/>
+            </a:solidFill>
+          </a:ln>
+          <a:effectLst/>
+        </p:spPr>
+        <p:style>
+          <a:lnRef idx="1">
+            <a:schemeClr val="accent1"/>
+          </a:lnRef>
+          <a:fillRef idx="3">
+            <a:schemeClr val="accent1"/>
+          </a:fillRef>
+          <a:effectRef idx="2">
+            <a:schemeClr val="accent1"/>
+          </a:effectRef>
+          <a:fontRef idx="minor">
+            <a:schemeClr val="lt1"/>
+          </a:fontRef>
+        </p:style>
+        <p:txBody>
+          <a:bodyPr rtlCol="0" anchor="t" wrap="square" lIns="201168" rIns="201168" tIns="164592" bIns="164592"/>
+          <a:lstStyle/>
+          <a:p>
+            <a:pPr algn="l">
+              <a:spcAft>
+                <a:spcPts val="900"/>
+              </a:spcAft>
+            </a:pPr>
+            <a:r>
+              <a:rPr sz="1900" b="1">
+                <a:solidFill>
+                  <a:srgbClr val="2B2D42"/>
+                </a:solidFill>
+                <a:latin typeface="Patrick Hand"/>
+              </a:rPr>
+              <a:t>Next</a:t>
+            </a:r>
+          </a:p>
+          <a:p>
+            <a:pPr algn="l">
+              <a:spcAft>
+                <a:spcPts val="900"/>
+              </a:spcAft>
+            </a:pPr>
+            <a:r>
+              <a:rPr sz="1900" b="0">
+                <a:solidFill>
+                  <a:srgbClr val="2B2D42"/>
+                </a:solidFill>
+                <a:latin typeface="Patrick Hand"/>
+              </a:rPr>
+              <a:t>1. Patch single positions (quote, year, "Authors:") to find which token carries the paper</a:t>
+            </a:r>
+          </a:p>
+          <a:p>
+            <a:pPr algn="l">
+              <a:spcAft>
+                <a:spcPts val="900"/>
+              </a:spcAft>
+            </a:pPr>
+            <a:r>
+              <a:rPr sz="1900" b="0">
+                <a:solidFill>
+                  <a:srgbClr val="2B2D42"/>
+                </a:solidFill>
+                <a:latin typeface="Patrick Hand"/>
+              </a:rPr>
+              <a:t>2. Patch / probe per layer inside L24-L50 to see when it is computed</a:t>
+            </a:r>
+          </a:p>
+          <a:p>
+            <a:pPr algn="l">
+              <a:spcAft>
+                <a:spcPts val="900"/>
+              </a:spcAft>
+            </a:pPr>
+            <a:r>
+              <a:rPr sz="1900" b="0">
+                <a:solidFill>
+                  <a:srgbClr val="2B2D42"/>
+                </a:solidFill>
+                <a:latin typeface="Patrick Hand"/>
+              </a:rPr>
+              <a:t>3. Repeat on a second model</a:t>
             </a:r>
           </a:p>
         </p:txBody>

</xml_diff>

<commit_message>
Stage 12 code; name-prior analysis and probe controls; report and talk updated
</commit_message>
<xml_diff>
--- a/experiment_files/351_stage10/reports/talk/Stage10_author_readout_talk.pptx
+++ b/experiment_files/351_stage10/reports/talk/Stage10_author_readout_talk.pptx
@@ -26,6 +26,8 @@
     <p:sldId id="274" r:id="rId26"/>
     <p:sldId id="275" r:id="rId27"/>
     <p:sldId id="276" r:id="rId28"/>
+    <p:sldId id="277" r:id="rId29"/>
+    <p:sldId id="278" r:id="rId30"/>
   </p:sldIdLst>
   <p:sldSz cx="12191695" cy="6858000" type="screen4x3"/>
   <p:notesSz cx="6858000" cy="9144000"/>
@@ -732,7 +734,7 @@
           <a:lstStyle/>
           <a:p>
             <a:r>
-              <a:t>Is the author readable at the title itself? With the lenses, barely: about 0.01 to 0.03 title-specific signal at the last title token. A linear probe trained across papers gets more, 0.04 at L16 rising to 0.08 at L56, and a little more for target papers. Caution: a probe trained across papers can also pick up topic-to-name associations, not only this paper.</a:t>
+              <a:t>Is the author readable at the title itself? With the lenses, barely: about 0.01 to 0.03 title-specific signal at the last title token. A linear probe trained across papers gets more, 0.04 at L16 rising to 0.08 at L56, and a little more for target papers. The controls on the next slide show this probe signal is specific to the paper, not a topic-to-name association.</a:t>
             </a:r>
           </a:p>
         </p:txBody>
@@ -872,7 +874,7 @@
           <a:lstStyle/>
           <a:p>
             <a:r>
-              <a:t>Comparing lenses. On readout quality fitA is best in most middle layers, self100 at L40; at L48 the Jacobian lenses put the right token in the top 10 for 15-18% of tokens versus 1% for the logit lens. At L62 the plain logit lens is best.</a:t>
+              <a:t>How much is just the name prior? We score the same names with no title at all. Without a title the correct name already sits around rank 12 on average: punctuation and the rest of a surname are easy once the prefix is given. The true title improves the surname first token the most: for target papers from about rank 146 to rank 24. Split the target minus control gap within citation bins: about 0.09 is already there without a title (target names are a bit easier to guess), false titles take back 0.05, and 0.21 is paper-specific. On the surname first token the prior part is about zero and 0.42 is paper-specific. The prior barely tracks multiple-choice recognition (Spearman 0.09 vs 0.33 for the paper-specific part).</a:t>
             </a:r>
           </a:p>
         </p:txBody>
@@ -942,7 +944,7 @@
           <a:lstStyle/>
           <a:p>
             <a:r>
-              <a:t>Do Jacobian lenses see paper-specific information the logit lens misses? A little: +0.01 to +0.03 more title-specific signal at L24-L48, CIs above zero, but tiny next to 0.44 at L62. And it is not bigger for target: target minus control of that extra is about zero, negative at L48 and L56.</a:t>
+              <a:t>Is the probe at the title token reading real paper knowledge, or just topic to name associations? If we score its output against the authors of another paper, or of another paper in the same field, the signal drops to zero. If we train it only on false-title pairs it gets even stronger. So the last title token carries linearly decodable, paper-specific author information already at L24, more for target papers, even though the lenses cannot read it.</a:t>
             </a:r>
           </a:p>
         </p:txBody>
@@ -1012,7 +1014,7 @@
           <a:lstStyle/>
           <a:p>
             <a:r>
-              <a:t>Citations. Within both groups the title-specific signal rises steadily with citation bin: target from +0.35 in bin 0-2 to +0.64 in 4097+. Spearman with log citations: 0.45 overall, 0.33 within target, 0.19 within control. The level itself changes much less - names are not easier to guess for famous papers, the model just knows famous papers better.</a:t>
+              <a:t>Comparing lenses. On readout quality fitA is best in most middle layers, self100 at L40; at L48 the Jacobian lenses put the right token in the top 10 for 15-18% of tokens versus 1% for the logit lens. At L62 the plain logit lens is best.</a:t>
             </a:r>
           </a:p>
         </p:txBody>
@@ -1082,7 +1084,7 @@
           <a:lstStyle/>
           <a:p>
             <a:r>
-              <a:t>Is the signal decided by the first token? It depends on the name format. Initial-first names: the initial carries little, the signal is on the later tokens that include the surname. Given-name-first names: the given name carries about as much as the rest. Note teacher forcing: later tokens already see the correct prefix in every condition, so their title-specific signal can only come from the title.</a:t>
+              <a:t>Do Jacobian lenses see paper-specific information the logit lens misses? A little: +0.01 to +0.03 more title-specific signal at L24-L48, CIs above zero, but tiny next to 0.44 at L62. And it is not bigger for target: target minus control of that extra is about zero, negative at L48 and L56.</a:t>
             </a:r>
           </a:p>
         </p:txBody>
@@ -1152,7 +1154,7 @@
           <a:lstStyle/>
           <a:p>
             <a:r>
-              <a:t>Does knowing the first word make the rest easier? For a full given name, yes: when it is in the top 10 the surname is +0.22 better at the output, +0.32 for the logit lens at L62. For an initial, no. Mixing both formats would even show a negative effect, because initials are easy and the surnames after them are hard.</a:t>
+              <a:t>Citations. Within both groups the title-specific signal rises steadily with citation bin: target from +0.35 in bin 0-2 to +0.64 in 4097+. Spearman with log citations: 0.45 overall, 0.33 within target, 0.19 within control. The level itself changes much less - names are not easier to guess for famous papers, the model just knows famous papers better.</a:t>
             </a:r>
           </a:p>
         </p:txBody>
@@ -1222,7 +1224,7 @@
           <a:lstStyle/>
           <a:p>
             <a:r>
-              <a:t>Left: title-specific signal by token role at the output - surname first token carries most, initials least, punctuation about zero (negative control). Right: across all unrecalled papers, the more multiple-choice orders right, the better the model output (Spearman 0.27).</a:t>
+              <a:t>Is the signal decided by the first token? It depends on the name format. Initial-first names: the initial carries little, the signal is on the later tokens that include the surname. Given-name-first names: the given name carries about as much as the rest. Note teacher forcing: later tokens already see the correct prefix in every condition, so their title-specific signal can only come from the title.</a:t>
             </a:r>
           </a:p>
         </p:txBody>
@@ -1362,7 +1364,7 @@
           <a:lstStyle/>
           <a:p>
             <a:r>
-              <a:t>Wrap up the five findings.</a:t>
+              <a:t>Does knowing the first word make the rest easier? For a full given name, yes: when it is in the top 10 the surname is +0.22 better at the output, +0.32 for the logit lens at L62. For an initial, no. Mixing both formats would even show a negative effect, because initials are easy and the surnames after them are hard.</a:t>
             </a:r>
           </a:p>
         </p:txBody>
@@ -1388,6 +1390,146 @@
 </file>
 
 <file path=ppt/notesSlides/notesSlide21.xml><?xml version="1.0" encoding="utf-8"?>
+<p:notes xmlns:a="http://schemas.openxmlformats.org/drawingml/2006/main" xmlns:p="http://schemas.openxmlformats.org/presentationml/2006/main" xmlns:r="http://schemas.openxmlformats.org/officeDocument/2006/relationships">
+  <p:cSld>
+    <p:spTree>
+      <p:nvGrpSpPr>
+        <p:cNvPr id="1" name=""/>
+        <p:cNvGrpSpPr/>
+        <p:nvPr/>
+      </p:nvGrpSpPr>
+      <p:grpSpPr>
+        <a:xfrm>
+          <a:off x="0" y="0"/>
+          <a:ext cx="0" cy="0"/>
+          <a:chOff x="0" y="0"/>
+          <a:chExt cx="0" cy="0"/>
+        </a:xfrm>
+      </p:grpSpPr>
+      <p:sp>
+        <p:nvSpPr>
+          <p:cNvPr id="2" name="Slide Image Placeholder 1"/>
+          <p:cNvSpPr>
+            <a:spLocks noGrp="1"/>
+          </p:cNvSpPr>
+          <p:nvPr>
+            <p:ph type="sldImg" idx="2"/>
+          </p:nvPr>
+        </p:nvSpPr>
+        <p:spPr/>
+      </p:sp>
+      <p:sp>
+        <p:nvSpPr>
+          <p:cNvPr id="3" name="Notes Placeholder 2"/>
+          <p:cNvSpPr>
+            <a:spLocks noGrp="1"/>
+          </p:cNvSpPr>
+          <p:nvPr>
+            <p:ph type="body" idx="3" sz="quarter"/>
+          </p:nvPr>
+        </p:nvSpPr>
+        <p:spPr/>
+        <p:txBody>
+          <a:bodyPr/>
+          <a:lstStyle/>
+          <a:p>
+            <a:r>
+              <a:t>Left: title-specific signal by token role at the output - surname first token carries most, initials least, punctuation about zero (negative control). Right: across all unrecalled papers, the more multiple-choice orders right, the better the model output (Spearman 0.27).</a:t>
+            </a:r>
+          </a:p>
+        </p:txBody>
+      </p:sp>
+      <p:sp>
+        <p:nvSpPr>
+          <p:cNvPr id="4" name="Slide Number Placeholder 3"/>
+          <p:cNvSpPr>
+            <a:spLocks noGrp="1"/>
+          </p:cNvSpPr>
+          <p:nvPr>
+            <p:ph type="sldNum" idx="5" sz="quarter"/>
+          </p:nvPr>
+        </p:nvSpPr>
+        <p:spPr/>
+      </p:sp>
+    </p:spTree>
+  </p:cSld>
+  <p:clrMapOvr>
+    <a:masterClrMapping/>
+  </p:clrMapOvr>
+</p:notes>
+</file>
+
+<file path=ppt/notesSlides/notesSlide22.xml><?xml version="1.0" encoding="utf-8"?>
+<p:notes xmlns:a="http://schemas.openxmlformats.org/drawingml/2006/main" xmlns:p="http://schemas.openxmlformats.org/presentationml/2006/main" xmlns:r="http://schemas.openxmlformats.org/officeDocument/2006/relationships">
+  <p:cSld>
+    <p:spTree>
+      <p:nvGrpSpPr>
+        <p:cNvPr id="1" name=""/>
+        <p:cNvGrpSpPr/>
+        <p:nvPr/>
+      </p:nvGrpSpPr>
+      <p:grpSpPr>
+        <a:xfrm>
+          <a:off x="0" y="0"/>
+          <a:ext cx="0" cy="0"/>
+          <a:chOff x="0" y="0"/>
+          <a:chExt cx="0" cy="0"/>
+        </a:xfrm>
+      </p:grpSpPr>
+      <p:sp>
+        <p:nvSpPr>
+          <p:cNvPr id="2" name="Slide Image Placeholder 1"/>
+          <p:cNvSpPr>
+            <a:spLocks noGrp="1"/>
+          </p:cNvSpPr>
+          <p:nvPr>
+            <p:ph type="sldImg" idx="2"/>
+          </p:nvPr>
+        </p:nvSpPr>
+        <p:spPr/>
+      </p:sp>
+      <p:sp>
+        <p:nvSpPr>
+          <p:cNvPr id="3" name="Notes Placeholder 2"/>
+          <p:cNvSpPr>
+            <a:spLocks noGrp="1"/>
+          </p:cNvSpPr>
+          <p:nvPr>
+            <p:ph type="body" idx="3" sz="quarter"/>
+          </p:nvPr>
+        </p:nvSpPr>
+        <p:spPr/>
+        <p:txBody>
+          <a:bodyPr/>
+          <a:lstStyle/>
+          <a:p>
+            <a:r>
+              <a:t>Wrap up the five findings.</a:t>
+            </a:r>
+          </a:p>
+        </p:txBody>
+      </p:sp>
+      <p:sp>
+        <p:nvSpPr>
+          <p:cNvPr id="4" name="Slide Number Placeholder 3"/>
+          <p:cNvSpPr>
+            <a:spLocks noGrp="1"/>
+          </p:cNvSpPr>
+          <p:nvPr>
+            <p:ph type="sldNum" idx="5" sz="quarter"/>
+          </p:nvPr>
+        </p:nvSpPr>
+        <p:spPr/>
+      </p:sp>
+    </p:spTree>
+  </p:cSld>
+  <p:clrMapOvr>
+    <a:masterClrMapping/>
+  </p:clrMapOvr>
+</p:notes>
+</file>
+
+<file path=ppt/notesSlides/notesSlide23.xml><?xml version="1.0" encoding="utf-8"?>
 <p:notes xmlns:a="http://schemas.openxmlformats.org/drawingml/2006/main" xmlns:p="http://schemas.openxmlformats.org/presentationml/2006/main" xmlns:r="http://schemas.openxmlformats.org/officeDocument/2006/relationships">
   <p:cSld>
     <p:spTree>
@@ -5946,7 +6088,7 @@
                 </a:solidFill>
                 <a:latin typeface="Caveat"/>
               </a:rPr>
-              <a:t>Not readable at the title token itself</a:t>
+              <a:t>Lenses cannot read it at the title token</a:t>
             </a:r>
           </a:p>
         </p:txBody>
@@ -6118,7 +6260,7 @@
                 </a:solidFill>
                 <a:latin typeface="Patrick Hand"/>
               </a:rPr>
-              <a:t>target a bit higher; may include topic -&gt; name associations</a:t>
+              <a:t>target higher; paper-specific (next slide)</a:t>
             </a:r>
           </a:p>
         </p:txBody>
@@ -6452,7 +6594,7 @@
                 </a:solidFill>
                 <a:latin typeface="Caveat"/>
               </a:rPr>
-              <a:t>Which lens reads best?</a:t>
+              <a:t>How much is just the name prior?</a:t>
             </a:r>
           </a:p>
         </p:txBody>
@@ -6491,14 +6633,14 @@
                 </a:solidFill>
                 <a:latin typeface="Patrick Hand"/>
               </a:rPr>
-              <a:t>all papers · true title</a:t>
+              <a:t>model output · no title vs false title vs true title · all 9,108 papers</a:t>
             </a:r>
           </a:p>
         </p:txBody>
       </p:sp>
       <p:pic>
         <p:nvPicPr>
-          <p:cNvPr id="5" name="Picture 4" descr="c4_lens_quality.png"/>
+          <p:cNvPr id="5" name="Picture 4" descr="c15_name_prior.png"/>
           <p:cNvPicPr>
             <a:picLocks noChangeAspect="1"/>
           </p:cNvPicPr>
@@ -6513,7 +6655,7 @@
         <p:spPr>
           <a:xfrm>
             <a:off x="457200" y="1463040"/>
-            <a:ext cx="8412480" cy="3963572"/>
+            <a:ext cx="8412480" cy="3968150"/>
           </a:xfrm>
           <a:prstGeom prst="rect">
             <a:avLst/>
@@ -6527,9 +6669,9 @@
           <p:nvPr/>
         </p:nvSpPr>
         <p:spPr>
-          <a:xfrm rot="21510000">
+          <a:xfrm rot="90000">
             <a:off x="9098280" y="1737360"/>
-            <a:ext cx="2651760" cy="3108960"/>
+            <a:ext cx="2651760" cy="3566160"/>
           </a:xfrm>
           <a:prstGeom prst="rect">
             <a:avLst/>
@@ -6568,13 +6710,22 @@
               </a:spcAft>
             </a:pPr>
             <a:r>
-              <a:rPr sz="1900" b="1">
-                <a:solidFill>
-                  <a:srgbClr val="3C8D5A"/>
-                </a:solidFill>
-                <a:latin typeface="Patrick Hand"/>
-              </a:rPr>
-              <a:t>Middle layers:</a:t>
+              <a:rPr sz="1700" b="0">
+                <a:solidFill>
+                  <a:srgbClr val="2B2D42"/>
+                </a:solidFill>
+                <a:latin typeface="Patrick Hand"/>
+              </a:rPr>
+              <a:t>no title: rank </a:t>
+            </a:r>
+            <a:r>
+              <a:rPr sz="1700" b="1">
+                <a:solidFill>
+                  <a:srgbClr val="2B2D42"/>
+                </a:solidFill>
+                <a:latin typeface="Patrick Hand"/>
+              </a:rPr>
+              <a:t>~12</a:t>
             </a:r>
           </a:p>
           <a:p>
@@ -6584,13 +6735,49 @@
               </a:spcAft>
             </a:pPr>
             <a:r>
-              <a:rPr sz="1900" b="0">
-                <a:solidFill>
-                  <a:srgbClr val="2B2D42"/>
-                </a:solidFill>
-                <a:latin typeface="Patrick Hand"/>
-              </a:rPr>
-              <a:t>fitA best; at L48 15-18% top-10 vs 1% for logit</a:t>
+              <a:rPr sz="1700" b="0">
+                <a:solidFill>
+                  <a:srgbClr val="2B2D42"/>
+                </a:solidFill>
+                <a:latin typeface="Patrick Hand"/>
+              </a:rPr>
+              <a:t>target - control: </a:t>
+            </a:r>
+            <a:r>
+              <a:rPr sz="1700" b="1">
+                <a:solidFill>
+                  <a:srgbClr val="6E7080"/>
+                </a:solidFill>
+                <a:latin typeface="Patrick Hand"/>
+              </a:rPr>
+              <a:t>+0.09</a:t>
+            </a:r>
+            <a:r>
+              <a:rPr sz="1700" b="0">
+                <a:solidFill>
+                  <a:srgbClr val="2B2D42"/>
+                </a:solidFill>
+                <a:latin typeface="Patrick Hand"/>
+              </a:rPr>
+              <a:t> prior, </a:t>
+            </a:r>
+            <a:r>
+              <a:rPr sz="1700" b="1">
+                <a:solidFill>
+                  <a:srgbClr val="E07A2F"/>
+                </a:solidFill>
+                <a:latin typeface="Patrick Hand"/>
+              </a:rPr>
+              <a:t>+0.21</a:t>
+            </a:r>
+            <a:r>
+              <a:rPr sz="1700" b="0">
+                <a:solidFill>
+                  <a:srgbClr val="2B2D42"/>
+                </a:solidFill>
+                <a:latin typeface="Patrick Hand"/>
+              </a:rPr>
+              <a:t> paper</a:t>
             </a:r>
           </a:p>
           <a:p>
@@ -6600,22 +6787,47 @@
               </a:spcAft>
             </a:pPr>
             <a:r>
-              <a:rPr sz="1900" b="1">
-                <a:solidFill>
-                  <a:srgbClr val="3A6EA5"/>
-                </a:solidFill>
-                <a:latin typeface="Patrick Hand"/>
-              </a:rPr>
-              <a:t>L62:</a:t>
-            </a:r>
-            <a:r>
-              <a:rPr sz="1900" b="0">
-                <a:solidFill>
-                  <a:srgbClr val="2B2D42"/>
-                </a:solidFill>
-                <a:latin typeface="Patrick Hand"/>
-              </a:rPr>
-              <a:t> logit lens best (59%)</a:t>
+              <a:rPr sz="1700" b="0">
+                <a:solidFill>
+                  <a:srgbClr val="2B2D42"/>
+                </a:solidFill>
+                <a:latin typeface="Patrick Hand"/>
+              </a:rPr>
+              <a:t>surname 1st: prior ~0, paper </a:t>
+            </a:r>
+            <a:r>
+              <a:rPr sz="1700" b="1">
+                <a:solidFill>
+                  <a:srgbClr val="E07A2F"/>
+                </a:solidFill>
+                <a:latin typeface="Patrick Hand"/>
+              </a:rPr>
+              <a:t>+0.42</a:t>
+            </a:r>
+          </a:p>
+          <a:p>
+            <a:pPr algn="l">
+              <a:spcAft>
+                <a:spcPts val="900"/>
+              </a:spcAft>
+            </a:pPr>
+            <a:r>
+              <a:rPr sz="1700" b="0">
+                <a:solidFill>
+                  <a:srgbClr val="2B2D42"/>
+                </a:solidFill>
+                <a:latin typeface="Patrick Hand"/>
+              </a:rPr>
+              <a:t>prior vs recognition rho </a:t>
+            </a:r>
+            <a:r>
+              <a:rPr sz="1700" b="1">
+                <a:solidFill>
+                  <a:srgbClr val="2B2D42"/>
+                </a:solidFill>
+                <a:latin typeface="Patrick Hand"/>
+              </a:rPr>
+              <a:t>0.09</a:t>
             </a:r>
           </a:p>
         </p:txBody>
@@ -6696,7 +6908,7 @@
                 </a:solidFill>
                 <a:latin typeface="Caveat"/>
               </a:rPr>
-              <a:t>Do lenses reveal hidden paper knowledge?</a:t>
+              <a:t>The probe signal is paper-specific</a:t>
             </a:r>
           </a:p>
         </p:txBody>
@@ -6735,14 +6947,14 @@
                 </a:solidFill>
                 <a:latin typeface="Patrick Hand"/>
               </a:rPr>
-              <a:t>paired differences, 95% CI</a:t>
+              <a:t>last title token · 5-fold ridge probe · controls · all 9,108 papers</a:t>
             </a:r>
           </a:p>
         </p:txBody>
       </p:sp>
       <p:pic>
         <p:nvPicPr>
-          <p:cNvPr id="5" name="Picture 4" descr="c5_lens_extra.png"/>
+          <p:cNvPr id="5" name="Picture 4" descr="c16_probe_controls.png"/>
           <p:cNvPicPr>
             <a:picLocks noChangeAspect="1"/>
           </p:cNvPicPr>
@@ -6756,8 +6968,8 @@
         </p:blipFill>
         <p:spPr>
           <a:xfrm>
-            <a:off x="457200" y="1463040"/>
-            <a:ext cx="8412480" cy="3963572"/>
+            <a:off x="548640" y="1463040"/>
+            <a:ext cx="7315200" cy="4167962"/>
           </a:xfrm>
           <a:prstGeom prst="rect">
             <a:avLst/>
@@ -6771,9 +6983,9 @@
           <p:nvPr/>
         </p:nvSpPr>
         <p:spPr>
-          <a:xfrm rot="90000">
-            <a:off x="9098280" y="1737360"/>
-            <a:ext cx="2651760" cy="3108960"/>
+          <a:xfrm rot="21510000">
+            <a:off x="8229600" y="1737360"/>
+            <a:ext cx="3383280" cy="3291840"/>
           </a:xfrm>
           <a:prstGeom prst="rect">
             <a:avLst/>
@@ -6812,22 +7024,22 @@
               </a:spcAft>
             </a:pPr>
             <a:r>
-              <a:rPr sz="1900" b="0">
-                <a:solidFill>
-                  <a:srgbClr val="2B2D42"/>
-                </a:solidFill>
-                <a:latin typeface="Patrick Hand"/>
-              </a:rPr>
-              <a:t>Extra signal: </a:t>
-            </a:r>
-            <a:r>
-              <a:rPr sz="1900" b="1">
-                <a:solidFill>
-                  <a:srgbClr val="2B2D42"/>
-                </a:solidFill>
-                <a:latin typeface="Patrick Hand"/>
-              </a:rPr>
-              <a:t>+0.01 to +0.03</a:t>
+              <a:rPr sz="1800" b="0">
+                <a:solidFill>
+                  <a:srgbClr val="2B2D42"/>
+                </a:solidFill>
+                <a:latin typeface="Patrick Hand"/>
+              </a:rPr>
+              <a:t>another paper's authors: </a:t>
+            </a:r>
+            <a:r>
+              <a:rPr sz="1800" b="1">
+                <a:solidFill>
+                  <a:srgbClr val="2B2D42"/>
+                </a:solidFill>
+                <a:latin typeface="Patrick Hand"/>
+              </a:rPr>
+              <a:t>0</a:t>
             </a:r>
           </a:p>
           <a:p>
@@ -6837,13 +7049,22 @@
               </a:spcAft>
             </a:pPr>
             <a:r>
-              <a:rPr sz="1900" b="0">
-                <a:solidFill>
-                  <a:srgbClr val="2B2D42"/>
-                </a:solidFill>
-                <a:latin typeface="Patrick Hand"/>
-              </a:rPr>
-              <a:t>vs ~0.44 at L62</a:t>
+              <a:rPr sz="1800" b="0">
+                <a:solidFill>
+                  <a:srgbClr val="2B2D42"/>
+                </a:solidFill>
+                <a:latin typeface="Patrick Hand"/>
+              </a:rPr>
+              <a:t>same-field paper: </a:t>
+            </a:r>
+            <a:r>
+              <a:rPr sz="1800" b="1">
+                <a:solidFill>
+                  <a:srgbClr val="2B2D42"/>
+                </a:solidFill>
+                <a:latin typeface="Patrick Hand"/>
+              </a:rPr>
+              <a:t>0</a:t>
             </a:r>
           </a:p>
           <a:p>
@@ -6853,22 +7074,47 @@
               </a:spcAft>
             </a:pPr>
             <a:r>
-              <a:rPr sz="1900" b="1">
+              <a:rPr sz="1800" b="0">
+                <a:solidFill>
+                  <a:srgbClr val="2B2D42"/>
+                </a:solidFill>
+                <a:latin typeface="Patrick Hand"/>
+              </a:rPr>
+              <a:t>so it is </a:t>
+            </a:r>
+            <a:r>
+              <a:rPr sz="1800" b="1">
                 <a:solidFill>
                   <a:srgbClr val="E07A2F"/>
                 </a:solidFill>
                 <a:latin typeface="Patrick Hand"/>
               </a:rPr>
-              <a:t>Not bigger for target</a:t>
-            </a:r>
-            <a:r>
-              <a:rPr sz="1900" b="0">
-                <a:solidFill>
-                  <a:srgbClr val="2B2D42"/>
-                </a:solidFill>
-                <a:latin typeface="Patrick Hand"/>
-              </a:rPr>
-              <a:t> (even negative at L48-56)</a:t>
+              <a:t>this paper</a:t>
+            </a:r>
+            <a:r>
+              <a:rPr sz="1800" b="0">
+                <a:solidFill>
+                  <a:srgbClr val="2B2D42"/>
+                </a:solidFill>
+                <a:latin typeface="Patrick Hand"/>
+              </a:rPr>
+              <a:t>, already at L24</a:t>
+            </a:r>
+          </a:p>
+          <a:p>
+            <a:pPr algn="l">
+              <a:spcAft>
+                <a:spcPts val="900"/>
+              </a:spcAft>
+            </a:pPr>
+            <a:r>
+              <a:rPr sz="1800" b="0">
+                <a:solidFill>
+                  <a:srgbClr val="2B2D42"/>
+                </a:solidFill>
+                <a:latin typeface="Patrick Hand"/>
+              </a:rPr>
+              <a:t>lenses cannot read it</a:t>
             </a:r>
           </a:p>
         </p:txBody>
@@ -6949,7 +7195,7 @@
                 </a:solidFill>
                 <a:latin typeface="Caveat"/>
               </a:rPr>
-              <a:t>More citations, more paper knowledge</a:t>
+              <a:t>Which lens reads best?</a:t>
             </a:r>
           </a:p>
         </p:txBody>
@@ -6988,14 +7234,14 @@
                 </a:solidFill>
                 <a:latin typeface="Patrick Hand"/>
               </a:rPr>
-              <a:t>model output · bins with &lt; 10 papers omitted</a:t>
+              <a:t>all papers · true title</a:t>
             </a:r>
           </a:p>
         </p:txBody>
       </p:sp>
       <p:pic>
         <p:nvPicPr>
-          <p:cNvPr id="5" name="Picture 4" descr="c6_citation.png"/>
+          <p:cNvPr id="5" name="Picture 4" descr="c4_lens_quality.png"/>
           <p:cNvPicPr>
             <a:picLocks noChangeAspect="1"/>
           </p:cNvPicPr>
@@ -7010,7 +7256,7 @@
         <p:spPr>
           <a:xfrm>
             <a:off x="457200" y="1463040"/>
-            <a:ext cx="8412480" cy="3894666"/>
+            <a:ext cx="8412480" cy="3963572"/>
           </a:xfrm>
           <a:prstGeom prst="rect">
             <a:avLst/>
@@ -7065,22 +7311,13 @@
               </a:spcAft>
             </a:pPr>
             <a:r>
-              <a:rPr sz="1800" b="0">
-                <a:solidFill>
-                  <a:srgbClr val="2B2D42"/>
-                </a:solidFill>
-                <a:latin typeface="Patrick Hand"/>
-              </a:rPr>
-              <a:t>Target: </a:t>
-            </a:r>
-            <a:r>
-              <a:rPr sz="1800" b="1">
-                <a:solidFill>
-                  <a:srgbClr val="E07A2F"/>
-                </a:solidFill>
-                <a:latin typeface="Patrick Hand"/>
-              </a:rPr>
-              <a:t>+0.35 -&gt; +0.64</a:t>
+              <a:rPr sz="1900" b="1">
+                <a:solidFill>
+                  <a:srgbClr val="3C8D5A"/>
+                </a:solidFill>
+                <a:latin typeface="Patrick Hand"/>
+              </a:rPr>
+              <a:t>Middle layers:</a:t>
             </a:r>
           </a:p>
           <a:p>
@@ -7090,13 +7327,13 @@
               </a:spcAft>
             </a:pPr>
             <a:r>
-              <a:rPr sz="1800" b="0">
-                <a:solidFill>
-                  <a:srgbClr val="2B2D42"/>
-                </a:solidFill>
-                <a:latin typeface="Patrick Hand"/>
-              </a:rPr>
-              <a:t>Spearman (title-specific)</a:t>
+              <a:rPr sz="1900" b="0">
+                <a:solidFill>
+                  <a:srgbClr val="2B2D42"/>
+                </a:solidFill>
+                <a:latin typeface="Patrick Hand"/>
+              </a:rPr>
+              <a:t>fitA best; at L48 15-18% top-10 vs 1% for logit</a:t>
             </a:r>
           </a:p>
           <a:p>
@@ -7106,38 +7343,22 @@
               </a:spcAft>
             </a:pPr>
             <a:r>
-              <a:rPr sz="1800" b="1">
-                <a:solidFill>
-                  <a:srgbClr val="2B2D42"/>
-                </a:solidFill>
-                <a:latin typeface="Patrick Hand"/>
-              </a:rPr>
-              <a:t>0.45</a:t>
-            </a:r>
-            <a:r>
-              <a:rPr sz="1800" b="0">
-                <a:solidFill>
-                  <a:srgbClr val="2B2D42"/>
-                </a:solidFill>
-                <a:latin typeface="Patrick Hand"/>
-              </a:rPr>
-              <a:t> all · 0.33 target · 0.19 control</a:t>
-            </a:r>
-          </a:p>
-          <a:p>
-            <a:pPr algn="l">
-              <a:spcAft>
-                <a:spcPts val="900"/>
-              </a:spcAft>
-            </a:pPr>
-            <a:r>
-              <a:rPr sz="1800" b="0">
-                <a:solidFill>
-                  <a:srgbClr val="2B2D42"/>
-                </a:solidFill>
-                <a:latin typeface="Patrick Hand"/>
-              </a:rPr>
-              <a:t>Target &gt; control in every bin</a:t>
+              <a:rPr sz="1900" b="1">
+                <a:solidFill>
+                  <a:srgbClr val="3A6EA5"/>
+                </a:solidFill>
+                <a:latin typeface="Patrick Hand"/>
+              </a:rPr>
+              <a:t>L62:</a:t>
+            </a:r>
+            <a:r>
+              <a:rPr sz="1900" b="0">
+                <a:solidFill>
+                  <a:srgbClr val="2B2D42"/>
+                </a:solidFill>
+                <a:latin typeface="Patrick Hand"/>
+              </a:rPr>
+              <a:t> logit lens best (59%)</a:t>
             </a:r>
           </a:p>
         </p:txBody>
@@ -7218,7 +7439,7 @@
                 </a:solidFill>
                 <a:latin typeface="Caveat"/>
               </a:rPr>
-              <a:t>First token or the rest of the name?</a:t>
+              <a:t>Do lenses reveal hidden paper knowledge?</a:t>
             </a:r>
           </a:p>
         </p:txBody>
@@ -7257,14 +7478,14 @@
                 </a:solidFill>
                 <a:latin typeface="Patrick Hand"/>
               </a:rPr>
-              <a:t>model output · split by name format</a:t>
+              <a:t>paired differences, 95% CI</a:t>
             </a:r>
           </a:p>
         </p:txBody>
       </p:sp>
       <p:pic>
         <p:nvPicPr>
-          <p:cNvPr id="5" name="Picture 4" descr="c7_format_position.png"/>
+          <p:cNvPr id="5" name="Picture 4" descr="c5_lens_extra.png"/>
           <p:cNvPicPr>
             <a:picLocks noChangeAspect="1"/>
           </p:cNvPicPr>
@@ -7334,14 +7555,30 @@
               </a:spcAft>
             </a:pPr>
             <a:r>
+              <a:rPr sz="1900" b="0">
+                <a:solidFill>
+                  <a:srgbClr val="2B2D42"/>
+                </a:solidFill>
+                <a:latin typeface="Patrick Hand"/>
+              </a:rPr>
+              <a:t>Extra signal: </a:t>
+            </a:r>
+            <a:r>
               <a:rPr sz="1900" b="1">
                 <a:solidFill>
-                  <a:srgbClr val="3A6EA5"/>
-                </a:solidFill>
-                <a:latin typeface="Patrick Hand"/>
-              </a:rPr>
-              <a:t>Initial:</a:t>
-            </a:r>
+                  <a:srgbClr val="2B2D42"/>
+                </a:solidFill>
+                <a:latin typeface="Patrick Hand"/>
+              </a:rPr>
+              <a:t>+0.01 to +0.03</a:t>
+            </a:r>
+          </a:p>
+          <a:p>
+            <a:pPr algn="l">
+              <a:spcAft>
+                <a:spcPts val="900"/>
+              </a:spcAft>
+            </a:pPr>
             <a:r>
               <a:rPr sz="1900" b="0">
                 <a:solidFill>
@@ -7349,7 +7586,7 @@
                 </a:solidFill>
                 <a:latin typeface="Patrick Hand"/>
               </a:rPr>
-              <a:t> carries little; signal is on the surname</a:t>
+              <a:t>vs ~0.44 at L62</a:t>
             </a:r>
           </a:p>
           <a:p>
@@ -7365,7 +7602,7 @@
                 </a:solidFill>
                 <a:latin typeface="Patrick Hand"/>
               </a:rPr>
-              <a:t>Full given name:</a:t>
+              <a:t>Not bigger for target</a:t>
             </a:r>
             <a:r>
               <a:rPr sz="1900" b="0">
@@ -7374,7 +7611,7 @@
                 </a:solidFill>
                 <a:latin typeface="Patrick Hand"/>
               </a:rPr>
-              <a:t> carries about as much as the surname</a:t>
+              <a:t> (even negative at L48-56)</a:t>
             </a:r>
           </a:p>
         </p:txBody>
@@ -7455,7 +7692,7 @@
                 </a:solidFill>
                 <a:latin typeface="Caveat"/>
               </a:rPr>
-              <a:t>Knowing the given name helps with the surname</a:t>
+              <a:t>More citations, more paper knowledge</a:t>
             </a:r>
           </a:p>
         </p:txBody>
@@ -7494,14 +7731,14 @@
                 </a:solidFill>
                 <a:latin typeface="Patrick Hand"/>
               </a:rPr>
-              <a:t>true title · later words when the first word is / is not in the top 10</a:t>
+              <a:t>model output · bins with &lt; 10 papers omitted</a:t>
             </a:r>
           </a:p>
         </p:txBody>
       </p:sp>
       <p:pic>
         <p:nvPicPr>
-          <p:cNvPr id="5" name="Picture 4" descr="c8_first_word_helps.png"/>
+          <p:cNvPr id="5" name="Picture 4" descr="c6_citation.png"/>
           <p:cNvPicPr>
             <a:picLocks noChangeAspect="1"/>
           </p:cNvPicPr>
@@ -7515,8 +7752,8 @@
         </p:blipFill>
         <p:spPr>
           <a:xfrm>
-            <a:off x="548640" y="1463040"/>
-            <a:ext cx="7315200" cy="4354285"/>
+            <a:off x="457200" y="1463040"/>
+            <a:ext cx="8412480" cy="3894666"/>
           </a:xfrm>
           <a:prstGeom prst="rect">
             <a:avLst/>
@@ -7531,8 +7768,8 @@
         </p:nvSpPr>
         <p:spPr>
           <a:xfrm rot="21510000">
-            <a:off x="8229600" y="1737360"/>
-            <a:ext cx="3383280" cy="3108960"/>
+            <a:off x="9098280" y="1737360"/>
+            <a:ext cx="2651760" cy="3108960"/>
           </a:xfrm>
           <a:prstGeom prst="rect">
             <a:avLst/>
@@ -7571,13 +7808,22 @@
               </a:spcAft>
             </a:pPr>
             <a:r>
-              <a:rPr sz="1900" b="1">
+              <a:rPr sz="1800" b="0">
+                <a:solidFill>
+                  <a:srgbClr val="2B2D42"/>
+                </a:solidFill>
+                <a:latin typeface="Patrick Hand"/>
+              </a:rPr>
+              <a:t>Target: </a:t>
+            </a:r>
+            <a:r>
+              <a:rPr sz="1800" b="1">
                 <a:solidFill>
                   <a:srgbClr val="E07A2F"/>
                 </a:solidFill>
                 <a:latin typeface="Patrick Hand"/>
               </a:rPr>
-              <a:t>Given name in top 10</a:t>
+              <a:t>+0.35 -&gt; +0.64</a:t>
             </a:r>
           </a:p>
           <a:p>
@@ -7587,13 +7833,13 @@
               </a:spcAft>
             </a:pPr>
             <a:r>
-              <a:rPr sz="1900" b="0">
-                <a:solidFill>
-                  <a:srgbClr val="2B2D42"/>
-                </a:solidFill>
-                <a:latin typeface="Patrick Hand"/>
-              </a:rPr>
-              <a:t>surname +0.22 (output)</a:t>
+              <a:rPr sz="1800" b="0">
+                <a:solidFill>
+                  <a:srgbClr val="2B2D42"/>
+                </a:solidFill>
+                <a:latin typeface="Patrick Hand"/>
+              </a:rPr>
+              <a:t>Spearman (title-specific)</a:t>
             </a:r>
           </a:p>
           <a:p>
@@ -7603,13 +7849,22 @@
               </a:spcAft>
             </a:pPr>
             <a:r>
-              <a:rPr sz="1900" b="0">
-                <a:solidFill>
-                  <a:srgbClr val="2B2D42"/>
-                </a:solidFill>
-                <a:latin typeface="Patrick Hand"/>
-              </a:rPr>
-              <a:t>+0.32 (logit L62)</a:t>
+              <a:rPr sz="1800" b="1">
+                <a:solidFill>
+                  <a:srgbClr val="2B2D42"/>
+                </a:solidFill>
+                <a:latin typeface="Patrick Hand"/>
+              </a:rPr>
+              <a:t>0.45</a:t>
+            </a:r>
+            <a:r>
+              <a:rPr sz="1800" b="0">
+                <a:solidFill>
+                  <a:srgbClr val="2B2D42"/>
+                </a:solidFill>
+                <a:latin typeface="Patrick Hand"/>
+              </a:rPr>
+              <a:t> all · 0.33 target · 0.19 control</a:t>
             </a:r>
           </a:p>
           <a:p>
@@ -7619,22 +7874,13 @@
               </a:spcAft>
             </a:pPr>
             <a:r>
-              <a:rPr sz="1900" b="1">
-                <a:solidFill>
-                  <a:srgbClr val="3A6EA5"/>
-                </a:solidFill>
-                <a:latin typeface="Patrick Hand"/>
-              </a:rPr>
-              <a:t>Initial in top 10</a:t>
-            </a:r>
-            <a:r>
-              <a:rPr sz="1900" b="0">
-                <a:solidFill>
-                  <a:srgbClr val="2B2D42"/>
-                </a:solidFill>
-                <a:latin typeface="Patrick Hand"/>
-              </a:rPr>
-              <a:t>: no help</a:t>
+              <a:rPr sz="1800" b="0">
+                <a:solidFill>
+                  <a:srgbClr val="2B2D42"/>
+                </a:solidFill>
+                <a:latin typeface="Patrick Hand"/>
+              </a:rPr>
+              <a:t>Target &gt; control in every bin</a:t>
             </a:r>
           </a:p>
         </p:txBody>
@@ -7715,7 +7961,7 @@
                 </a:solidFill>
                 <a:latin typeface="Caveat"/>
               </a:rPr>
-              <a:t>Where the signal sits, and a dose-response</a:t>
+              <a:t>First token or the rest of the name?</a:t>
             </a:r>
           </a:p>
         </p:txBody>
@@ -7754,14 +8000,14 @@
                 </a:solidFill>
                 <a:latin typeface="Patrick Hand"/>
               </a:rPr>
-              <a:t>model output</a:t>
+              <a:t>model output · split by name format</a:t>
             </a:r>
           </a:p>
         </p:txBody>
       </p:sp>
       <p:pic>
         <p:nvPicPr>
-          <p:cNvPr id="5" name="Picture 4" descr="c9_roles.png"/>
+          <p:cNvPr id="5" name="Picture 4" descr="c7_format_position.png"/>
           <p:cNvPicPr>
             <a:picLocks noChangeAspect="1"/>
           </p:cNvPicPr>
@@ -7775,73 +8021,103 @@
         </p:blipFill>
         <p:spPr>
           <a:xfrm>
-            <a:off x="365760" y="1463040"/>
-            <a:ext cx="6675120" cy="3973285"/>
+            <a:off x="457200" y="1463040"/>
+            <a:ext cx="8412480" cy="3963572"/>
           </a:xfrm>
           <a:prstGeom prst="rect">
             <a:avLst/>
           </a:prstGeom>
         </p:spPr>
       </p:pic>
-      <p:pic>
-        <p:nvPicPr>
-          <p:cNvPr id="6" name="Picture 5" descr="c10_graded.png"/>
-          <p:cNvPicPr>
-            <a:picLocks noChangeAspect="1"/>
-          </p:cNvPicPr>
-          <p:nvPr/>
-        </p:nvPicPr>
-        <p:blipFill>
-          <a:blip r:embed="rId5"/>
-          <a:stretch>
-            <a:fillRect/>
-          </a:stretch>
-        </p:blipFill>
-        <p:spPr>
-          <a:xfrm>
-            <a:off x="7223760" y="1737360"/>
-            <a:ext cx="4572000" cy="3282553"/>
-          </a:xfrm>
-          <a:prstGeom prst="rect">
-            <a:avLst/>
-          </a:prstGeom>
-        </p:spPr>
-      </p:pic>
-      <p:sp>
-        <p:nvSpPr>
-          <p:cNvPr id="7" name="TextBox 6"/>
-          <p:cNvSpPr txBox="1"/>
-          <p:nvPr/>
-        </p:nvSpPr>
-        <p:spPr>
-          <a:xfrm>
-            <a:off x="713232" y="6355080"/>
-            <a:ext cx="10789920" cy="320040"/>
-          </a:xfrm>
-          <a:prstGeom prst="rect">
-            <a:avLst/>
-          </a:prstGeom>
-          <a:noFill/>
-        </p:spPr>
-        <p:txBody>
-          <a:bodyPr wrap="square" lIns="0" rIns="0" tIns="0" bIns="0" anchor="t">
-            <a:spAutoFit/>
-          </a:bodyPr>
-          <a:lstStyle/>
-          <a:p>
-            <a:pPr algn="l">
-              <a:spcAft>
-                <a:spcPts val="800"/>
-              </a:spcAft>
-            </a:pPr>
-            <a:r>
-              <a:rPr sz="1400" b="0">
-                <a:solidFill>
-                  <a:srgbClr val="6E7080"/>
-                </a:solidFill>
-                <a:latin typeface="Patrick Hand"/>
-              </a:rPr>
-              <a:t>Right: R0/R1 papers, centred within citation bin; Spearman rho = 0.27, p &lt; 0.001.</a:t>
+      <p:sp>
+        <p:nvSpPr>
+          <p:cNvPr id="6" name="Rectangle 5"/>
+          <p:cNvSpPr/>
+          <p:nvPr/>
+        </p:nvSpPr>
+        <p:spPr>
+          <a:xfrm rot="90000">
+            <a:off x="9098280" y="1737360"/>
+            <a:ext cx="2651760" cy="3108960"/>
+          </a:xfrm>
+          <a:prstGeom prst="rect">
+            <a:avLst/>
+          </a:prstGeom>
+          <a:solidFill>
+            <a:srgbClr val="FFF1A8"/>
+          </a:solidFill>
+          <a:ln w="12700">
+            <a:solidFill>
+              <a:srgbClr val="E2D37A"/>
+            </a:solidFill>
+          </a:ln>
+          <a:effectLst/>
+        </p:spPr>
+        <p:style>
+          <a:lnRef idx="1">
+            <a:schemeClr val="accent1"/>
+          </a:lnRef>
+          <a:fillRef idx="3">
+            <a:schemeClr val="accent1"/>
+          </a:fillRef>
+          <a:effectRef idx="2">
+            <a:schemeClr val="accent1"/>
+          </a:effectRef>
+          <a:fontRef idx="minor">
+            <a:schemeClr val="lt1"/>
+          </a:fontRef>
+        </p:style>
+        <p:txBody>
+          <a:bodyPr rtlCol="0" anchor="t" wrap="square" lIns="201168" rIns="201168" tIns="164592" bIns="164592"/>
+          <a:lstStyle/>
+          <a:p>
+            <a:pPr algn="l">
+              <a:spcAft>
+                <a:spcPts val="900"/>
+              </a:spcAft>
+            </a:pPr>
+            <a:r>
+              <a:rPr sz="1900" b="1">
+                <a:solidFill>
+                  <a:srgbClr val="3A6EA5"/>
+                </a:solidFill>
+                <a:latin typeface="Patrick Hand"/>
+              </a:rPr>
+              <a:t>Initial:</a:t>
+            </a:r>
+            <a:r>
+              <a:rPr sz="1900" b="0">
+                <a:solidFill>
+                  <a:srgbClr val="2B2D42"/>
+                </a:solidFill>
+                <a:latin typeface="Patrick Hand"/>
+              </a:rPr>
+              <a:t> carries little; signal is on the surname</a:t>
+            </a:r>
+          </a:p>
+          <a:p>
+            <a:pPr algn="l">
+              <a:spcAft>
+                <a:spcPts val="900"/>
+              </a:spcAft>
+            </a:pPr>
+            <a:r>
+              <a:rPr sz="1900" b="1">
+                <a:solidFill>
+                  <a:srgbClr val="E07A2F"/>
+                </a:solidFill>
+                <a:latin typeface="Patrick Hand"/>
+              </a:rPr>
+              <a:t>Full given name:</a:t>
+            </a:r>
+            <a:r>
+              <a:rPr sz="1900" b="0">
+                <a:solidFill>
+                  <a:srgbClr val="2B2D42"/>
+                </a:solidFill>
+                <a:latin typeface="Patrick Hand"/>
+              </a:rPr>
+              <a:t> carries about as much as the surname</a:t>
             </a:r>
           </a:p>
         </p:txBody>
@@ -8333,7 +8609,7 @@
                 </a:solidFill>
                 <a:latin typeface="Caveat"/>
               </a:rPr>
-              <a:t>What we learned</a:t>
+              <a:t>Knowing the given name helps with the surname</a:t>
             </a:r>
           </a:p>
         </p:txBody>
@@ -8346,8 +8622,8 @@
         </p:nvSpPr>
         <p:spPr>
           <a:xfrm>
-            <a:off x="822960" y="1325880"/>
-            <a:ext cx="2834640" cy="777240"/>
+            <a:off x="713232" y="987552"/>
+            <a:ext cx="10881360" cy="411480"/>
           </a:xfrm>
           <a:prstGeom prst="rect">
             <a:avLst/>
@@ -8366,442 +8642,153 @@
               </a:spcAft>
             </a:pPr>
             <a:r>
-              <a:rPr sz="2800" b="1">
+              <a:rPr sz="1900" b="0">
+                <a:solidFill>
+                  <a:srgbClr val="6E7080"/>
+                </a:solidFill>
+                <a:latin typeface="Patrick Hand"/>
+              </a:rPr>
+              <a:t>true title · later words when the first word is / is not in the top 10</a:t>
+            </a:r>
+          </a:p>
+        </p:txBody>
+      </p:sp>
+      <p:pic>
+        <p:nvPicPr>
+          <p:cNvPr id="5" name="Picture 4" descr="c8_first_word_helps.png"/>
+          <p:cNvPicPr>
+            <a:picLocks noChangeAspect="1"/>
+          </p:cNvPicPr>
+          <p:nvPr/>
+        </p:nvPicPr>
+        <p:blipFill>
+          <a:blip r:embed="rId4"/>
+          <a:stretch>
+            <a:fillRect/>
+          </a:stretch>
+        </p:blipFill>
+        <p:spPr>
+          <a:xfrm>
+            <a:off x="548640" y="1463040"/>
+            <a:ext cx="7315200" cy="4354285"/>
+          </a:xfrm>
+          <a:prstGeom prst="rect">
+            <a:avLst/>
+          </a:prstGeom>
+        </p:spPr>
+      </p:pic>
+      <p:sp>
+        <p:nvSpPr>
+          <p:cNvPr id="6" name="Rectangle 5"/>
+          <p:cNvSpPr/>
+          <p:nvPr/>
+        </p:nvSpPr>
+        <p:spPr>
+          <a:xfrm rot="21510000">
+            <a:off x="8229600" y="1737360"/>
+            <a:ext cx="3383280" cy="3108960"/>
+          </a:xfrm>
+          <a:prstGeom prst="rect">
+            <a:avLst/>
+          </a:prstGeom>
+          <a:solidFill>
+            <a:srgbClr val="FFF1A8"/>
+          </a:solidFill>
+          <a:ln w="12700">
+            <a:solidFill>
+              <a:srgbClr val="E2D37A"/>
+            </a:solidFill>
+          </a:ln>
+          <a:effectLst/>
+        </p:spPr>
+        <p:style>
+          <a:lnRef idx="1">
+            <a:schemeClr val="accent1"/>
+          </a:lnRef>
+          <a:fillRef idx="3">
+            <a:schemeClr val="accent1"/>
+          </a:fillRef>
+          <a:effectRef idx="2">
+            <a:schemeClr val="accent1"/>
+          </a:effectRef>
+          <a:fontRef idx="minor">
+            <a:schemeClr val="lt1"/>
+          </a:fontRef>
+        </p:style>
+        <p:txBody>
+          <a:bodyPr rtlCol="0" anchor="t" wrap="square" lIns="201168" rIns="201168" tIns="164592" bIns="164592"/>
+          <a:lstStyle/>
+          <a:p>
+            <a:pPr algn="l">
+              <a:spcAft>
+                <a:spcPts val="900"/>
+              </a:spcAft>
+            </a:pPr>
+            <a:r>
+              <a:rPr sz="1900" b="1">
                 <a:solidFill>
                   <a:srgbClr val="E07A2F"/>
                 </a:solidFill>
-                <a:latin typeface="Caveat"/>
-              </a:rPr>
-              <a:t>Late</a:t>
-            </a:r>
-          </a:p>
-        </p:txBody>
-      </p:sp>
-      <p:sp>
-        <p:nvSpPr>
-          <p:cNvPr id="5" name="TextBox 4"/>
-          <p:cNvSpPr txBox="1"/>
-          <p:nvPr/>
-        </p:nvSpPr>
-        <p:spPr>
-          <a:xfrm>
-            <a:off x="3657600" y="1417320"/>
-            <a:ext cx="7863840" cy="777240"/>
-          </a:xfrm>
-          <a:prstGeom prst="rect">
-            <a:avLst/>
-          </a:prstGeom>
-          <a:noFill/>
-        </p:spPr>
-        <p:txBody>
-          <a:bodyPr wrap="square" lIns="0" rIns="0" tIns="0" bIns="0" anchor="t">
-            <a:spAutoFit/>
-          </a:bodyPr>
-          <a:lstStyle/>
-          <a:p>
-            <a:pPr algn="l">
-              <a:spcAft>
-                <a:spcPts val="800"/>
-              </a:spcAft>
-            </a:pPr>
-            <a:r>
-              <a:rPr sz="2000" b="0">
-                <a:solidFill>
-                  <a:srgbClr val="2B2D42"/>
-                </a:solidFill>
-                <a:latin typeface="Patrick Hand"/>
-              </a:rPr>
-              <a:t>Paper-specific author knowledge builds up from about L50, fastest over L57-L61, peaking at L61-L62.</a:t>
-            </a:r>
-          </a:p>
-        </p:txBody>
-      </p:sp>
-      <p:sp>
-        <p:nvSpPr>
-          <p:cNvPr id="6" name="TextBox 5"/>
-          <p:cNvSpPr txBox="1"/>
-          <p:nvPr/>
-        </p:nvSpPr>
-        <p:spPr>
-          <a:xfrm>
-            <a:off x="822960" y="2167128"/>
-            <a:ext cx="2834640" cy="777240"/>
-          </a:xfrm>
-          <a:prstGeom prst="rect">
-            <a:avLst/>
-          </a:prstGeom>
-          <a:noFill/>
-        </p:spPr>
-        <p:txBody>
-          <a:bodyPr wrap="square" lIns="0" rIns="0" tIns="0" bIns="0" anchor="t">
-            <a:spAutoFit/>
-          </a:bodyPr>
-          <a:lstStyle/>
-          <a:p>
-            <a:pPr algn="l">
-              <a:spcAft>
-                <a:spcPts val="800"/>
-              </a:spcAft>
-            </a:pPr>
-            <a:r>
-              <a:rPr sz="2800" b="1">
-                <a:solidFill>
-                  <a:srgbClr val="3C8D5A"/>
-                </a:solidFill>
-                <a:latin typeface="Caveat"/>
-              </a:rPr>
-              <a:t>Read early</a:t>
-            </a:r>
-          </a:p>
-        </p:txBody>
-      </p:sp>
-      <p:sp>
-        <p:nvSpPr>
-          <p:cNvPr id="7" name="TextBox 6"/>
-          <p:cNvSpPr txBox="1"/>
-          <p:nvPr/>
-        </p:nvSpPr>
-        <p:spPr>
-          <a:xfrm>
-            <a:off x="3657600" y="2258568"/>
-            <a:ext cx="7863840" cy="777240"/>
-          </a:xfrm>
-          <a:prstGeom prst="rect">
-            <a:avLst/>
-          </a:prstGeom>
-          <a:noFill/>
-        </p:spPr>
-        <p:txBody>
-          <a:bodyPr wrap="square" lIns="0" rIns="0" tIns="0" bIns="0" anchor="t">
-            <a:spAutoFit/>
-          </a:bodyPr>
-          <a:lstStyle/>
-          <a:p>
-            <a:pPr algn="l">
-              <a:spcAft>
-                <a:spcPts val="800"/>
-              </a:spcAft>
-            </a:pPr>
-            <a:r>
-              <a:rPr sz="2000" b="0">
-                <a:solidFill>
-                  <a:srgbClr val="2B2D42"/>
-                </a:solidFill>
-                <a:latin typeface="Patrick Hand"/>
-              </a:rPr>
-              <a:t>Causally, the title is read in L24-L50 and moved into the tokens after it; after L52 it is no longer needed.</a:t>
-            </a:r>
-          </a:p>
-        </p:txBody>
-      </p:sp>
-      <p:sp>
-        <p:nvSpPr>
-          <p:cNvPr id="8" name="TextBox 7"/>
-          <p:cNvSpPr txBox="1"/>
-          <p:nvPr/>
-        </p:nvSpPr>
-        <p:spPr>
-          <a:xfrm>
-            <a:off x="822960" y="3008376"/>
-            <a:ext cx="2834640" cy="777240"/>
-          </a:xfrm>
-          <a:prstGeom prst="rect">
-            <a:avLst/>
-          </a:prstGeom>
-          <a:noFill/>
-        </p:spPr>
-        <p:txBody>
-          <a:bodyPr wrap="square" lIns="0" rIns="0" tIns="0" bIns="0" anchor="t">
-            <a:spAutoFit/>
-          </a:bodyPr>
-          <a:lstStyle/>
-          <a:p>
-            <a:pPr algn="l">
-              <a:spcAft>
-                <a:spcPts val="800"/>
-              </a:spcAft>
-            </a:pPr>
-            <a:r>
-              <a:rPr sz="2800" b="1">
+                <a:latin typeface="Patrick Hand"/>
+              </a:rPr>
+              <a:t>Given name in top 10</a:t>
+            </a:r>
+          </a:p>
+          <a:p>
+            <a:pPr algn="l">
+              <a:spcAft>
+                <a:spcPts val="900"/>
+              </a:spcAft>
+            </a:pPr>
+            <a:r>
+              <a:rPr sz="1900" b="0">
+                <a:solidFill>
+                  <a:srgbClr val="2B2D42"/>
+                </a:solidFill>
+                <a:latin typeface="Patrick Hand"/>
+              </a:rPr>
+              <a:t>surname +0.22 (output)</a:t>
+            </a:r>
+          </a:p>
+          <a:p>
+            <a:pPr algn="l">
+              <a:spcAft>
+                <a:spcPts val="900"/>
+              </a:spcAft>
+            </a:pPr>
+            <a:r>
+              <a:rPr sz="1900" b="0">
+                <a:solidFill>
+                  <a:srgbClr val="2B2D42"/>
+                </a:solidFill>
+                <a:latin typeface="Patrick Hand"/>
+              </a:rPr>
+              <a:t>+0.32 (logit L62)</a:t>
+            </a:r>
+          </a:p>
+          <a:p>
+            <a:pPr algn="l">
+              <a:spcAft>
+                <a:spcPts val="900"/>
+              </a:spcAft>
+            </a:pPr>
+            <a:r>
+              <a:rPr sz="1900" b="1">
                 <a:solidFill>
                   <a:srgbClr val="3A6EA5"/>
                 </a:solidFill>
-                <a:latin typeface="Caveat"/>
-              </a:rPr>
-              <a:t>No head start</a:t>
-            </a:r>
-          </a:p>
-        </p:txBody>
-      </p:sp>
-      <p:sp>
-        <p:nvSpPr>
-          <p:cNvPr id="9" name="TextBox 8"/>
-          <p:cNvSpPr txBox="1"/>
-          <p:nvPr/>
-        </p:nvSpPr>
-        <p:spPr>
-          <a:xfrm>
-            <a:off x="3657600" y="3099816"/>
-            <a:ext cx="7863840" cy="777240"/>
-          </a:xfrm>
-          <a:prstGeom prst="rect">
-            <a:avLst/>
-          </a:prstGeom>
-          <a:noFill/>
-        </p:spPr>
-        <p:txBody>
-          <a:bodyPr wrap="square" lIns="0" rIns="0" tIns="0" bIns="0" anchor="t">
-            <a:spAutoFit/>
-          </a:bodyPr>
-          <a:lstStyle/>
-          <a:p>
-            <a:pPr algn="l">
-              <a:spcAft>
-                <a:spcPts val="800"/>
-              </a:spcAft>
-            </a:pPr>
-            <a:r>
-              <a:rPr sz="2000" b="0">
-                <a:solidFill>
-                  <a:srgbClr val="2B2D42"/>
-                </a:solidFill>
-                <a:latin typeface="Patrick Hand"/>
-              </a:rPr>
-              <a:t>Target papers are not ahead of control in middle layers; the +0.21 gap is at the end.</a:t>
-            </a:r>
-          </a:p>
-        </p:txBody>
-      </p:sp>
-      <p:sp>
-        <p:nvSpPr>
-          <p:cNvPr id="10" name="TextBox 9"/>
-          <p:cNvSpPr txBox="1"/>
-          <p:nvPr/>
-        </p:nvSpPr>
-        <p:spPr>
-          <a:xfrm>
-            <a:off x="822960" y="3849624"/>
-            <a:ext cx="2834640" cy="777240"/>
-          </a:xfrm>
-          <a:prstGeom prst="rect">
-            <a:avLst/>
-          </a:prstGeom>
-          <a:noFill/>
-        </p:spPr>
-        <p:txBody>
-          <a:bodyPr wrap="square" lIns="0" rIns="0" tIns="0" bIns="0" anchor="t">
-            <a:spAutoFit/>
-          </a:bodyPr>
-          <a:lstStyle/>
-          <a:p>
-            <a:pPr algn="l">
-              <a:spcAft>
-                <a:spcPts val="800"/>
-              </a:spcAft>
-            </a:pPr>
-            <a:r>
-              <a:rPr sz="2800" b="1">
-                <a:solidFill>
-                  <a:srgbClr val="3C8D5A"/>
-                </a:solidFill>
-                <a:latin typeface="Caveat"/>
-              </a:rPr>
-              <a:t>Real knowledge</a:t>
-            </a:r>
-          </a:p>
-        </p:txBody>
-      </p:sp>
-      <p:sp>
-        <p:nvSpPr>
-          <p:cNvPr id="11" name="TextBox 10"/>
-          <p:cNvSpPr txBox="1"/>
-          <p:nvPr/>
-        </p:nvSpPr>
-        <p:spPr>
-          <a:xfrm>
-            <a:off x="3657600" y="3941063"/>
-            <a:ext cx="7863840" cy="777240"/>
-          </a:xfrm>
-          <a:prstGeom prst="rect">
-            <a:avLst/>
-          </a:prstGeom>
-          <a:noFill/>
-        </p:spPr>
-        <p:txBody>
-          <a:bodyPr wrap="square" lIns="0" rIns="0" tIns="0" bIns="0" anchor="t">
-            <a:spAutoFit/>
-          </a:bodyPr>
-          <a:lstStyle/>
-          <a:p>
-            <a:pPr algn="l">
-              <a:spcAft>
-                <a:spcPts val="800"/>
-              </a:spcAft>
-            </a:pPr>
-            <a:r>
-              <a:rPr sz="2000" b="0">
-                <a:solidFill>
-                  <a:srgbClr val="2B2D42"/>
-                </a:solidFill>
-                <a:latin typeface="Patrick Hand"/>
-              </a:rPr>
-              <a:t>The gap is title-specific and grows with citations, so it is not name guessing.</a:t>
-            </a:r>
-          </a:p>
-        </p:txBody>
-      </p:sp>
-      <p:sp>
-        <p:nvSpPr>
-          <p:cNvPr id="12" name="TextBox 11"/>
-          <p:cNvSpPr txBox="1"/>
-          <p:nvPr/>
-        </p:nvSpPr>
-        <p:spPr>
-          <a:xfrm>
-            <a:off x="822960" y="4690872"/>
-            <a:ext cx="2834640" cy="777240"/>
-          </a:xfrm>
-          <a:prstGeom prst="rect">
-            <a:avLst/>
-          </a:prstGeom>
-          <a:noFill/>
-        </p:spPr>
-        <p:txBody>
-          <a:bodyPr wrap="square" lIns="0" rIns="0" tIns="0" bIns="0" anchor="t">
-            <a:spAutoFit/>
-          </a:bodyPr>
-          <a:lstStyle/>
-          <a:p>
-            <a:pPr algn="l">
-              <a:spcAft>
-                <a:spcPts val="800"/>
-              </a:spcAft>
-            </a:pPr>
-            <a:r>
-              <a:rPr sz="2800" b="1">
-                <a:solidFill>
-                  <a:srgbClr val="2B2D42"/>
-                </a:solidFill>
-                <a:latin typeface="Caveat"/>
-              </a:rPr>
-              <a:t>Lenses agree</a:t>
-            </a:r>
-          </a:p>
-        </p:txBody>
-      </p:sp>
-      <p:sp>
-        <p:nvSpPr>
-          <p:cNvPr id="13" name="TextBox 12"/>
-          <p:cNvSpPr txBox="1"/>
-          <p:nvPr/>
-        </p:nvSpPr>
-        <p:spPr>
-          <a:xfrm>
-            <a:off x="3657600" y="4782312"/>
-            <a:ext cx="7863840" cy="777240"/>
-          </a:xfrm>
-          <a:prstGeom prst="rect">
-            <a:avLst/>
-          </a:prstGeom>
-          <a:noFill/>
-        </p:spPr>
-        <p:txBody>
-          <a:bodyPr wrap="square" lIns="0" rIns="0" tIns="0" bIns="0" anchor="t">
-            <a:spAutoFit/>
-          </a:bodyPr>
-          <a:lstStyle/>
-          <a:p>
-            <a:pPr algn="l">
-              <a:spcAft>
-                <a:spcPts val="800"/>
-              </a:spcAft>
-            </a:pPr>
-            <a:r>
-              <a:rPr sz="2000" b="0">
-                <a:solidFill>
-                  <a:srgbClr val="2B2D42"/>
-                </a:solidFill>
-                <a:latin typeface="Patrick Hand"/>
-              </a:rPr>
-              <a:t>Jacobian lenses read more in middle layers, but nothing target-specific.</a:t>
-            </a:r>
-          </a:p>
-        </p:txBody>
-      </p:sp>
-      <p:sp>
-        <p:nvSpPr>
-          <p:cNvPr id="14" name="TextBox 13"/>
-          <p:cNvSpPr txBox="1"/>
-          <p:nvPr/>
-        </p:nvSpPr>
-        <p:spPr>
-          <a:xfrm>
-            <a:off x="822960" y="5532120"/>
-            <a:ext cx="2834640" cy="777240"/>
-          </a:xfrm>
-          <a:prstGeom prst="rect">
-            <a:avLst/>
-          </a:prstGeom>
-          <a:noFill/>
-        </p:spPr>
-        <p:txBody>
-          <a:bodyPr wrap="square" lIns="0" rIns="0" tIns="0" bIns="0" anchor="t">
-            <a:spAutoFit/>
-          </a:bodyPr>
-          <a:lstStyle/>
-          <a:p>
-            <a:pPr algn="l">
-              <a:spcAft>
-                <a:spcPts val="800"/>
-              </a:spcAft>
-            </a:pPr>
-            <a:r>
-              <a:rPr sz="2800" b="1">
-                <a:solidFill>
-                  <a:srgbClr val="E07A2F"/>
-                </a:solidFill>
-                <a:latin typeface="Caveat"/>
-              </a:rPr>
-              <a:t>Name format</a:t>
-            </a:r>
-          </a:p>
-        </p:txBody>
-      </p:sp>
-      <p:sp>
-        <p:nvSpPr>
-          <p:cNvPr id="15" name="TextBox 14"/>
-          <p:cNvSpPr txBox="1"/>
-          <p:nvPr/>
-        </p:nvSpPr>
-        <p:spPr>
-          <a:xfrm>
-            <a:off x="3657600" y="5623560"/>
-            <a:ext cx="7863840" cy="777240"/>
-          </a:xfrm>
-          <a:prstGeom prst="rect">
-            <a:avLst/>
-          </a:prstGeom>
-          <a:noFill/>
-        </p:spPr>
-        <p:txBody>
-          <a:bodyPr wrap="square" lIns="0" rIns="0" tIns="0" bIns="0" anchor="t">
-            <a:spAutoFit/>
-          </a:bodyPr>
-          <a:lstStyle/>
-          <a:p>
-            <a:pPr algn="l">
-              <a:spcAft>
-                <a:spcPts val="800"/>
-              </a:spcAft>
-            </a:pPr>
-            <a:r>
-              <a:rPr sz="2000" b="0">
-                <a:solidFill>
-                  <a:srgbClr val="2B2D42"/>
-                </a:solidFill>
-                <a:latin typeface="Patrick Hand"/>
-              </a:rPr>
-              <a:t>Initials carry little; full given names carry as much as surnames and help predict them.</a:t>
+                <a:latin typeface="Patrick Hand"/>
+              </a:rPr>
+              <a:t>Initial in top 10</a:t>
+            </a:r>
+            <a:r>
+              <a:rPr sz="1900" b="0">
+                <a:solidFill>
+                  <a:srgbClr val="2B2D42"/>
+                </a:solidFill>
+                <a:latin typeface="Patrick Hand"/>
+              </a:rPr>
+              <a:t>: no help</a:t>
             </a:r>
           </a:p>
         </p:txBody>
@@ -8815,6 +8802,762 @@
 </file>
 
 <file path=ppt/slides/slide21.xml><?xml version="1.0" encoding="utf-8"?>
+<p:sld xmlns:a="http://schemas.openxmlformats.org/drawingml/2006/main" xmlns:p="http://schemas.openxmlformats.org/presentationml/2006/main" xmlns:r="http://schemas.openxmlformats.org/officeDocument/2006/relationships">
+  <p:cSld>
+    <p:spTree>
+      <p:nvGrpSpPr>
+        <p:cNvPr id="1" name=""/>
+        <p:cNvGrpSpPr/>
+        <p:nvPr/>
+      </p:nvGrpSpPr>
+      <p:grpSpPr/>
+      <p:pic>
+        <p:nvPicPr>
+          <p:cNvPr id="2" name="Picture 1" descr="paper.png"/>
+          <p:cNvPicPr>
+            <a:picLocks noChangeAspect="1"/>
+          </p:cNvPicPr>
+          <p:nvPr/>
+        </p:nvPicPr>
+        <p:blipFill>
+          <a:blip r:embed="rId2"/>
+          <a:stretch>
+            <a:fillRect/>
+          </a:stretch>
+        </p:blipFill>
+        <p:spPr>
+          <a:xfrm>
+            <a:off x="0" y="0"/>
+            <a:ext cx="12191695" cy="6858000"/>
+          </a:xfrm>
+          <a:prstGeom prst="rect">
+            <a:avLst/>
+          </a:prstGeom>
+        </p:spPr>
+      </p:pic>
+      <p:sp>
+        <p:nvSpPr>
+          <p:cNvPr id="3" name="TextBox 2"/>
+          <p:cNvSpPr txBox="1"/>
+          <p:nvPr/>
+        </p:nvSpPr>
+        <p:spPr>
+          <a:xfrm>
+            <a:off x="685800" y="274320"/>
+            <a:ext cx="10881360" cy="822960"/>
+          </a:xfrm>
+          <a:prstGeom prst="rect">
+            <a:avLst/>
+          </a:prstGeom>
+          <a:noFill/>
+        </p:spPr>
+        <p:txBody>
+          <a:bodyPr wrap="square" lIns="0" rIns="0" tIns="0" bIns="0" anchor="t">
+            <a:spAutoFit/>
+          </a:bodyPr>
+          <a:lstStyle/>
+          <a:p>
+            <a:pPr algn="l">
+              <a:spcAft>
+                <a:spcPts val="800"/>
+              </a:spcAft>
+            </a:pPr>
+            <a:r>
+              <a:rPr sz="4600" b="1">
+                <a:solidFill>
+                  <a:srgbClr val="2B2D42"/>
+                </a:solidFill>
+                <a:latin typeface="Caveat"/>
+              </a:rPr>
+              <a:t>Where the signal sits, and a dose-response</a:t>
+            </a:r>
+          </a:p>
+        </p:txBody>
+      </p:sp>
+      <p:sp>
+        <p:nvSpPr>
+          <p:cNvPr id="4" name="TextBox 3"/>
+          <p:cNvSpPr txBox="1"/>
+          <p:nvPr/>
+        </p:nvSpPr>
+        <p:spPr>
+          <a:xfrm>
+            <a:off x="713232" y="987552"/>
+            <a:ext cx="10881360" cy="411480"/>
+          </a:xfrm>
+          <a:prstGeom prst="rect">
+            <a:avLst/>
+          </a:prstGeom>
+          <a:noFill/>
+        </p:spPr>
+        <p:txBody>
+          <a:bodyPr wrap="square" lIns="0" rIns="0" tIns="0" bIns="0" anchor="t">
+            <a:spAutoFit/>
+          </a:bodyPr>
+          <a:lstStyle/>
+          <a:p>
+            <a:pPr algn="l">
+              <a:spcAft>
+                <a:spcPts val="800"/>
+              </a:spcAft>
+            </a:pPr>
+            <a:r>
+              <a:rPr sz="1900" b="0">
+                <a:solidFill>
+                  <a:srgbClr val="6E7080"/>
+                </a:solidFill>
+                <a:latin typeface="Patrick Hand"/>
+              </a:rPr>
+              <a:t>model output</a:t>
+            </a:r>
+          </a:p>
+        </p:txBody>
+      </p:sp>
+      <p:pic>
+        <p:nvPicPr>
+          <p:cNvPr id="5" name="Picture 4" descr="c9_roles.png"/>
+          <p:cNvPicPr>
+            <a:picLocks noChangeAspect="1"/>
+          </p:cNvPicPr>
+          <p:nvPr/>
+        </p:nvPicPr>
+        <p:blipFill>
+          <a:blip r:embed="rId4"/>
+          <a:stretch>
+            <a:fillRect/>
+          </a:stretch>
+        </p:blipFill>
+        <p:spPr>
+          <a:xfrm>
+            <a:off x="365760" y="1463040"/>
+            <a:ext cx="6675120" cy="3973285"/>
+          </a:xfrm>
+          <a:prstGeom prst="rect">
+            <a:avLst/>
+          </a:prstGeom>
+        </p:spPr>
+      </p:pic>
+      <p:pic>
+        <p:nvPicPr>
+          <p:cNvPr id="6" name="Picture 5" descr="c10_graded.png"/>
+          <p:cNvPicPr>
+            <a:picLocks noChangeAspect="1"/>
+          </p:cNvPicPr>
+          <p:nvPr/>
+        </p:nvPicPr>
+        <p:blipFill>
+          <a:blip r:embed="rId5"/>
+          <a:stretch>
+            <a:fillRect/>
+          </a:stretch>
+        </p:blipFill>
+        <p:spPr>
+          <a:xfrm>
+            <a:off x="7223760" y="1737360"/>
+            <a:ext cx="4572000" cy="3282553"/>
+          </a:xfrm>
+          <a:prstGeom prst="rect">
+            <a:avLst/>
+          </a:prstGeom>
+        </p:spPr>
+      </p:pic>
+      <p:sp>
+        <p:nvSpPr>
+          <p:cNvPr id="7" name="TextBox 6"/>
+          <p:cNvSpPr txBox="1"/>
+          <p:nvPr/>
+        </p:nvSpPr>
+        <p:spPr>
+          <a:xfrm>
+            <a:off x="713232" y="6355080"/>
+            <a:ext cx="10789920" cy="320040"/>
+          </a:xfrm>
+          <a:prstGeom prst="rect">
+            <a:avLst/>
+          </a:prstGeom>
+          <a:noFill/>
+        </p:spPr>
+        <p:txBody>
+          <a:bodyPr wrap="square" lIns="0" rIns="0" tIns="0" bIns="0" anchor="t">
+            <a:spAutoFit/>
+          </a:bodyPr>
+          <a:lstStyle/>
+          <a:p>
+            <a:pPr algn="l">
+              <a:spcAft>
+                <a:spcPts val="800"/>
+              </a:spcAft>
+            </a:pPr>
+            <a:r>
+              <a:rPr sz="1400" b="0">
+                <a:solidFill>
+                  <a:srgbClr val="6E7080"/>
+                </a:solidFill>
+                <a:latin typeface="Patrick Hand"/>
+              </a:rPr>
+              <a:t>Right: R0/R1 papers, centred within citation bin; Spearman rho = 0.27, p &lt; 0.001.</a:t>
+            </a:r>
+          </a:p>
+        </p:txBody>
+      </p:sp>
+    </p:spTree>
+  </p:cSld>
+  <p:clrMapOvr>
+    <a:masterClrMapping/>
+  </p:clrMapOvr>
+</p:sld>
+</file>
+
+<file path=ppt/slides/slide22.xml><?xml version="1.0" encoding="utf-8"?>
+<p:sld xmlns:a="http://schemas.openxmlformats.org/drawingml/2006/main" xmlns:p="http://schemas.openxmlformats.org/presentationml/2006/main" xmlns:r="http://schemas.openxmlformats.org/officeDocument/2006/relationships">
+  <p:cSld>
+    <p:spTree>
+      <p:nvGrpSpPr>
+        <p:cNvPr id="1" name=""/>
+        <p:cNvGrpSpPr/>
+        <p:nvPr/>
+      </p:nvGrpSpPr>
+      <p:grpSpPr/>
+      <p:pic>
+        <p:nvPicPr>
+          <p:cNvPr id="2" name="Picture 1" descr="paper.png"/>
+          <p:cNvPicPr>
+            <a:picLocks noChangeAspect="1"/>
+          </p:cNvPicPr>
+          <p:nvPr/>
+        </p:nvPicPr>
+        <p:blipFill>
+          <a:blip r:embed="rId2"/>
+          <a:stretch>
+            <a:fillRect/>
+          </a:stretch>
+        </p:blipFill>
+        <p:spPr>
+          <a:xfrm>
+            <a:off x="0" y="0"/>
+            <a:ext cx="12191695" cy="6858000"/>
+          </a:xfrm>
+          <a:prstGeom prst="rect">
+            <a:avLst/>
+          </a:prstGeom>
+        </p:spPr>
+      </p:pic>
+      <p:sp>
+        <p:nvSpPr>
+          <p:cNvPr id="3" name="TextBox 2"/>
+          <p:cNvSpPr txBox="1"/>
+          <p:nvPr/>
+        </p:nvSpPr>
+        <p:spPr>
+          <a:xfrm>
+            <a:off x="685800" y="274320"/>
+            <a:ext cx="10881360" cy="822960"/>
+          </a:xfrm>
+          <a:prstGeom prst="rect">
+            <a:avLst/>
+          </a:prstGeom>
+          <a:noFill/>
+        </p:spPr>
+        <p:txBody>
+          <a:bodyPr wrap="square" lIns="0" rIns="0" tIns="0" bIns="0" anchor="t">
+            <a:spAutoFit/>
+          </a:bodyPr>
+          <a:lstStyle/>
+          <a:p>
+            <a:pPr algn="l">
+              <a:spcAft>
+                <a:spcPts val="800"/>
+              </a:spcAft>
+            </a:pPr>
+            <a:r>
+              <a:rPr sz="4600" b="1">
+                <a:solidFill>
+                  <a:srgbClr val="2B2D42"/>
+                </a:solidFill>
+                <a:latin typeface="Caveat"/>
+              </a:rPr>
+              <a:t>What we learned</a:t>
+            </a:r>
+          </a:p>
+        </p:txBody>
+      </p:sp>
+      <p:sp>
+        <p:nvSpPr>
+          <p:cNvPr id="4" name="TextBox 3"/>
+          <p:cNvSpPr txBox="1"/>
+          <p:nvPr/>
+        </p:nvSpPr>
+        <p:spPr>
+          <a:xfrm>
+            <a:off x="822960" y="1325880"/>
+            <a:ext cx="2834640" cy="777240"/>
+          </a:xfrm>
+          <a:prstGeom prst="rect">
+            <a:avLst/>
+          </a:prstGeom>
+          <a:noFill/>
+        </p:spPr>
+        <p:txBody>
+          <a:bodyPr wrap="square" lIns="0" rIns="0" tIns="0" bIns="0" anchor="t">
+            <a:spAutoFit/>
+          </a:bodyPr>
+          <a:lstStyle/>
+          <a:p>
+            <a:pPr algn="l">
+              <a:spcAft>
+                <a:spcPts val="800"/>
+              </a:spcAft>
+            </a:pPr>
+            <a:r>
+              <a:rPr sz="2800" b="1">
+                <a:solidFill>
+                  <a:srgbClr val="E07A2F"/>
+                </a:solidFill>
+                <a:latin typeface="Caveat"/>
+              </a:rPr>
+              <a:t>Late</a:t>
+            </a:r>
+          </a:p>
+        </p:txBody>
+      </p:sp>
+      <p:sp>
+        <p:nvSpPr>
+          <p:cNvPr id="5" name="TextBox 4"/>
+          <p:cNvSpPr txBox="1"/>
+          <p:nvPr/>
+        </p:nvSpPr>
+        <p:spPr>
+          <a:xfrm>
+            <a:off x="3657600" y="1417320"/>
+            <a:ext cx="7863840" cy="777240"/>
+          </a:xfrm>
+          <a:prstGeom prst="rect">
+            <a:avLst/>
+          </a:prstGeom>
+          <a:noFill/>
+        </p:spPr>
+        <p:txBody>
+          <a:bodyPr wrap="square" lIns="0" rIns="0" tIns="0" bIns="0" anchor="t">
+            <a:spAutoFit/>
+          </a:bodyPr>
+          <a:lstStyle/>
+          <a:p>
+            <a:pPr algn="l">
+              <a:spcAft>
+                <a:spcPts val="800"/>
+              </a:spcAft>
+            </a:pPr>
+            <a:r>
+              <a:rPr sz="2000" b="0">
+                <a:solidFill>
+                  <a:srgbClr val="2B2D42"/>
+                </a:solidFill>
+                <a:latin typeface="Patrick Hand"/>
+              </a:rPr>
+              <a:t>Paper-specific author knowledge builds up from about L50, fastest over L57-L61, peaking at L61-L62.</a:t>
+            </a:r>
+          </a:p>
+        </p:txBody>
+      </p:sp>
+      <p:sp>
+        <p:nvSpPr>
+          <p:cNvPr id="6" name="TextBox 5"/>
+          <p:cNvSpPr txBox="1"/>
+          <p:nvPr/>
+        </p:nvSpPr>
+        <p:spPr>
+          <a:xfrm>
+            <a:off x="822960" y="2167128"/>
+            <a:ext cx="2834640" cy="777240"/>
+          </a:xfrm>
+          <a:prstGeom prst="rect">
+            <a:avLst/>
+          </a:prstGeom>
+          <a:noFill/>
+        </p:spPr>
+        <p:txBody>
+          <a:bodyPr wrap="square" lIns="0" rIns="0" tIns="0" bIns="0" anchor="t">
+            <a:spAutoFit/>
+          </a:bodyPr>
+          <a:lstStyle/>
+          <a:p>
+            <a:pPr algn="l">
+              <a:spcAft>
+                <a:spcPts val="800"/>
+              </a:spcAft>
+            </a:pPr>
+            <a:r>
+              <a:rPr sz="2800" b="1">
+                <a:solidFill>
+                  <a:srgbClr val="3C8D5A"/>
+                </a:solidFill>
+                <a:latin typeface="Caveat"/>
+              </a:rPr>
+              <a:t>Read early</a:t>
+            </a:r>
+          </a:p>
+        </p:txBody>
+      </p:sp>
+      <p:sp>
+        <p:nvSpPr>
+          <p:cNvPr id="7" name="TextBox 6"/>
+          <p:cNvSpPr txBox="1"/>
+          <p:nvPr/>
+        </p:nvSpPr>
+        <p:spPr>
+          <a:xfrm>
+            <a:off x="3657600" y="2258568"/>
+            <a:ext cx="7863840" cy="777240"/>
+          </a:xfrm>
+          <a:prstGeom prst="rect">
+            <a:avLst/>
+          </a:prstGeom>
+          <a:noFill/>
+        </p:spPr>
+        <p:txBody>
+          <a:bodyPr wrap="square" lIns="0" rIns="0" tIns="0" bIns="0" anchor="t">
+            <a:spAutoFit/>
+          </a:bodyPr>
+          <a:lstStyle/>
+          <a:p>
+            <a:pPr algn="l">
+              <a:spcAft>
+                <a:spcPts val="800"/>
+              </a:spcAft>
+            </a:pPr>
+            <a:r>
+              <a:rPr sz="2000" b="0">
+                <a:solidFill>
+                  <a:srgbClr val="2B2D42"/>
+                </a:solidFill>
+                <a:latin typeface="Patrick Hand"/>
+              </a:rPr>
+              <a:t>Causally, the title is read in L24-L50 and moved into the tokens after it; after L52 it is no longer needed.</a:t>
+            </a:r>
+          </a:p>
+        </p:txBody>
+      </p:sp>
+      <p:sp>
+        <p:nvSpPr>
+          <p:cNvPr id="8" name="TextBox 7"/>
+          <p:cNvSpPr txBox="1"/>
+          <p:nvPr/>
+        </p:nvSpPr>
+        <p:spPr>
+          <a:xfrm>
+            <a:off x="822960" y="3008376"/>
+            <a:ext cx="2834640" cy="777240"/>
+          </a:xfrm>
+          <a:prstGeom prst="rect">
+            <a:avLst/>
+          </a:prstGeom>
+          <a:noFill/>
+        </p:spPr>
+        <p:txBody>
+          <a:bodyPr wrap="square" lIns="0" rIns="0" tIns="0" bIns="0" anchor="t">
+            <a:spAutoFit/>
+          </a:bodyPr>
+          <a:lstStyle/>
+          <a:p>
+            <a:pPr algn="l">
+              <a:spcAft>
+                <a:spcPts val="800"/>
+              </a:spcAft>
+            </a:pPr>
+            <a:r>
+              <a:rPr sz="2800" b="1">
+                <a:solidFill>
+                  <a:srgbClr val="3A6EA5"/>
+                </a:solidFill>
+                <a:latin typeface="Caveat"/>
+              </a:rPr>
+              <a:t>No head start</a:t>
+            </a:r>
+          </a:p>
+        </p:txBody>
+      </p:sp>
+      <p:sp>
+        <p:nvSpPr>
+          <p:cNvPr id="9" name="TextBox 8"/>
+          <p:cNvSpPr txBox="1"/>
+          <p:nvPr/>
+        </p:nvSpPr>
+        <p:spPr>
+          <a:xfrm>
+            <a:off x="3657600" y="3099816"/>
+            <a:ext cx="7863840" cy="777240"/>
+          </a:xfrm>
+          <a:prstGeom prst="rect">
+            <a:avLst/>
+          </a:prstGeom>
+          <a:noFill/>
+        </p:spPr>
+        <p:txBody>
+          <a:bodyPr wrap="square" lIns="0" rIns="0" tIns="0" bIns="0" anchor="t">
+            <a:spAutoFit/>
+          </a:bodyPr>
+          <a:lstStyle/>
+          <a:p>
+            <a:pPr algn="l">
+              <a:spcAft>
+                <a:spcPts val="800"/>
+              </a:spcAft>
+            </a:pPr>
+            <a:r>
+              <a:rPr sz="2000" b="0">
+                <a:solidFill>
+                  <a:srgbClr val="2B2D42"/>
+                </a:solidFill>
+                <a:latin typeface="Patrick Hand"/>
+              </a:rPr>
+              <a:t>Target papers are not ahead of control in middle layers; the +0.21 gap is at the end.</a:t>
+            </a:r>
+          </a:p>
+        </p:txBody>
+      </p:sp>
+      <p:sp>
+        <p:nvSpPr>
+          <p:cNvPr id="10" name="TextBox 9"/>
+          <p:cNvSpPr txBox="1"/>
+          <p:nvPr/>
+        </p:nvSpPr>
+        <p:spPr>
+          <a:xfrm>
+            <a:off x="822960" y="3849624"/>
+            <a:ext cx="2834640" cy="777240"/>
+          </a:xfrm>
+          <a:prstGeom prst="rect">
+            <a:avLst/>
+          </a:prstGeom>
+          <a:noFill/>
+        </p:spPr>
+        <p:txBody>
+          <a:bodyPr wrap="square" lIns="0" rIns="0" tIns="0" bIns="0" anchor="t">
+            <a:spAutoFit/>
+          </a:bodyPr>
+          <a:lstStyle/>
+          <a:p>
+            <a:pPr algn="l">
+              <a:spcAft>
+                <a:spcPts val="800"/>
+              </a:spcAft>
+            </a:pPr>
+            <a:r>
+              <a:rPr sz="2800" b="1">
+                <a:solidFill>
+                  <a:srgbClr val="3C8D5A"/>
+                </a:solidFill>
+                <a:latin typeface="Caveat"/>
+              </a:rPr>
+              <a:t>Real knowledge</a:t>
+            </a:r>
+          </a:p>
+        </p:txBody>
+      </p:sp>
+      <p:sp>
+        <p:nvSpPr>
+          <p:cNvPr id="11" name="TextBox 10"/>
+          <p:cNvSpPr txBox="1"/>
+          <p:nvPr/>
+        </p:nvSpPr>
+        <p:spPr>
+          <a:xfrm>
+            <a:off x="3657600" y="3941063"/>
+            <a:ext cx="7863840" cy="777240"/>
+          </a:xfrm>
+          <a:prstGeom prst="rect">
+            <a:avLst/>
+          </a:prstGeom>
+          <a:noFill/>
+        </p:spPr>
+        <p:txBody>
+          <a:bodyPr wrap="square" lIns="0" rIns="0" tIns="0" bIns="0" anchor="t">
+            <a:spAutoFit/>
+          </a:bodyPr>
+          <a:lstStyle/>
+          <a:p>
+            <a:pPr algn="l">
+              <a:spcAft>
+                <a:spcPts val="800"/>
+              </a:spcAft>
+            </a:pPr>
+            <a:r>
+              <a:rPr sz="2000" b="0">
+                <a:solidFill>
+                  <a:srgbClr val="2B2D42"/>
+                </a:solidFill>
+                <a:latin typeface="Patrick Hand"/>
+              </a:rPr>
+              <a:t>Name prior is ~1/3 of the gap overall but ~0 on surnames; the rest is paper-specific and grows with citations.</a:t>
+            </a:r>
+          </a:p>
+        </p:txBody>
+      </p:sp>
+      <p:sp>
+        <p:nvSpPr>
+          <p:cNvPr id="12" name="TextBox 11"/>
+          <p:cNvSpPr txBox="1"/>
+          <p:nvPr/>
+        </p:nvSpPr>
+        <p:spPr>
+          <a:xfrm>
+            <a:off x="822960" y="4690872"/>
+            <a:ext cx="2834640" cy="777240"/>
+          </a:xfrm>
+          <a:prstGeom prst="rect">
+            <a:avLst/>
+          </a:prstGeom>
+          <a:noFill/>
+        </p:spPr>
+        <p:txBody>
+          <a:bodyPr wrap="square" lIns="0" rIns="0" tIns="0" bIns="0" anchor="t">
+            <a:spAutoFit/>
+          </a:bodyPr>
+          <a:lstStyle/>
+          <a:p>
+            <a:pPr algn="l">
+              <a:spcAft>
+                <a:spcPts val="800"/>
+              </a:spcAft>
+            </a:pPr>
+            <a:r>
+              <a:rPr sz="2800" b="1">
+                <a:solidFill>
+                  <a:srgbClr val="2B2D42"/>
+                </a:solidFill>
+                <a:latin typeface="Caveat"/>
+              </a:rPr>
+              <a:t>Lenses agree</a:t>
+            </a:r>
+          </a:p>
+        </p:txBody>
+      </p:sp>
+      <p:sp>
+        <p:nvSpPr>
+          <p:cNvPr id="13" name="TextBox 12"/>
+          <p:cNvSpPr txBox="1"/>
+          <p:nvPr/>
+        </p:nvSpPr>
+        <p:spPr>
+          <a:xfrm>
+            <a:off x="3657600" y="4782312"/>
+            <a:ext cx="7863840" cy="777240"/>
+          </a:xfrm>
+          <a:prstGeom prst="rect">
+            <a:avLst/>
+          </a:prstGeom>
+          <a:noFill/>
+        </p:spPr>
+        <p:txBody>
+          <a:bodyPr wrap="square" lIns="0" rIns="0" tIns="0" bIns="0" anchor="t">
+            <a:spAutoFit/>
+          </a:bodyPr>
+          <a:lstStyle/>
+          <a:p>
+            <a:pPr algn="l">
+              <a:spcAft>
+                <a:spcPts val="800"/>
+              </a:spcAft>
+            </a:pPr>
+            <a:r>
+              <a:rPr sz="2000" b="0">
+                <a:solidFill>
+                  <a:srgbClr val="2B2D42"/>
+                </a:solidFill>
+                <a:latin typeface="Patrick Hand"/>
+              </a:rPr>
+              <a:t>Jacobian lenses read more in middle layers, but nothing target-specific.</a:t>
+            </a:r>
+          </a:p>
+        </p:txBody>
+      </p:sp>
+      <p:sp>
+        <p:nvSpPr>
+          <p:cNvPr id="14" name="TextBox 13"/>
+          <p:cNvSpPr txBox="1"/>
+          <p:nvPr/>
+        </p:nvSpPr>
+        <p:spPr>
+          <a:xfrm>
+            <a:off x="822960" y="5532120"/>
+            <a:ext cx="2834640" cy="777240"/>
+          </a:xfrm>
+          <a:prstGeom prst="rect">
+            <a:avLst/>
+          </a:prstGeom>
+          <a:noFill/>
+        </p:spPr>
+        <p:txBody>
+          <a:bodyPr wrap="square" lIns="0" rIns="0" tIns="0" bIns="0" anchor="t">
+            <a:spAutoFit/>
+          </a:bodyPr>
+          <a:lstStyle/>
+          <a:p>
+            <a:pPr algn="l">
+              <a:spcAft>
+                <a:spcPts val="800"/>
+              </a:spcAft>
+            </a:pPr>
+            <a:r>
+              <a:rPr sz="2800" b="1">
+                <a:solidFill>
+                  <a:srgbClr val="E07A2F"/>
+                </a:solidFill>
+                <a:latin typeface="Caveat"/>
+              </a:rPr>
+              <a:t>Name format</a:t>
+            </a:r>
+          </a:p>
+        </p:txBody>
+      </p:sp>
+      <p:sp>
+        <p:nvSpPr>
+          <p:cNvPr id="15" name="TextBox 14"/>
+          <p:cNvSpPr txBox="1"/>
+          <p:nvPr/>
+        </p:nvSpPr>
+        <p:spPr>
+          <a:xfrm>
+            <a:off x="3657600" y="5623560"/>
+            <a:ext cx="7863840" cy="777240"/>
+          </a:xfrm>
+          <a:prstGeom prst="rect">
+            <a:avLst/>
+          </a:prstGeom>
+          <a:noFill/>
+        </p:spPr>
+        <p:txBody>
+          <a:bodyPr wrap="square" lIns="0" rIns="0" tIns="0" bIns="0" anchor="t">
+            <a:spAutoFit/>
+          </a:bodyPr>
+          <a:lstStyle/>
+          <a:p>
+            <a:pPr algn="l">
+              <a:spcAft>
+                <a:spcPts val="800"/>
+              </a:spcAft>
+            </a:pPr>
+            <a:r>
+              <a:rPr sz="2000" b="0">
+                <a:solidFill>
+                  <a:srgbClr val="2B2D42"/>
+                </a:solidFill>
+                <a:latin typeface="Patrick Hand"/>
+              </a:rPr>
+              <a:t>Initials carry little; full given names carry as much as surnames and help predict them.</a:t>
+            </a:r>
+          </a:p>
+        </p:txBody>
+      </p:sp>
+    </p:spTree>
+  </p:cSld>
+  <p:clrMapOvr>
+    <a:masterClrMapping/>
+  </p:clrMapOvr>
+</p:sld>
+</file>
+
+<file path=ppt/slides/slide23.xml><?xml version="1.0" encoding="utf-8"?>
 <p:sld xmlns:a="http://schemas.openxmlformats.org/drawingml/2006/main" xmlns:p="http://schemas.openxmlformats.org/presentationml/2006/main" xmlns:r="http://schemas.openxmlformats.org/officeDocument/2006/relationships">
   <p:cSld>
     <p:spTree>

</xml_diff>

<commit_message>
Stage labels everywhere: STAGES.md overview, per-stage READMEs, [Stage X] tags in report and talk; R0-only sensitivity (Stage 10 + 11)
</commit_message>
<xml_diff>
--- a/experiment_files/351_stage10/reports/talk/Stage10_author_readout_talk.pptx
+++ b/experiment_files/351_stage10/reports/talk/Stage10_author_readout_talk.pptx
@@ -1296,7 +1296,7 @@
           <a:lstStyle/>
           <a:p>
             <a:r>
-              <a:t>Earlier labels: for about half of the papers the model cannot write the authors when asked openly, but picks the true author list in a 4-option multiple choice. We call these target papers. Control papers: cannot write, cannot pick. If recognition is already computed in middle layers, a lens should read the right names better for target than control there.</a:t>
+              <a:t>Earlier labels: for about half of the papers the model cannot write the author list when asked openly (R0: no true author, or R1: a few right but HR2 above 0.5), but picks the true author list in a 4-option multiple choice. We call these target papers. Control papers: cannot write, cannot pick. If recognition is already computed in middle layers, a lens should read the right names better for target than control there.</a:t>
             </a:r>
           </a:p>
         </p:txBody>
@@ -2206,7 +2206,7 @@
           <a:lstStyle/>
           <a:p>
             <a:r>
-              <a:t>Key slide. Target minus control within citation bins. Left: true title only - middle layers are even slightly negative for the Jacobian lens. Right: title-specific part - about zero until L56, then +0.21 to +0.23 at L62 and the output. The target advantage is late and almost entirely title-specific.</a:t>
+              <a:t>Key slide. Target minus control within citation bins. Left: true title only - middle layers are even slightly negative for the Jacobian lens. Right: title-specific part - about zero until L56, then +0.21 to +0.23 at L62 and the output. Robustness: 11 percent of target papers are R1 (a few authors right) against 1.5 percent of controls; keeping R0 papers only in both groups, the output difference is +0.199 instead of +0.207 and every layer looks the same, and the Stage 11 curves do not change either. The target advantage is late and almost entirely title-specific.</a:t>
             </a:r>
           </a:p>
         </p:txBody>
@@ -5697,6 +5697,63 @@
           </a:p>
         </p:txBody>
       </p:sp>
+      <p:sp>
+        <p:nvSpPr>
+          <p:cNvPr id="7" name="Rounded Rectangle 6"/>
+          <p:cNvSpPr/>
+          <p:nvPr/>
+        </p:nvSpPr>
+        <p:spPr>
+          <a:xfrm>
+            <a:off x="10241280" y="182880"/>
+            <a:ext cx="1691640" cy="384048"/>
+          </a:xfrm>
+          <a:prstGeom prst="roundRect">
+            <a:avLst>
+              <a:gd name="adj" fmla="val 30000"/>
+            </a:avLst>
+          </a:prstGeom>
+          <a:solidFill>
+            <a:srgbClr val="FFFFFF"/>
+          </a:solidFill>
+          <a:ln w="22225">
+            <a:solidFill>
+              <a:srgbClr val="3A6EA5"/>
+            </a:solidFill>
+          </a:ln>
+          <a:effectLst/>
+        </p:spPr>
+        <p:style>
+          <a:lnRef idx="1">
+            <a:schemeClr val="accent1"/>
+          </a:lnRef>
+          <a:fillRef idx="3">
+            <a:schemeClr val="accent1"/>
+          </a:fillRef>
+          <a:effectRef idx="2">
+            <a:schemeClr val="accent1"/>
+          </a:effectRef>
+          <a:fontRef idx="minor">
+            <a:schemeClr val="lt1"/>
+          </a:fontRef>
+        </p:style>
+        <p:txBody>
+          <a:bodyPr rtlCol="0" anchor="ctr" lIns="0" rIns="0" tIns="0" bIns="0"/>
+          <a:lstStyle/>
+          <a:p>
+            <a:pPr algn="ctr"/>
+            <a:r>
+              <a:rPr sz="1500" b="1">
+                <a:solidFill>
+                  <a:srgbClr val="3A6EA5"/>
+                </a:solidFill>
+                <a:latin typeface="Patrick Hand"/>
+              </a:rPr>
+              <a:t>Stage 10</a:t>
+            </a:r>
+          </a:p>
+        </p:txBody>
+      </p:sp>
     </p:spTree>
   </p:cSld>
   <p:clrMapOvr>
@@ -6152,6 +6209,63 @@
           </a:p>
         </p:txBody>
       </p:sp>
+      <p:sp>
+        <p:nvSpPr>
+          <p:cNvPr id="10" name="Rounded Rectangle 9"/>
+          <p:cNvSpPr/>
+          <p:nvPr/>
+        </p:nvSpPr>
+        <p:spPr>
+          <a:xfrm>
+            <a:off x="10241280" y="182880"/>
+            <a:ext cx="1691640" cy="384048"/>
+          </a:xfrm>
+          <a:prstGeom prst="roundRect">
+            <a:avLst>
+              <a:gd name="adj" fmla="val 30000"/>
+            </a:avLst>
+          </a:prstGeom>
+          <a:solidFill>
+            <a:srgbClr val="FFFFFF"/>
+          </a:solidFill>
+          <a:ln w="22225">
+            <a:solidFill>
+              <a:srgbClr val="E07A2F"/>
+            </a:solidFill>
+          </a:ln>
+          <a:effectLst/>
+        </p:spPr>
+        <p:style>
+          <a:lnRef idx="1">
+            <a:schemeClr val="accent1"/>
+          </a:lnRef>
+          <a:fillRef idx="3">
+            <a:schemeClr val="accent1"/>
+          </a:fillRef>
+          <a:effectRef idx="2">
+            <a:schemeClr val="accent1"/>
+          </a:effectRef>
+          <a:fontRef idx="minor">
+            <a:schemeClr val="lt1"/>
+          </a:fontRef>
+        </p:style>
+        <p:txBody>
+          <a:bodyPr rtlCol="0" anchor="ctr" lIns="0" rIns="0" tIns="0" bIns="0"/>
+          <a:lstStyle/>
+          <a:p>
+            <a:pPr algn="ctr"/>
+            <a:r>
+              <a:rPr sz="1500" b="1">
+                <a:solidFill>
+                  <a:srgbClr val="E07A2F"/>
+                </a:solidFill>
+                <a:latin typeface="Patrick Hand"/>
+              </a:rPr>
+              <a:t>Stage 11</a:t>
+            </a:r>
+          </a:p>
+        </p:txBody>
+      </p:sp>
     </p:spTree>
   </p:cSld>
   <p:clrMapOvr>
@@ -6414,6 +6528,63 @@
           </a:p>
         </p:txBody>
       </p:sp>
+      <p:sp>
+        <p:nvSpPr>
+          <p:cNvPr id="7" name="Rounded Rectangle 6"/>
+          <p:cNvSpPr/>
+          <p:nvPr/>
+        </p:nvSpPr>
+        <p:spPr>
+          <a:xfrm>
+            <a:off x="10241280" y="182880"/>
+            <a:ext cx="1691640" cy="384048"/>
+          </a:xfrm>
+          <a:prstGeom prst="roundRect">
+            <a:avLst>
+              <a:gd name="adj" fmla="val 30000"/>
+            </a:avLst>
+          </a:prstGeom>
+          <a:solidFill>
+            <a:srgbClr val="FFFFFF"/>
+          </a:solidFill>
+          <a:ln w="22225">
+            <a:solidFill>
+              <a:srgbClr val="E07A2F"/>
+            </a:solidFill>
+          </a:ln>
+          <a:effectLst/>
+        </p:spPr>
+        <p:style>
+          <a:lnRef idx="1">
+            <a:schemeClr val="accent1"/>
+          </a:lnRef>
+          <a:fillRef idx="3">
+            <a:schemeClr val="accent1"/>
+          </a:fillRef>
+          <a:effectRef idx="2">
+            <a:schemeClr val="accent1"/>
+          </a:effectRef>
+          <a:fontRef idx="minor">
+            <a:schemeClr val="lt1"/>
+          </a:fontRef>
+        </p:style>
+        <p:txBody>
+          <a:bodyPr rtlCol="0" anchor="ctr" lIns="0" rIns="0" tIns="0" bIns="0"/>
+          <a:lstStyle/>
+          <a:p>
+            <a:pPr algn="ctr"/>
+            <a:r>
+              <a:rPr sz="1500" b="1">
+                <a:solidFill>
+                  <a:srgbClr val="E07A2F"/>
+                </a:solidFill>
+                <a:latin typeface="Patrick Hand"/>
+              </a:rPr>
+              <a:t>Stage 11</a:t>
+            </a:r>
+          </a:p>
+        </p:txBody>
+      </p:sp>
     </p:spTree>
   </p:cSld>
   <p:clrMapOvr>
@@ -6719,6 +6890,63 @@
           </a:p>
         </p:txBody>
       </p:sp>
+      <p:sp>
+        <p:nvSpPr>
+          <p:cNvPr id="7" name="Rounded Rectangle 6"/>
+          <p:cNvSpPr/>
+          <p:nvPr/>
+        </p:nvSpPr>
+        <p:spPr>
+          <a:xfrm>
+            <a:off x="10241280" y="182880"/>
+            <a:ext cx="1691640" cy="384048"/>
+          </a:xfrm>
+          <a:prstGeom prst="roundRect">
+            <a:avLst>
+              <a:gd name="adj" fmla="val 30000"/>
+            </a:avLst>
+          </a:prstGeom>
+          <a:solidFill>
+            <a:srgbClr val="FFFFFF"/>
+          </a:solidFill>
+          <a:ln w="22225">
+            <a:solidFill>
+              <a:srgbClr val="E07A2F"/>
+            </a:solidFill>
+          </a:ln>
+          <a:effectLst/>
+        </p:spPr>
+        <p:style>
+          <a:lnRef idx="1">
+            <a:schemeClr val="accent1"/>
+          </a:lnRef>
+          <a:fillRef idx="3">
+            <a:schemeClr val="accent1"/>
+          </a:fillRef>
+          <a:effectRef idx="2">
+            <a:schemeClr val="accent1"/>
+          </a:effectRef>
+          <a:fontRef idx="minor">
+            <a:schemeClr val="lt1"/>
+          </a:fontRef>
+        </p:style>
+        <p:txBody>
+          <a:bodyPr rtlCol="0" anchor="ctr" lIns="0" rIns="0" tIns="0" bIns="0"/>
+          <a:lstStyle/>
+          <a:p>
+            <a:pPr algn="ctr"/>
+            <a:r>
+              <a:rPr sz="1500" b="1">
+                <a:solidFill>
+                  <a:srgbClr val="E07A2F"/>
+                </a:solidFill>
+                <a:latin typeface="Patrick Hand"/>
+              </a:rPr>
+              <a:t>Stage 11</a:t>
+            </a:r>
+          </a:p>
+        </p:txBody>
+      </p:sp>
     </p:spTree>
   </p:cSld>
   <p:clrMapOvr>
@@ -6972,6 +7200,63 @@
           </a:p>
         </p:txBody>
       </p:sp>
+      <p:sp>
+        <p:nvSpPr>
+          <p:cNvPr id="7" name="Rounded Rectangle 6"/>
+          <p:cNvSpPr/>
+          <p:nvPr/>
+        </p:nvSpPr>
+        <p:spPr>
+          <a:xfrm>
+            <a:off x="10241280" y="182880"/>
+            <a:ext cx="1691640" cy="384048"/>
+          </a:xfrm>
+          <a:prstGeom prst="roundRect">
+            <a:avLst>
+              <a:gd name="adj" fmla="val 30000"/>
+            </a:avLst>
+          </a:prstGeom>
+          <a:solidFill>
+            <a:srgbClr val="FFFFFF"/>
+          </a:solidFill>
+          <a:ln w="22225">
+            <a:solidFill>
+              <a:srgbClr val="E07A2F"/>
+            </a:solidFill>
+          </a:ln>
+          <a:effectLst/>
+        </p:spPr>
+        <p:style>
+          <a:lnRef idx="1">
+            <a:schemeClr val="accent1"/>
+          </a:lnRef>
+          <a:fillRef idx="3">
+            <a:schemeClr val="accent1"/>
+          </a:fillRef>
+          <a:effectRef idx="2">
+            <a:schemeClr val="accent1"/>
+          </a:effectRef>
+          <a:fontRef idx="minor">
+            <a:schemeClr val="lt1"/>
+          </a:fontRef>
+        </p:style>
+        <p:txBody>
+          <a:bodyPr rtlCol="0" anchor="ctr" lIns="0" rIns="0" tIns="0" bIns="0"/>
+          <a:lstStyle/>
+          <a:p>
+            <a:pPr algn="ctr"/>
+            <a:r>
+              <a:rPr sz="1500" b="1">
+                <a:solidFill>
+                  <a:srgbClr val="E07A2F"/>
+                </a:solidFill>
+                <a:latin typeface="Patrick Hand"/>
+              </a:rPr>
+              <a:t>Stage 11</a:t>
+            </a:r>
+          </a:p>
+        </p:txBody>
+      </p:sp>
     </p:spTree>
   </p:cSld>
   <p:clrMapOvr>
@@ -7286,6 +7571,63 @@
           </a:p>
         </p:txBody>
       </p:sp>
+      <p:sp>
+        <p:nvSpPr>
+          <p:cNvPr id="7" name="Rounded Rectangle 6"/>
+          <p:cNvSpPr/>
+          <p:nvPr/>
+        </p:nvSpPr>
+        <p:spPr>
+          <a:xfrm>
+            <a:off x="10241280" y="182880"/>
+            <a:ext cx="1691640" cy="384048"/>
+          </a:xfrm>
+          <a:prstGeom prst="roundRect">
+            <a:avLst>
+              <a:gd name="adj" fmla="val 30000"/>
+            </a:avLst>
+          </a:prstGeom>
+          <a:solidFill>
+            <a:srgbClr val="FFFFFF"/>
+          </a:solidFill>
+          <a:ln w="22225">
+            <a:solidFill>
+              <a:srgbClr val="3C8D5A"/>
+            </a:solidFill>
+          </a:ln>
+          <a:effectLst/>
+        </p:spPr>
+        <p:style>
+          <a:lnRef idx="1">
+            <a:schemeClr val="accent1"/>
+          </a:lnRef>
+          <a:fillRef idx="3">
+            <a:schemeClr val="accent1"/>
+          </a:fillRef>
+          <a:effectRef idx="2">
+            <a:schemeClr val="accent1"/>
+          </a:effectRef>
+          <a:fontRef idx="minor">
+            <a:schemeClr val="lt1"/>
+          </a:fontRef>
+        </p:style>
+        <p:txBody>
+          <a:bodyPr rtlCol="0" anchor="ctr" lIns="0" rIns="0" tIns="0" bIns="0"/>
+          <a:lstStyle/>
+          <a:p>
+            <a:pPr algn="ctr"/>
+            <a:r>
+              <a:rPr sz="1500" b="1">
+                <a:solidFill>
+                  <a:srgbClr val="3C8D5A"/>
+                </a:solidFill>
+                <a:latin typeface="Patrick Hand"/>
+              </a:rPr>
+              <a:t>Stage 12</a:t>
+            </a:r>
+          </a:p>
+        </p:txBody>
+      </p:sp>
     </p:spTree>
   </p:cSld>
   <p:clrMapOvr>
@@ -7573,6 +7915,63 @@
           </a:p>
         </p:txBody>
       </p:sp>
+      <p:sp>
+        <p:nvSpPr>
+          <p:cNvPr id="7" name="Rounded Rectangle 6"/>
+          <p:cNvSpPr/>
+          <p:nvPr/>
+        </p:nvSpPr>
+        <p:spPr>
+          <a:xfrm>
+            <a:off x="10241280" y="182880"/>
+            <a:ext cx="1691640" cy="384048"/>
+          </a:xfrm>
+          <a:prstGeom prst="roundRect">
+            <a:avLst>
+              <a:gd name="adj" fmla="val 30000"/>
+            </a:avLst>
+          </a:prstGeom>
+          <a:solidFill>
+            <a:srgbClr val="FFFFFF"/>
+          </a:solidFill>
+          <a:ln w="22225">
+            <a:solidFill>
+              <a:srgbClr val="3C8D5A"/>
+            </a:solidFill>
+          </a:ln>
+          <a:effectLst/>
+        </p:spPr>
+        <p:style>
+          <a:lnRef idx="1">
+            <a:schemeClr val="accent1"/>
+          </a:lnRef>
+          <a:fillRef idx="3">
+            <a:schemeClr val="accent1"/>
+          </a:fillRef>
+          <a:effectRef idx="2">
+            <a:schemeClr val="accent1"/>
+          </a:effectRef>
+          <a:fontRef idx="minor">
+            <a:schemeClr val="lt1"/>
+          </a:fontRef>
+        </p:style>
+        <p:txBody>
+          <a:bodyPr rtlCol="0" anchor="ctr" lIns="0" rIns="0" tIns="0" bIns="0"/>
+          <a:lstStyle/>
+          <a:p>
+            <a:pPr algn="ctr"/>
+            <a:r>
+              <a:rPr sz="1500" b="1">
+                <a:solidFill>
+                  <a:srgbClr val="3C8D5A"/>
+                </a:solidFill>
+                <a:latin typeface="Patrick Hand"/>
+              </a:rPr>
+              <a:t>Stage 12</a:t>
+            </a:r>
+          </a:p>
+        </p:txBody>
+      </p:sp>
     </p:spTree>
   </p:cSld>
   <p:clrMapOvr>
@@ -7817,6 +8216,63 @@
           </a:p>
         </p:txBody>
       </p:sp>
+      <p:sp>
+        <p:nvSpPr>
+          <p:cNvPr id="7" name="Rounded Rectangle 6"/>
+          <p:cNvSpPr/>
+          <p:nvPr/>
+        </p:nvSpPr>
+        <p:spPr>
+          <a:xfrm>
+            <a:off x="10241280" y="182880"/>
+            <a:ext cx="1691640" cy="384048"/>
+          </a:xfrm>
+          <a:prstGeom prst="roundRect">
+            <a:avLst>
+              <a:gd name="adj" fmla="val 30000"/>
+            </a:avLst>
+          </a:prstGeom>
+          <a:solidFill>
+            <a:srgbClr val="FFFFFF"/>
+          </a:solidFill>
+          <a:ln w="22225">
+            <a:solidFill>
+              <a:srgbClr val="3A6EA5"/>
+            </a:solidFill>
+          </a:ln>
+          <a:effectLst/>
+        </p:spPr>
+        <p:style>
+          <a:lnRef idx="1">
+            <a:schemeClr val="accent1"/>
+          </a:lnRef>
+          <a:fillRef idx="3">
+            <a:schemeClr val="accent1"/>
+          </a:fillRef>
+          <a:effectRef idx="2">
+            <a:schemeClr val="accent1"/>
+          </a:effectRef>
+          <a:fontRef idx="minor">
+            <a:schemeClr val="lt1"/>
+          </a:fontRef>
+        </p:style>
+        <p:txBody>
+          <a:bodyPr rtlCol="0" anchor="ctr" lIns="0" rIns="0" tIns="0" bIns="0"/>
+          <a:lstStyle/>
+          <a:p>
+            <a:pPr algn="ctr"/>
+            <a:r>
+              <a:rPr sz="1500" b="1">
+                <a:solidFill>
+                  <a:srgbClr val="3A6EA5"/>
+                </a:solidFill>
+                <a:latin typeface="Patrick Hand"/>
+              </a:rPr>
+              <a:t>Stage 10</a:t>
+            </a:r>
+          </a:p>
+        </p:txBody>
+      </p:sp>
     </p:spTree>
   </p:cSld>
   <p:clrMapOvr>
@@ -8070,6 +8526,63 @@
           </a:p>
         </p:txBody>
       </p:sp>
+      <p:sp>
+        <p:nvSpPr>
+          <p:cNvPr id="7" name="Rounded Rectangle 6"/>
+          <p:cNvSpPr/>
+          <p:nvPr/>
+        </p:nvSpPr>
+        <p:spPr>
+          <a:xfrm>
+            <a:off x="10241280" y="182880"/>
+            <a:ext cx="1691640" cy="384048"/>
+          </a:xfrm>
+          <a:prstGeom prst="roundRect">
+            <a:avLst>
+              <a:gd name="adj" fmla="val 30000"/>
+            </a:avLst>
+          </a:prstGeom>
+          <a:solidFill>
+            <a:srgbClr val="FFFFFF"/>
+          </a:solidFill>
+          <a:ln w="22225">
+            <a:solidFill>
+              <a:srgbClr val="3A6EA5"/>
+            </a:solidFill>
+          </a:ln>
+          <a:effectLst/>
+        </p:spPr>
+        <p:style>
+          <a:lnRef idx="1">
+            <a:schemeClr val="accent1"/>
+          </a:lnRef>
+          <a:fillRef idx="3">
+            <a:schemeClr val="accent1"/>
+          </a:fillRef>
+          <a:effectRef idx="2">
+            <a:schemeClr val="accent1"/>
+          </a:effectRef>
+          <a:fontRef idx="minor">
+            <a:schemeClr val="lt1"/>
+          </a:fontRef>
+        </p:style>
+        <p:txBody>
+          <a:bodyPr rtlCol="0" anchor="ctr" lIns="0" rIns="0" tIns="0" bIns="0"/>
+          <a:lstStyle/>
+          <a:p>
+            <a:pPr algn="ctr"/>
+            <a:r>
+              <a:rPr sz="1500" b="1">
+                <a:solidFill>
+                  <a:srgbClr val="3A6EA5"/>
+                </a:solidFill>
+                <a:latin typeface="Patrick Hand"/>
+              </a:rPr>
+              <a:t>Stage 10</a:t>
+            </a:r>
+          </a:p>
+        </p:txBody>
+      </p:sp>
     </p:spTree>
   </p:cSld>
   <p:clrMapOvr>
@@ -8339,6 +8852,63 @@
           </a:p>
         </p:txBody>
       </p:sp>
+      <p:sp>
+        <p:nvSpPr>
+          <p:cNvPr id="7" name="Rounded Rectangle 6"/>
+          <p:cNvSpPr/>
+          <p:nvPr/>
+        </p:nvSpPr>
+        <p:spPr>
+          <a:xfrm>
+            <a:off x="10241280" y="182880"/>
+            <a:ext cx="1691640" cy="384048"/>
+          </a:xfrm>
+          <a:prstGeom prst="roundRect">
+            <a:avLst>
+              <a:gd name="adj" fmla="val 30000"/>
+            </a:avLst>
+          </a:prstGeom>
+          <a:solidFill>
+            <a:srgbClr val="FFFFFF"/>
+          </a:solidFill>
+          <a:ln w="22225">
+            <a:solidFill>
+              <a:srgbClr val="3A6EA5"/>
+            </a:solidFill>
+          </a:ln>
+          <a:effectLst/>
+        </p:spPr>
+        <p:style>
+          <a:lnRef idx="1">
+            <a:schemeClr val="accent1"/>
+          </a:lnRef>
+          <a:fillRef idx="3">
+            <a:schemeClr val="accent1"/>
+          </a:fillRef>
+          <a:effectRef idx="2">
+            <a:schemeClr val="accent1"/>
+          </a:effectRef>
+          <a:fontRef idx="minor">
+            <a:schemeClr val="lt1"/>
+          </a:fontRef>
+        </p:style>
+        <p:txBody>
+          <a:bodyPr rtlCol="0" anchor="ctr" lIns="0" rIns="0" tIns="0" bIns="0"/>
+          <a:lstStyle/>
+          <a:p>
+            <a:pPr algn="ctr"/>
+            <a:r>
+              <a:rPr sz="1500" b="1">
+                <a:solidFill>
+                  <a:srgbClr val="3A6EA5"/>
+                </a:solidFill>
+                <a:latin typeface="Patrick Hand"/>
+              </a:rPr>
+              <a:t>Stage 10</a:t>
+            </a:r>
+          </a:p>
+        </p:txBody>
+      </p:sp>
     </p:spTree>
   </p:cSld>
   <p:clrMapOvr>
@@ -8489,7 +9059,7 @@
                 </a:solidFill>
                 <a:latin typeface="Patrick Hand"/>
               </a:rPr>
-              <a:t>can't write the authors</a:t>
+              <a:t>can't write the list (R0/R1)</a:t>
             </a:r>
           </a:p>
           <a:p>
@@ -8579,7 +9149,7 @@
                 </a:solidFill>
                 <a:latin typeface="Patrick Hand"/>
               </a:rPr>
-              <a:t>can't write the authors</a:t>
+              <a:t>can't write the list (R0/R1)</a:t>
             </a:r>
           </a:p>
           <a:p>
@@ -8746,6 +9316,63 @@
                 <a:latin typeface="Patrick Hand"/>
               </a:rPr>
               <a:t>So: at which layer does target pull ahead of control?</a:t>
+            </a:r>
+          </a:p>
+        </p:txBody>
+      </p:sp>
+      <p:sp>
+        <p:nvSpPr>
+          <p:cNvPr id="8" name="Rounded Rectangle 7"/>
+          <p:cNvSpPr/>
+          <p:nvPr/>
+        </p:nvSpPr>
+        <p:spPr>
+          <a:xfrm>
+            <a:off x="10241280" y="182880"/>
+            <a:ext cx="1691640" cy="384048"/>
+          </a:xfrm>
+          <a:prstGeom prst="roundRect">
+            <a:avLst>
+              <a:gd name="adj" fmla="val 30000"/>
+            </a:avLst>
+          </a:prstGeom>
+          <a:solidFill>
+            <a:srgbClr val="FFFFFF"/>
+          </a:solidFill>
+          <a:ln w="22225">
+            <a:solidFill>
+              <a:srgbClr val="3A6EA5"/>
+            </a:solidFill>
+          </a:ln>
+          <a:effectLst/>
+        </p:spPr>
+        <p:style>
+          <a:lnRef idx="1">
+            <a:schemeClr val="accent1"/>
+          </a:lnRef>
+          <a:fillRef idx="3">
+            <a:schemeClr val="accent1"/>
+          </a:fillRef>
+          <a:effectRef idx="2">
+            <a:schemeClr val="accent1"/>
+          </a:effectRef>
+          <a:fontRef idx="minor">
+            <a:schemeClr val="lt1"/>
+          </a:fontRef>
+        </p:style>
+        <p:txBody>
+          <a:bodyPr rtlCol="0" anchor="ctr" lIns="0" rIns="0" tIns="0" bIns="0"/>
+          <a:lstStyle/>
+          <a:p>
+            <a:pPr algn="ctr"/>
+            <a:r>
+              <a:rPr sz="1500" b="1">
+                <a:solidFill>
+                  <a:srgbClr val="3A6EA5"/>
+                </a:solidFill>
+                <a:latin typeface="Patrick Hand"/>
+              </a:rPr>
+              <a:t>Stage 10</a:t>
             </a:r>
           </a:p>
         </p:txBody>
@@ -8987,6 +9614,63 @@
           </a:p>
         </p:txBody>
       </p:sp>
+      <p:sp>
+        <p:nvSpPr>
+          <p:cNvPr id="7" name="Rounded Rectangle 6"/>
+          <p:cNvSpPr/>
+          <p:nvPr/>
+        </p:nvSpPr>
+        <p:spPr>
+          <a:xfrm>
+            <a:off x="10241280" y="182880"/>
+            <a:ext cx="1691640" cy="384048"/>
+          </a:xfrm>
+          <a:prstGeom prst="roundRect">
+            <a:avLst>
+              <a:gd name="adj" fmla="val 30000"/>
+            </a:avLst>
+          </a:prstGeom>
+          <a:solidFill>
+            <a:srgbClr val="FFFFFF"/>
+          </a:solidFill>
+          <a:ln w="22225">
+            <a:solidFill>
+              <a:srgbClr val="3A6EA5"/>
+            </a:solidFill>
+          </a:ln>
+          <a:effectLst/>
+        </p:spPr>
+        <p:style>
+          <a:lnRef idx="1">
+            <a:schemeClr val="accent1"/>
+          </a:lnRef>
+          <a:fillRef idx="3">
+            <a:schemeClr val="accent1"/>
+          </a:fillRef>
+          <a:effectRef idx="2">
+            <a:schemeClr val="accent1"/>
+          </a:effectRef>
+          <a:fontRef idx="minor">
+            <a:schemeClr val="lt1"/>
+          </a:fontRef>
+        </p:style>
+        <p:txBody>
+          <a:bodyPr rtlCol="0" anchor="ctr" lIns="0" rIns="0" tIns="0" bIns="0"/>
+          <a:lstStyle/>
+          <a:p>
+            <a:pPr algn="ctr"/>
+            <a:r>
+              <a:rPr sz="1500" b="1">
+                <a:solidFill>
+                  <a:srgbClr val="3A6EA5"/>
+                </a:solidFill>
+                <a:latin typeface="Patrick Hand"/>
+              </a:rPr>
+              <a:t>Stage 10</a:t>
+            </a:r>
+          </a:p>
+        </p:txBody>
+      </p:sp>
     </p:spTree>
   </p:cSld>
   <p:clrMapOvr>
@@ -9247,6 +9931,63 @@
           </a:p>
         </p:txBody>
       </p:sp>
+      <p:sp>
+        <p:nvSpPr>
+          <p:cNvPr id="7" name="Rounded Rectangle 6"/>
+          <p:cNvSpPr/>
+          <p:nvPr/>
+        </p:nvSpPr>
+        <p:spPr>
+          <a:xfrm>
+            <a:off x="10241280" y="182880"/>
+            <a:ext cx="1691640" cy="384048"/>
+          </a:xfrm>
+          <a:prstGeom prst="roundRect">
+            <a:avLst>
+              <a:gd name="adj" fmla="val 30000"/>
+            </a:avLst>
+          </a:prstGeom>
+          <a:solidFill>
+            <a:srgbClr val="FFFFFF"/>
+          </a:solidFill>
+          <a:ln w="22225">
+            <a:solidFill>
+              <a:srgbClr val="3A6EA5"/>
+            </a:solidFill>
+          </a:ln>
+          <a:effectLst/>
+        </p:spPr>
+        <p:style>
+          <a:lnRef idx="1">
+            <a:schemeClr val="accent1"/>
+          </a:lnRef>
+          <a:fillRef idx="3">
+            <a:schemeClr val="accent1"/>
+          </a:fillRef>
+          <a:effectRef idx="2">
+            <a:schemeClr val="accent1"/>
+          </a:effectRef>
+          <a:fontRef idx="minor">
+            <a:schemeClr val="lt1"/>
+          </a:fontRef>
+        </p:style>
+        <p:txBody>
+          <a:bodyPr rtlCol="0" anchor="ctr" lIns="0" rIns="0" tIns="0" bIns="0"/>
+          <a:lstStyle/>
+          <a:p>
+            <a:pPr algn="ctr"/>
+            <a:r>
+              <a:rPr sz="1500" b="1">
+                <a:solidFill>
+                  <a:srgbClr val="3A6EA5"/>
+                </a:solidFill>
+                <a:latin typeface="Patrick Hand"/>
+              </a:rPr>
+              <a:t>Stage 10</a:t>
+            </a:r>
+          </a:p>
+        </p:txBody>
+      </p:sp>
     </p:spTree>
   </p:cSld>
   <p:clrMapOvr>
@@ -9454,6 +10195,63 @@
           </a:p>
         </p:txBody>
       </p:sp>
+      <p:sp>
+        <p:nvSpPr>
+          <p:cNvPr id="8" name="Rounded Rectangle 7"/>
+          <p:cNvSpPr/>
+          <p:nvPr/>
+        </p:nvSpPr>
+        <p:spPr>
+          <a:xfrm>
+            <a:off x="10241280" y="182880"/>
+            <a:ext cx="1691640" cy="384048"/>
+          </a:xfrm>
+          <a:prstGeom prst="roundRect">
+            <a:avLst>
+              <a:gd name="adj" fmla="val 30000"/>
+            </a:avLst>
+          </a:prstGeom>
+          <a:solidFill>
+            <a:srgbClr val="FFFFFF"/>
+          </a:solidFill>
+          <a:ln w="22225">
+            <a:solidFill>
+              <a:srgbClr val="3A6EA5"/>
+            </a:solidFill>
+          </a:ln>
+          <a:effectLst/>
+        </p:spPr>
+        <p:style>
+          <a:lnRef idx="1">
+            <a:schemeClr val="accent1"/>
+          </a:lnRef>
+          <a:fillRef idx="3">
+            <a:schemeClr val="accent1"/>
+          </a:fillRef>
+          <a:effectRef idx="2">
+            <a:schemeClr val="accent1"/>
+          </a:effectRef>
+          <a:fontRef idx="minor">
+            <a:schemeClr val="lt1"/>
+          </a:fontRef>
+        </p:style>
+        <p:txBody>
+          <a:bodyPr rtlCol="0" anchor="ctr" lIns="0" rIns="0" tIns="0" bIns="0"/>
+          <a:lstStyle/>
+          <a:p>
+            <a:pPr algn="ctr"/>
+            <a:r>
+              <a:rPr sz="1500" b="1">
+                <a:solidFill>
+                  <a:srgbClr val="3A6EA5"/>
+                </a:solidFill>
+                <a:latin typeface="Patrick Hand"/>
+              </a:rPr>
+              <a:t>Stage 10</a:t>
+            </a:r>
+          </a:p>
+        </p:txBody>
+      </p:sp>
     </p:spTree>
   </p:cSld>
   <p:clrMapOvr>
@@ -10326,6 +11124,63 @@
           </a:p>
         </p:txBody>
       </p:sp>
+      <p:sp>
+        <p:nvSpPr>
+          <p:cNvPr id="6" name="Rounded Rectangle 5"/>
+          <p:cNvSpPr/>
+          <p:nvPr/>
+        </p:nvSpPr>
+        <p:spPr>
+          <a:xfrm>
+            <a:off x="10241280" y="182880"/>
+            <a:ext cx="1691640" cy="384048"/>
+          </a:xfrm>
+          <a:prstGeom prst="roundRect">
+            <a:avLst>
+              <a:gd name="adj" fmla="val 30000"/>
+            </a:avLst>
+          </a:prstGeom>
+          <a:solidFill>
+            <a:srgbClr val="FFFFFF"/>
+          </a:solidFill>
+          <a:ln w="22225">
+            <a:solidFill>
+              <a:srgbClr val="3C8D5A"/>
+            </a:solidFill>
+          </a:ln>
+          <a:effectLst/>
+        </p:spPr>
+        <p:style>
+          <a:lnRef idx="1">
+            <a:schemeClr val="accent1"/>
+          </a:lnRef>
+          <a:fillRef idx="3">
+            <a:schemeClr val="accent1"/>
+          </a:fillRef>
+          <a:effectRef idx="2">
+            <a:schemeClr val="accent1"/>
+          </a:effectRef>
+          <a:fontRef idx="minor">
+            <a:schemeClr val="lt1"/>
+          </a:fontRef>
+        </p:style>
+        <p:txBody>
+          <a:bodyPr rtlCol="0" anchor="ctr" lIns="0" rIns="0" tIns="0" bIns="0"/>
+          <a:lstStyle/>
+          <a:p>
+            <a:pPr algn="ctr"/>
+            <a:r>
+              <a:rPr sz="1500" b="1">
+                <a:solidFill>
+                  <a:srgbClr val="3C8D5A"/>
+                </a:solidFill>
+                <a:latin typeface="Patrick Hand"/>
+              </a:rPr>
+              <a:t>Stage 12 plan</a:t>
+            </a:r>
+          </a:p>
+        </p:txBody>
+      </p:sp>
     </p:spTree>
   </p:cSld>
   <p:clrMapOvr>
@@ -11119,6 +11974,63 @@
           </a:p>
         </p:txBody>
       </p:sp>
+      <p:sp>
+        <p:nvSpPr>
+          <p:cNvPr id="15" name="Rounded Rectangle 14"/>
+          <p:cNvSpPr/>
+          <p:nvPr/>
+        </p:nvSpPr>
+        <p:spPr>
+          <a:xfrm>
+            <a:off x="10241280" y="182880"/>
+            <a:ext cx="1691640" cy="384048"/>
+          </a:xfrm>
+          <a:prstGeom prst="roundRect">
+            <a:avLst>
+              <a:gd name="adj" fmla="val 30000"/>
+            </a:avLst>
+          </a:prstGeom>
+          <a:solidFill>
+            <a:srgbClr val="FFFFFF"/>
+          </a:solidFill>
+          <a:ln w="22225">
+            <a:solidFill>
+              <a:srgbClr val="3A6EA5"/>
+            </a:solidFill>
+          </a:ln>
+          <a:effectLst/>
+        </p:spPr>
+        <p:style>
+          <a:lnRef idx="1">
+            <a:schemeClr val="accent1"/>
+          </a:lnRef>
+          <a:fillRef idx="3">
+            <a:schemeClr val="accent1"/>
+          </a:fillRef>
+          <a:effectRef idx="2">
+            <a:schemeClr val="accent1"/>
+          </a:effectRef>
+          <a:fontRef idx="minor">
+            <a:schemeClr val="lt1"/>
+          </a:fontRef>
+        </p:style>
+        <p:txBody>
+          <a:bodyPr rtlCol="0" anchor="ctr" lIns="0" rIns="0" tIns="0" bIns="0"/>
+          <a:lstStyle/>
+          <a:p>
+            <a:pPr algn="ctr"/>
+            <a:r>
+              <a:rPr sz="1500" b="1">
+                <a:solidFill>
+                  <a:srgbClr val="3A6EA5"/>
+                </a:solidFill>
+                <a:latin typeface="Patrick Hand"/>
+              </a:rPr>
+              <a:t>Stage 10</a:t>
+            </a:r>
+          </a:p>
+        </p:txBody>
+      </p:sp>
     </p:spTree>
   </p:cSld>
   <p:clrMapOvr>
@@ -11791,6 +12703,63 @@
           </a:p>
         </p:txBody>
       </p:sp>
+      <p:sp>
+        <p:nvSpPr>
+          <p:cNvPr id="9" name="Rounded Rectangle 8"/>
+          <p:cNvSpPr/>
+          <p:nvPr/>
+        </p:nvSpPr>
+        <p:spPr>
+          <a:xfrm>
+            <a:off x="10241280" y="182880"/>
+            <a:ext cx="1691640" cy="384048"/>
+          </a:xfrm>
+          <a:prstGeom prst="roundRect">
+            <a:avLst>
+              <a:gd name="adj" fmla="val 30000"/>
+            </a:avLst>
+          </a:prstGeom>
+          <a:solidFill>
+            <a:srgbClr val="FFFFFF"/>
+          </a:solidFill>
+          <a:ln w="22225">
+            <a:solidFill>
+              <a:srgbClr val="3A6EA5"/>
+            </a:solidFill>
+          </a:ln>
+          <a:effectLst/>
+        </p:spPr>
+        <p:style>
+          <a:lnRef idx="1">
+            <a:schemeClr val="accent1"/>
+          </a:lnRef>
+          <a:fillRef idx="3">
+            <a:schemeClr val="accent1"/>
+          </a:fillRef>
+          <a:effectRef idx="2">
+            <a:schemeClr val="accent1"/>
+          </a:effectRef>
+          <a:fontRef idx="minor">
+            <a:schemeClr val="lt1"/>
+          </a:fontRef>
+        </p:style>
+        <p:txBody>
+          <a:bodyPr rtlCol="0" anchor="ctr" lIns="0" rIns="0" tIns="0" bIns="0"/>
+          <a:lstStyle/>
+          <a:p>
+            <a:pPr algn="ctr"/>
+            <a:r>
+              <a:rPr sz="1500" b="1">
+                <a:solidFill>
+                  <a:srgbClr val="3A6EA5"/>
+                </a:solidFill>
+                <a:latin typeface="Patrick Hand"/>
+              </a:rPr>
+              <a:t>Stage 10</a:t>
+            </a:r>
+          </a:p>
+        </p:txBody>
+      </p:sp>
     </p:spTree>
   </p:cSld>
   <p:clrMapOvr>
@@ -12474,6 +13443,63 @@
           </a:p>
         </p:txBody>
       </p:sp>
+      <p:sp>
+        <p:nvSpPr>
+          <p:cNvPr id="12" name="Rounded Rectangle 11"/>
+          <p:cNvSpPr/>
+          <p:nvPr/>
+        </p:nvSpPr>
+        <p:spPr>
+          <a:xfrm>
+            <a:off x="10241280" y="182880"/>
+            <a:ext cx="1691640" cy="384048"/>
+          </a:xfrm>
+          <a:prstGeom prst="roundRect">
+            <a:avLst>
+              <a:gd name="adj" fmla="val 30000"/>
+            </a:avLst>
+          </a:prstGeom>
+          <a:solidFill>
+            <a:srgbClr val="FFFFFF"/>
+          </a:solidFill>
+          <a:ln w="22225">
+            <a:solidFill>
+              <a:srgbClr val="3A6EA5"/>
+            </a:solidFill>
+          </a:ln>
+          <a:effectLst/>
+        </p:spPr>
+        <p:style>
+          <a:lnRef idx="1">
+            <a:schemeClr val="accent1"/>
+          </a:lnRef>
+          <a:fillRef idx="3">
+            <a:schemeClr val="accent1"/>
+          </a:fillRef>
+          <a:effectRef idx="2">
+            <a:schemeClr val="accent1"/>
+          </a:effectRef>
+          <a:fontRef idx="minor">
+            <a:schemeClr val="lt1"/>
+          </a:fontRef>
+        </p:style>
+        <p:txBody>
+          <a:bodyPr rtlCol="0" anchor="ctr" lIns="0" rIns="0" tIns="0" bIns="0"/>
+          <a:lstStyle/>
+          <a:p>
+            <a:pPr algn="ctr"/>
+            <a:r>
+              <a:rPr sz="1500" b="1">
+                <a:solidFill>
+                  <a:srgbClr val="3A6EA5"/>
+                </a:solidFill>
+                <a:latin typeface="Patrick Hand"/>
+              </a:rPr>
+              <a:t>Stage 10</a:t>
+            </a:r>
+          </a:p>
+        </p:txBody>
+      </p:sp>
     </p:spTree>
   </p:cSld>
   <p:clrMapOvr>
@@ -12845,6 +13871,63 @@
           </a:p>
         </p:txBody>
       </p:sp>
+      <p:sp>
+        <p:nvSpPr>
+          <p:cNvPr id="8" name="Rounded Rectangle 7"/>
+          <p:cNvSpPr/>
+          <p:nvPr/>
+        </p:nvSpPr>
+        <p:spPr>
+          <a:xfrm>
+            <a:off x="10241280" y="182880"/>
+            <a:ext cx="1691640" cy="384048"/>
+          </a:xfrm>
+          <a:prstGeom prst="roundRect">
+            <a:avLst>
+              <a:gd name="adj" fmla="val 30000"/>
+            </a:avLst>
+          </a:prstGeom>
+          <a:solidFill>
+            <a:srgbClr val="FFFFFF"/>
+          </a:solidFill>
+          <a:ln w="22225">
+            <a:solidFill>
+              <a:srgbClr val="3A6EA5"/>
+            </a:solidFill>
+          </a:ln>
+          <a:effectLst/>
+        </p:spPr>
+        <p:style>
+          <a:lnRef idx="1">
+            <a:schemeClr val="accent1"/>
+          </a:lnRef>
+          <a:fillRef idx="3">
+            <a:schemeClr val="accent1"/>
+          </a:fillRef>
+          <a:effectRef idx="2">
+            <a:schemeClr val="accent1"/>
+          </a:effectRef>
+          <a:fontRef idx="minor">
+            <a:schemeClr val="lt1"/>
+          </a:fontRef>
+        </p:style>
+        <p:txBody>
+          <a:bodyPr rtlCol="0" anchor="ctr" lIns="0" rIns="0" tIns="0" bIns="0"/>
+          <a:lstStyle/>
+          <a:p>
+            <a:pPr algn="ctr"/>
+            <a:r>
+              <a:rPr sz="1500" b="1">
+                <a:solidFill>
+                  <a:srgbClr val="3A6EA5"/>
+                </a:solidFill>
+                <a:latin typeface="Patrick Hand"/>
+              </a:rPr>
+              <a:t>Stage 10</a:t>
+            </a:r>
+          </a:p>
+        </p:txBody>
+      </p:sp>
     </p:spTree>
   </p:cSld>
   <p:clrMapOvr>
@@ -13116,6 +14199,63 @@
           </a:p>
         </p:txBody>
       </p:sp>
+      <p:sp>
+        <p:nvSpPr>
+          <p:cNvPr id="7" name="Rounded Rectangle 6"/>
+          <p:cNvSpPr/>
+          <p:nvPr/>
+        </p:nvSpPr>
+        <p:spPr>
+          <a:xfrm>
+            <a:off x="10241280" y="182880"/>
+            <a:ext cx="1691640" cy="384048"/>
+          </a:xfrm>
+          <a:prstGeom prst="roundRect">
+            <a:avLst>
+              <a:gd name="adj" fmla="val 30000"/>
+            </a:avLst>
+          </a:prstGeom>
+          <a:solidFill>
+            <a:srgbClr val="FFFFFF"/>
+          </a:solidFill>
+          <a:ln w="22225">
+            <a:solidFill>
+              <a:srgbClr val="3A6EA5"/>
+            </a:solidFill>
+          </a:ln>
+          <a:effectLst/>
+        </p:spPr>
+        <p:style>
+          <a:lnRef idx="1">
+            <a:schemeClr val="accent1"/>
+          </a:lnRef>
+          <a:fillRef idx="3">
+            <a:schemeClr val="accent1"/>
+          </a:fillRef>
+          <a:effectRef idx="2">
+            <a:schemeClr val="accent1"/>
+          </a:effectRef>
+          <a:fontRef idx="minor">
+            <a:schemeClr val="lt1"/>
+          </a:fontRef>
+        </p:style>
+        <p:txBody>
+          <a:bodyPr rtlCol="0" anchor="ctr" lIns="0" rIns="0" tIns="0" bIns="0"/>
+          <a:lstStyle/>
+          <a:p>
+            <a:pPr algn="ctr"/>
+            <a:r>
+              <a:rPr sz="1500" b="1">
+                <a:solidFill>
+                  <a:srgbClr val="3A6EA5"/>
+                </a:solidFill>
+                <a:latin typeface="Patrick Hand"/>
+              </a:rPr>
+              <a:t>Stage 10</a:t>
+            </a:r>
+          </a:p>
+        </p:txBody>
+      </p:sp>
     </p:spTree>
   </p:cSld>
   <p:clrMapOvr>
@@ -13396,6 +14536,63 @@
           </a:p>
         </p:txBody>
       </p:sp>
+      <p:sp>
+        <p:nvSpPr>
+          <p:cNvPr id="7" name="Rounded Rectangle 6"/>
+          <p:cNvSpPr/>
+          <p:nvPr/>
+        </p:nvSpPr>
+        <p:spPr>
+          <a:xfrm>
+            <a:off x="10241280" y="182880"/>
+            <a:ext cx="1691640" cy="384048"/>
+          </a:xfrm>
+          <a:prstGeom prst="roundRect">
+            <a:avLst>
+              <a:gd name="adj" fmla="val 30000"/>
+            </a:avLst>
+          </a:prstGeom>
+          <a:solidFill>
+            <a:srgbClr val="FFFFFF"/>
+          </a:solidFill>
+          <a:ln w="22225">
+            <a:solidFill>
+              <a:srgbClr val="3A6EA5"/>
+            </a:solidFill>
+          </a:ln>
+          <a:effectLst/>
+        </p:spPr>
+        <p:style>
+          <a:lnRef idx="1">
+            <a:schemeClr val="accent1"/>
+          </a:lnRef>
+          <a:fillRef idx="3">
+            <a:schemeClr val="accent1"/>
+          </a:fillRef>
+          <a:effectRef idx="2">
+            <a:schemeClr val="accent1"/>
+          </a:effectRef>
+          <a:fontRef idx="minor">
+            <a:schemeClr val="lt1"/>
+          </a:fontRef>
+        </p:style>
+        <p:txBody>
+          <a:bodyPr rtlCol="0" anchor="ctr" lIns="0" rIns="0" tIns="0" bIns="0"/>
+          <a:lstStyle/>
+          <a:p>
+            <a:pPr algn="ctr"/>
+            <a:r>
+              <a:rPr sz="1500" b="1">
+                <a:solidFill>
+                  <a:srgbClr val="3A6EA5"/>
+                </a:solidFill>
+                <a:latin typeface="Patrick Hand"/>
+              </a:rPr>
+              <a:t>Stage 10</a:t>
+            </a:r>
+          </a:p>
+        </p:txBody>
+      </p:sp>
     </p:spTree>
   </p:cSld>
   <p:clrMapOvr>
@@ -13549,7 +14746,7 @@
         <p:spPr>
           <a:xfrm rot="90000">
             <a:off x="9098280" y="1737360"/>
-            <a:ext cx="2651760" cy="3108960"/>
+            <a:ext cx="2651760" cy="3931920"/>
           </a:xfrm>
           <a:prstGeom prst="rect">
             <a:avLst/>
@@ -13588,7 +14785,7 @@
               </a:spcAft>
             </a:pPr>
             <a:r>
-              <a:rPr sz="1900" b="0">
+              <a:rPr sz="1800" b="0">
                 <a:solidFill>
                   <a:srgbClr val="2B2D42"/>
                 </a:solidFill>
@@ -13597,7 +14794,7 @@
               <a:t>Middle layers: </a:t>
             </a:r>
             <a:r>
-              <a:rPr sz="1900" b="1">
+              <a:rPr sz="1800" b="1">
                 <a:solidFill>
                   <a:srgbClr val="2B2D42"/>
                 </a:solidFill>
@@ -13613,7 +14810,7 @@
               </a:spcAft>
             </a:pPr>
             <a:r>
-              <a:rPr sz="1900" b="0">
+              <a:rPr sz="1800" b="0">
                 <a:solidFill>
                   <a:srgbClr val="2B2D42"/>
                 </a:solidFill>
@@ -13629,7 +14826,7 @@
               </a:spcAft>
             </a:pPr>
             <a:r>
-              <a:rPr sz="1900" b="1">
+              <a:rPr sz="1800" b="1">
                 <a:solidFill>
                   <a:srgbClr val="E07A2F"/>
                 </a:solidFill>
@@ -13645,13 +14842,95 @@
               </a:spcAft>
             </a:pPr>
             <a:r>
-              <a:rPr sz="1900" b="0">
+              <a:rPr sz="1800" b="0">
                 <a:solidFill>
                   <a:srgbClr val="2B2D42"/>
                 </a:solidFill>
                 <a:latin typeface="Patrick Hand"/>
               </a:rPr>
               <a:t>almost all title-specific</a:t>
+            </a:r>
+          </a:p>
+          <a:p>
+            <a:pPr algn="l">
+              <a:spcAft>
+                <a:spcPts val="900"/>
+              </a:spcAft>
+            </a:pPr>
+            <a:r>
+              <a:rPr sz="1800" b="1">
+                <a:solidFill>
+                  <a:srgbClr val="2B2D42"/>
+                </a:solidFill>
+                <a:latin typeface="Patrick Hand"/>
+              </a:rPr>
+              <a:t>R0 only</a:t>
+            </a:r>
+            <a:r>
+              <a:rPr sz="1800" b="0">
+                <a:solidFill>
+                  <a:srgbClr val="2B2D42"/>
+                </a:solidFill>
+                <a:latin typeface="Patrick Hand"/>
+              </a:rPr>
+              <a:t> (no author written): output +0.199 vs +0.207</a:t>
+            </a:r>
+          </a:p>
+        </p:txBody>
+      </p:sp>
+      <p:sp>
+        <p:nvSpPr>
+          <p:cNvPr id="7" name="Rounded Rectangle 6"/>
+          <p:cNvSpPr/>
+          <p:nvPr/>
+        </p:nvSpPr>
+        <p:spPr>
+          <a:xfrm>
+            <a:off x="10241280" y="182880"/>
+            <a:ext cx="1691640" cy="384048"/>
+          </a:xfrm>
+          <a:prstGeom prst="roundRect">
+            <a:avLst>
+              <a:gd name="adj" fmla="val 30000"/>
+            </a:avLst>
+          </a:prstGeom>
+          <a:solidFill>
+            <a:srgbClr val="FFFFFF"/>
+          </a:solidFill>
+          <a:ln w="22225">
+            <a:solidFill>
+              <a:srgbClr val="3A6EA5"/>
+            </a:solidFill>
+          </a:ln>
+          <a:effectLst/>
+        </p:spPr>
+        <p:style>
+          <a:lnRef idx="1">
+            <a:schemeClr val="accent1"/>
+          </a:lnRef>
+          <a:fillRef idx="3">
+            <a:schemeClr val="accent1"/>
+          </a:fillRef>
+          <a:effectRef idx="2">
+            <a:schemeClr val="accent1"/>
+          </a:effectRef>
+          <a:fontRef idx="minor">
+            <a:schemeClr val="lt1"/>
+          </a:fontRef>
+        </p:style>
+        <p:txBody>
+          <a:bodyPr rtlCol="0" anchor="ctr" lIns="0" rIns="0" tIns="0" bIns="0"/>
+          <a:lstStyle/>
+          <a:p>
+            <a:pPr algn="ctr"/>
+            <a:r>
+              <a:rPr sz="1500" b="1">
+                <a:solidFill>
+                  <a:srgbClr val="3A6EA5"/>
+                </a:solidFill>
+                <a:latin typeface="Patrick Hand"/>
+              </a:rPr>
+              <a:t>Stage 10</a:t>
             </a:r>
           </a:p>
         </p:txBody>

</xml_diff>

<commit_message>
R0/R1 stratified analysis (Stage 10/11, CPU); deck v8; combined Stage 1-11 report sources
</commit_message>
<xml_diff>
--- a/experiment_files/351_stage10/reports/talk/Stage10_author_readout_talk.pptx
+++ b/experiment_files/351_stage10/reports/talk/Stage10_author_readout_talk.pptx
@@ -17,12 +17,14 @@
     <p:sldId id="267" r:id="rId19"/>
     <p:sldId id="268" r:id="rId20"/>
     <p:sldId id="270" r:id="rId22"/>
+    <p:sldId id="280" r:id="rId32"/>
     <p:sldId id="278" r:id="rId30"/>
     <p:sldId id="279" r:id="rId31"/>
-    <p:sldId id="280" r:id="rId32"/>
+    <p:sldId id="282" r:id="rId34"/>
     <p:sldId id="261" r:id="rId13"/>
     <p:sldId id="262" r:id="rId14"/>
     <p:sldId id="269" r:id="rId21"/>
+    <p:sldId id="281" r:id="rId33"/>
     <p:sldId id="271" r:id="rId23"/>
     <p:sldId id="272" r:id="rId24"/>
     <p:sldId id="273" r:id="rId25"/>
@@ -1672,6 +1674,146 @@
 </file>
 
 <file path=ppt/notesSlides/notesSlide25.xml><?xml version="1.0" encoding="utf-8"?>
+<p:notes xmlns:a="http://schemas.openxmlformats.org/drawingml/2006/main" xmlns:p="http://schemas.openxmlformats.org/presentationml/2006/main" xmlns:r="http://schemas.openxmlformats.org/officeDocument/2006/relationships">
+  <p:cSld>
+    <p:spTree>
+      <p:nvGrpSpPr>
+        <p:cNvPr id="1" name=""/>
+        <p:cNvGrpSpPr/>
+        <p:nvPr/>
+      </p:nvGrpSpPr>
+      <p:grpSpPr>
+        <a:xfrm>
+          <a:off x="0" y="0"/>
+          <a:ext cx="0" cy="0"/>
+          <a:chOff x="0" y="0"/>
+          <a:chExt cx="0" cy="0"/>
+        </a:xfrm>
+      </p:grpSpPr>
+      <p:sp>
+        <p:nvSpPr>
+          <p:cNvPr id="2" name="Slide Image Placeholder 1"/>
+          <p:cNvSpPr>
+            <a:spLocks noGrp="1"/>
+          </p:cNvSpPr>
+          <p:nvPr>
+            <p:ph type="sldImg" idx="2"/>
+          </p:nvPr>
+        </p:nvSpPr>
+        <p:spPr/>
+      </p:sp>
+      <p:sp>
+        <p:nvSpPr>
+          <p:cNvPr id="3" name="Notes Placeholder 2"/>
+          <p:cNvSpPr>
+            <a:spLocks noGrp="1"/>
+          </p:cNvSpPr>
+          <p:nvPr>
+            <p:ph type="body" idx="3" sz="quarter"/>
+          </p:nvPr>
+        </p:nvSpPr>
+        <p:spPr/>
+        <p:txBody>
+          <a:bodyPr/>
+          <a:lstStyle/>
+          <a:p>
+            <a:r>
+              <a:t>Is the target advantage just the R1 papers? Target pools R0 papers, where the open answer named no true author, and R1 papers, where it named a few; 11 percent of target papers are R1 but only 1.5 percent of controls. Left: three views of target minus control within citation bins. R0 only (groups A versus B, the Stage 1 to 9 comparison) gives +0.199 at the output against +0.207 pooled, and the curve has the same shape. R1 target papers against R0 controls give +0.37: they know their papers better, but they also only pull ahead after L52. Control R1 has only 34 papers, so it is described, not tested. Right: Stage 11 patching by recall level; R1 targets (36 papers) recover a little later but are complete by L52. The title-position probe gives the same picture: R0 view +0.02 to +0.04. Conclusion unchanged.</a:t>
+            </a:r>
+          </a:p>
+        </p:txBody>
+      </p:sp>
+      <p:sp>
+        <p:nvSpPr>
+          <p:cNvPr id="4" name="Slide Number Placeholder 3"/>
+          <p:cNvSpPr>
+            <a:spLocks noGrp="1"/>
+          </p:cNvSpPr>
+          <p:nvPr>
+            <p:ph type="sldNum" idx="5" sz="quarter"/>
+          </p:nvPr>
+        </p:nvSpPr>
+        <p:spPr/>
+      </p:sp>
+    </p:spTree>
+  </p:cSld>
+  <p:clrMapOvr>
+    <a:masterClrMapping/>
+  </p:clrMapOvr>
+</p:notes>
+</file>
+
+<file path=ppt/notesSlides/notesSlide26.xml><?xml version="1.0" encoding="utf-8"?>
+<p:notes xmlns:a="http://schemas.openxmlformats.org/drawingml/2006/main" xmlns:p="http://schemas.openxmlformats.org/presentationml/2006/main" xmlns:r="http://schemas.openxmlformats.org/officeDocument/2006/relationships">
+  <p:cSld>
+    <p:spTree>
+      <p:nvGrpSpPr>
+        <p:cNvPr id="1" name=""/>
+        <p:cNvGrpSpPr/>
+        <p:nvPr/>
+      </p:nvGrpSpPr>
+      <p:grpSpPr>
+        <a:xfrm>
+          <a:off x="0" y="0"/>
+          <a:ext cx="0" cy="0"/>
+          <a:chOff x="0" y="0"/>
+          <a:chExt cx="0" cy="0"/>
+        </a:xfrm>
+      </p:grpSpPr>
+      <p:sp>
+        <p:nvSpPr>
+          <p:cNvPr id="2" name="Slide Image Placeholder 1"/>
+          <p:cNvSpPr>
+            <a:spLocks noGrp="1"/>
+          </p:cNvSpPr>
+          <p:nvPr>
+            <p:ph type="sldImg" idx="2"/>
+          </p:nvPr>
+        </p:nvSpPr>
+        <p:spPr/>
+      </p:sp>
+      <p:sp>
+        <p:nvSpPr>
+          <p:cNvPr id="3" name="Notes Placeholder 2"/>
+          <p:cNvSpPr>
+            <a:spLocks noGrp="1"/>
+          </p:cNvSpPr>
+          <p:nvPr>
+            <p:ph type="body" idx="3" sz="quarter"/>
+          </p:nvPr>
+        </p:nvSpPr>
+        <p:spPr/>
+        <p:txBody>
+          <a:bodyPr/>
+          <a:lstStyle/>
+          <a:p>
+            <a:r>
+              <a:t>Inside R1 papers the open answer got some authors right and missed others. The label package only counts matches, so we rebuilt which authors matched; the rebuilt count equals the package count for 99.3 percent of R1 papers. In 495 papers with both kinds, the authors the model wrote correctly carry more title-specific signal at the output, +0.20, and the same holds without first authors. But the difference is zero up to L52 and grows from L54: even for authors the model actually produces, the paper-specific signal appears only in the last layers. They are also somewhat easier to guess without a title, +0.10.</a:t>
+            </a:r>
+          </a:p>
+        </p:txBody>
+      </p:sp>
+      <p:sp>
+        <p:nvSpPr>
+          <p:cNvPr id="4" name="Slide Number Placeholder 3"/>
+          <p:cNvSpPr>
+            <a:spLocks noGrp="1"/>
+          </p:cNvSpPr>
+          <p:nvPr>
+            <p:ph type="sldNum" idx="5" sz="quarter"/>
+          </p:nvPr>
+        </p:nvSpPr>
+        <p:spPr/>
+      </p:sp>
+    </p:spTree>
+  </p:cSld>
+  <p:clrMapOvr>
+    <a:masterClrMapping/>
+  </p:clrMapOvr>
+</p:notes>
+</file>
+
+<file path=ppt/notesSlides/notesSlide27.xml><?xml version="1.0" encoding="utf-8"?>
 <p:notes xmlns:a="http://schemas.openxmlformats.org/drawingml/2006/main" xmlns:p="http://schemas.openxmlformats.org/presentationml/2006/main" xmlns:r="http://schemas.openxmlformats.org/officeDocument/2006/relationships">
   <p:cSld>
     <p:spTree>
@@ -7592,7 +7734,7 @@
           </a:solidFill>
           <a:ln w="22225">
             <a:solidFill>
-              <a:srgbClr val="3C8D5A"/>
+              <a:srgbClr val="E07A2F"/>
             </a:solidFill>
           </a:ln>
           <a:effectLst/>
@@ -7619,11 +7761,11 @@
             <a:r>
               <a:rPr sz="1500" b="1">
                 <a:solidFill>
-                  <a:srgbClr val="3C8D5A"/>
-                </a:solidFill>
-                <a:latin typeface="Patrick Hand"/>
-              </a:rPr>
-              <a:t>Stage 12</a:t>
+                  <a:srgbClr val="E07A2F"/>
+                </a:solidFill>
+                <a:latin typeface="Patrick Hand"/>
+              </a:rPr>
+              <a:t>Stage 11</a:t>
             </a:r>
           </a:p>
         </p:txBody>
@@ -11190,6 +11332,674 @@
 </file>
 
 <file path=ppt/slides/slide25.xml><?xml version="1.0" encoding="utf-8"?>
+<p:sld xmlns:a="http://schemas.openxmlformats.org/drawingml/2006/main" xmlns:p="http://schemas.openxmlformats.org/presentationml/2006/main" xmlns:r="http://schemas.openxmlformats.org/officeDocument/2006/relationships">
+  <p:cSld>
+    <p:spTree>
+      <p:nvGrpSpPr>
+        <p:cNvPr id="1" name=""/>
+        <p:cNvGrpSpPr/>
+        <p:nvPr/>
+      </p:nvGrpSpPr>
+      <p:grpSpPr/>
+      <p:pic>
+        <p:nvPicPr>
+          <p:cNvPr id="2" name="Picture 1" descr="paper.png"/>
+          <p:cNvPicPr>
+            <a:picLocks noChangeAspect="1"/>
+          </p:cNvPicPr>
+          <p:nvPr/>
+        </p:nvPicPr>
+        <p:blipFill>
+          <a:blip r:embed="rId2"/>
+          <a:stretch>
+            <a:fillRect/>
+          </a:stretch>
+        </p:blipFill>
+        <p:spPr>
+          <a:xfrm>
+            <a:off x="0" y="0"/>
+            <a:ext cx="12191695" cy="6858000"/>
+          </a:xfrm>
+          <a:prstGeom prst="rect">
+            <a:avLst/>
+          </a:prstGeom>
+        </p:spPr>
+      </p:pic>
+      <p:sp>
+        <p:nvSpPr>
+          <p:cNvPr id="3" name="TextBox 2"/>
+          <p:cNvSpPr txBox="1"/>
+          <p:nvPr/>
+        </p:nvSpPr>
+        <p:spPr>
+          <a:xfrm>
+            <a:off x="685800" y="274320"/>
+            <a:ext cx="10881360" cy="822960"/>
+          </a:xfrm>
+          <a:prstGeom prst="rect">
+            <a:avLst/>
+          </a:prstGeom>
+          <a:noFill/>
+        </p:spPr>
+        <p:txBody>
+          <a:bodyPr wrap="square" lIns="0" rIns="0" tIns="0" bIns="0" anchor="t">
+            <a:spAutoFit/>
+          </a:bodyPr>
+          <a:lstStyle/>
+          <a:p>
+            <a:pPr algn="l">
+              <a:spcAft>
+                <a:spcPts val="800"/>
+              </a:spcAft>
+            </a:pPr>
+            <a:r>
+              <a:rPr sz="4600" b="1">
+                <a:solidFill>
+                  <a:srgbClr val="2B2D42"/>
+                </a:solidFill>
+                <a:latin typeface="Caveat"/>
+              </a:rPr>
+              <a:t>Is it just the R1 papers? No.</a:t>
+            </a:r>
+          </a:p>
+        </p:txBody>
+      </p:sp>
+      <p:sp>
+        <p:nvSpPr>
+          <p:cNvPr id="4" name="TextBox 3"/>
+          <p:cNvSpPr txBox="1"/>
+          <p:nvPr/>
+        </p:nvSpPr>
+        <p:spPr>
+          <a:xfrm>
+            <a:off x="713232" y="987552"/>
+            <a:ext cx="10881360" cy="411480"/>
+          </a:xfrm>
+          <a:prstGeom prst="rect">
+            <a:avLst/>
+          </a:prstGeom>
+          <a:noFill/>
+        </p:spPr>
+        <p:txBody>
+          <a:bodyPr wrap="square" lIns="0" rIns="0" tIns="0" bIns="0" anchor="t">
+            <a:spAutoFit/>
+          </a:bodyPr>
+          <a:lstStyle/>
+          <a:p>
+            <a:pPr algn="l">
+              <a:spcAft>
+                <a:spcPts val="800"/>
+              </a:spcAft>
+            </a:pPr>
+            <a:r>
+              <a:rPr sz="1900" b="0">
+                <a:solidFill>
+                  <a:srgbClr val="6E7080"/>
+                </a:solidFill>
+                <a:latin typeface="Patrick Hand"/>
+              </a:rPr>
+              <a:t>R0 = no true author written · R1 = a few written · A/B/C/D = target/control x R0/R1</a:t>
+            </a:r>
+          </a:p>
+        </p:txBody>
+      </p:sp>
+      <p:pic>
+        <p:nvPicPr>
+          <p:cNvPr id="5" name="Picture 4" descr="c17_r0_r1.png"/>
+          <p:cNvPicPr>
+            <a:picLocks noChangeAspect="1"/>
+          </p:cNvPicPr>
+          <p:nvPr/>
+        </p:nvPicPr>
+        <p:blipFill>
+          <a:blip r:embed="rId4"/>
+          <a:stretch>
+            <a:fillRect/>
+          </a:stretch>
+        </p:blipFill>
+        <p:spPr>
+          <a:xfrm>
+            <a:off x="457200" y="1463040"/>
+            <a:ext cx="8412480" cy="3968150"/>
+          </a:xfrm>
+          <a:prstGeom prst="rect">
+            <a:avLst/>
+          </a:prstGeom>
+        </p:spPr>
+      </p:pic>
+      <p:sp>
+        <p:nvSpPr>
+          <p:cNvPr id="6" name="Rectangle 5"/>
+          <p:cNvSpPr/>
+          <p:nvPr/>
+        </p:nvSpPr>
+        <p:spPr>
+          <a:xfrm rot="90000">
+            <a:off x="9098280" y="1737360"/>
+            <a:ext cx="2651760" cy="4023360"/>
+          </a:xfrm>
+          <a:prstGeom prst="rect">
+            <a:avLst/>
+          </a:prstGeom>
+          <a:solidFill>
+            <a:srgbClr val="FFF1A8"/>
+          </a:solidFill>
+          <a:ln w="12700">
+            <a:solidFill>
+              <a:srgbClr val="E2D37A"/>
+            </a:solidFill>
+          </a:ln>
+          <a:effectLst/>
+        </p:spPr>
+        <p:style>
+          <a:lnRef idx="1">
+            <a:schemeClr val="accent1"/>
+          </a:lnRef>
+          <a:fillRef idx="3">
+            <a:schemeClr val="accent1"/>
+          </a:fillRef>
+          <a:effectRef idx="2">
+            <a:schemeClr val="accent1"/>
+          </a:effectRef>
+          <a:fontRef idx="minor">
+            <a:schemeClr val="lt1"/>
+          </a:fontRef>
+        </p:style>
+        <p:txBody>
+          <a:bodyPr rtlCol="0" anchor="t" wrap="square" lIns="201168" rIns="201168" tIns="164592" bIns="164592"/>
+          <a:lstStyle/>
+          <a:p>
+            <a:pPr algn="l">
+              <a:spcAft>
+                <a:spcPts val="900"/>
+              </a:spcAft>
+            </a:pPr>
+            <a:r>
+              <a:rPr sz="1700" b="1">
+                <a:solidFill>
+                  <a:srgbClr val="E07A2F"/>
+                </a:solidFill>
+                <a:latin typeface="Patrick Hand"/>
+              </a:rPr>
+              <a:t>R0 only (A - B):</a:t>
+            </a:r>
+          </a:p>
+          <a:p>
+            <a:pPr algn="l">
+              <a:spcAft>
+                <a:spcPts val="900"/>
+              </a:spcAft>
+            </a:pPr>
+            <a:r>
+              <a:rPr sz="1700" b="0">
+                <a:solidFill>
+                  <a:srgbClr val="2B2D42"/>
+                </a:solidFill>
+                <a:latin typeface="Patrick Hand"/>
+              </a:rPr>
+              <a:t>output +0.199 vs +0.207, same shape</a:t>
+            </a:r>
+          </a:p>
+          <a:p>
+            <a:pPr algn="l">
+              <a:spcAft>
+                <a:spcPts val="900"/>
+              </a:spcAft>
+            </a:pPr>
+            <a:r>
+              <a:rPr sz="1700" b="1">
+                <a:solidFill>
+                  <a:srgbClr val="8A4FA3"/>
+                </a:solidFill>
+                <a:latin typeface="Patrick Hand"/>
+              </a:rPr>
+              <a:t>R1 (C - B):</a:t>
+            </a:r>
+            <a:r>
+              <a:rPr sz="1700" b="0">
+                <a:solidFill>
+                  <a:srgbClr val="2B2D42"/>
+                </a:solidFill>
+                <a:latin typeface="Patrick Hand"/>
+              </a:rPr>
+              <a:t> +0.37, also late</a:t>
+            </a:r>
+          </a:p>
+          <a:p>
+            <a:pPr algn="l">
+              <a:spcAft>
+                <a:spcPts val="900"/>
+              </a:spcAft>
+            </a:pPr>
+            <a:r>
+              <a:rPr sz="1700" b="0">
+                <a:solidFill>
+                  <a:srgbClr val="2B2D42"/>
+                </a:solidFill>
+                <a:latin typeface="Patrick Hand"/>
+              </a:rPr>
+              <a:t>C - A within target: +0.11, from L56</a:t>
+            </a:r>
+          </a:p>
+          <a:p>
+            <a:pPr algn="l">
+              <a:spcAft>
+                <a:spcPts val="900"/>
+              </a:spcAft>
+            </a:pPr>
+            <a:r>
+              <a:rPr sz="1700" b="1">
+                <a:solidFill>
+                  <a:srgbClr val="2B2D42"/>
+                </a:solidFill>
+                <a:latin typeface="Patrick Hand"/>
+              </a:rPr>
+              <a:t>patching:</a:t>
+            </a:r>
+            <a:r>
+              <a:rPr sz="1700" b="0">
+                <a:solidFill>
+                  <a:srgbClr val="2B2D42"/>
+                </a:solidFill>
+                <a:latin typeface="Patrick Hand"/>
+              </a:rPr>
+              <a:t> R1 a bit later, done by L52</a:t>
+            </a:r>
+          </a:p>
+        </p:txBody>
+      </p:sp>
+      <p:sp>
+        <p:nvSpPr>
+          <p:cNvPr id="7" name="Rounded Rectangle 6"/>
+          <p:cNvSpPr/>
+          <p:nvPr/>
+        </p:nvSpPr>
+        <p:spPr>
+          <a:xfrm>
+            <a:off x="10241280" y="182880"/>
+            <a:ext cx="1691640" cy="384048"/>
+          </a:xfrm>
+          <a:prstGeom prst="roundRect">
+            <a:avLst>
+              <a:gd name="adj" fmla="val 30000"/>
+            </a:avLst>
+          </a:prstGeom>
+          <a:solidFill>
+            <a:srgbClr val="FFFFFF"/>
+          </a:solidFill>
+          <a:ln w="22225">
+            <a:solidFill>
+              <a:srgbClr val="8A4FA3"/>
+            </a:solidFill>
+          </a:ln>
+          <a:effectLst/>
+        </p:spPr>
+        <p:style>
+          <a:lnRef idx="1">
+            <a:schemeClr val="accent1"/>
+          </a:lnRef>
+          <a:fillRef idx="3">
+            <a:schemeClr val="accent1"/>
+          </a:fillRef>
+          <a:effectRef idx="2">
+            <a:schemeClr val="accent1"/>
+          </a:effectRef>
+          <a:fontRef idx="minor">
+            <a:schemeClr val="lt1"/>
+          </a:fontRef>
+        </p:style>
+        <p:txBody>
+          <a:bodyPr rtlCol="0" anchor="ctr" lIns="0" rIns="0" tIns="0" bIns="0"/>
+          <a:lstStyle/>
+          <a:p>
+            <a:pPr algn="ctr"/>
+            <a:r>
+              <a:rPr sz="1500" b="1">
+                <a:solidFill>
+                  <a:srgbClr val="8A4FA3"/>
+                </a:solidFill>
+                <a:latin typeface="Patrick Hand"/>
+              </a:rPr>
+              <a:t>Stage 10-11</a:t>
+            </a:r>
+          </a:p>
+        </p:txBody>
+      </p:sp>
+    </p:spTree>
+  </p:cSld>
+  <p:clrMapOvr>
+    <a:masterClrMapping/>
+  </p:clrMapOvr>
+</p:sld>
+</file>
+
+<file path=ppt/slides/slide26.xml><?xml version="1.0" encoding="utf-8"?>
+<p:sld xmlns:a="http://schemas.openxmlformats.org/drawingml/2006/main" xmlns:p="http://schemas.openxmlformats.org/presentationml/2006/main" xmlns:r="http://schemas.openxmlformats.org/officeDocument/2006/relationships">
+  <p:cSld>
+    <p:spTree>
+      <p:nvGrpSpPr>
+        <p:cNvPr id="1" name=""/>
+        <p:cNvGrpSpPr/>
+        <p:nvPr/>
+      </p:nvGrpSpPr>
+      <p:grpSpPr/>
+      <p:pic>
+        <p:nvPicPr>
+          <p:cNvPr id="2" name="Picture 1" descr="paper.png"/>
+          <p:cNvPicPr>
+            <a:picLocks noChangeAspect="1"/>
+          </p:cNvPicPr>
+          <p:nvPr/>
+        </p:nvPicPr>
+        <p:blipFill>
+          <a:blip r:embed="rId2"/>
+          <a:stretch>
+            <a:fillRect/>
+          </a:stretch>
+        </p:blipFill>
+        <p:spPr>
+          <a:xfrm>
+            <a:off x="0" y="0"/>
+            <a:ext cx="12191695" cy="6858000"/>
+          </a:xfrm>
+          <a:prstGeom prst="rect">
+            <a:avLst/>
+          </a:prstGeom>
+        </p:spPr>
+      </p:pic>
+      <p:sp>
+        <p:nvSpPr>
+          <p:cNvPr id="3" name="TextBox 2"/>
+          <p:cNvSpPr txBox="1"/>
+          <p:nvPr/>
+        </p:nvSpPr>
+        <p:spPr>
+          <a:xfrm>
+            <a:off x="685800" y="274320"/>
+            <a:ext cx="10881360" cy="822960"/>
+          </a:xfrm>
+          <a:prstGeom prst="rect">
+            <a:avLst/>
+          </a:prstGeom>
+          <a:noFill/>
+        </p:spPr>
+        <p:txBody>
+          <a:bodyPr wrap="square" lIns="0" rIns="0" tIns="0" bIns="0" anchor="t">
+            <a:spAutoFit/>
+          </a:bodyPr>
+          <a:lstStyle/>
+          <a:p>
+            <a:pPr algn="l">
+              <a:spcAft>
+                <a:spcPts val="800"/>
+              </a:spcAft>
+            </a:pPr>
+            <a:r>
+              <a:rPr sz="4600" b="1">
+                <a:solidFill>
+                  <a:srgbClr val="2B2D42"/>
+                </a:solidFill>
+                <a:latin typeface="Caveat"/>
+              </a:rPr>
+              <a:t>Authors it wrote vs authors it missed</a:t>
+            </a:r>
+          </a:p>
+        </p:txBody>
+      </p:sp>
+      <p:sp>
+        <p:nvSpPr>
+          <p:cNvPr id="4" name="TextBox 3"/>
+          <p:cNvSpPr txBox="1"/>
+          <p:nvPr/>
+        </p:nvSpPr>
+        <p:spPr>
+          <a:xfrm>
+            <a:off x="713232" y="987552"/>
+            <a:ext cx="10881360" cy="411480"/>
+          </a:xfrm>
+          <a:prstGeom prst="rect">
+            <a:avLst/>
+          </a:prstGeom>
+          <a:noFill/>
+        </p:spPr>
+        <p:txBody>
+          <a:bodyPr wrap="square" lIns="0" rIns="0" tIns="0" bIns="0" anchor="t">
+            <a:spAutoFit/>
+          </a:bodyPr>
+          <a:lstStyle/>
+          <a:p>
+            <a:pPr algn="l">
+              <a:spcAft>
+                <a:spcPts val="800"/>
+              </a:spcAft>
+            </a:pPr>
+            <a:r>
+              <a:rPr sz="1900" b="0">
+                <a:solidFill>
+                  <a:srgbClr val="6E7080"/>
+                </a:solidFill>
+                <a:latin typeface="Patrick Hand"/>
+              </a:rPr>
+              <a:t>inside 495 R1 papers · paired within paper · 95% CI</a:t>
+            </a:r>
+          </a:p>
+        </p:txBody>
+      </p:sp>
+      <p:pic>
+        <p:nvPicPr>
+          <p:cNvPr id="5" name="Picture 4" descr="c18_r1_authors.png"/>
+          <p:cNvPicPr>
+            <a:picLocks noChangeAspect="1"/>
+          </p:cNvPicPr>
+          <p:nvPr/>
+        </p:nvPicPr>
+        <p:blipFill>
+          <a:blip r:embed="rId4"/>
+          <a:stretch>
+            <a:fillRect/>
+          </a:stretch>
+        </p:blipFill>
+        <p:spPr>
+          <a:xfrm>
+            <a:off x="457200" y="1463040"/>
+            <a:ext cx="8412480" cy="3968150"/>
+          </a:xfrm>
+          <a:prstGeom prst="rect">
+            <a:avLst/>
+          </a:prstGeom>
+        </p:spPr>
+      </p:pic>
+      <p:sp>
+        <p:nvSpPr>
+          <p:cNvPr id="6" name="Rectangle 5"/>
+          <p:cNvSpPr/>
+          <p:nvPr/>
+        </p:nvSpPr>
+        <p:spPr>
+          <a:xfrm rot="21510000">
+            <a:off x="9098280" y="1737360"/>
+            <a:ext cx="2651760" cy="3657600"/>
+          </a:xfrm>
+          <a:prstGeom prst="rect">
+            <a:avLst/>
+          </a:prstGeom>
+          <a:solidFill>
+            <a:srgbClr val="FFF1A8"/>
+          </a:solidFill>
+          <a:ln w="12700">
+            <a:solidFill>
+              <a:srgbClr val="E2D37A"/>
+            </a:solidFill>
+          </a:ln>
+          <a:effectLst/>
+        </p:spPr>
+        <p:style>
+          <a:lnRef idx="1">
+            <a:schemeClr val="accent1"/>
+          </a:lnRef>
+          <a:fillRef idx="3">
+            <a:schemeClr val="accent1"/>
+          </a:fillRef>
+          <a:effectRef idx="2">
+            <a:schemeClr val="accent1"/>
+          </a:effectRef>
+          <a:fontRef idx="minor">
+            <a:schemeClr val="lt1"/>
+          </a:fontRef>
+        </p:style>
+        <p:txBody>
+          <a:bodyPr rtlCol="0" anchor="t" wrap="square" lIns="201168" rIns="201168" tIns="164592" bIns="164592"/>
+          <a:lstStyle/>
+          <a:p>
+            <a:pPr algn="l">
+              <a:spcAft>
+                <a:spcPts val="900"/>
+              </a:spcAft>
+            </a:pPr>
+            <a:r>
+              <a:rPr sz="1800" b="0">
+                <a:solidFill>
+                  <a:srgbClr val="2B2D42"/>
+                </a:solidFill>
+                <a:latin typeface="Patrick Hand"/>
+              </a:rPr>
+              <a:t>written - missed, output: </a:t>
+            </a:r>
+            <a:r>
+              <a:rPr sz="1800" b="1">
+                <a:solidFill>
+                  <a:srgbClr val="E07A2F"/>
+                </a:solidFill>
+                <a:latin typeface="Patrick Hand"/>
+              </a:rPr>
+              <a:t>+0.20</a:t>
+            </a:r>
+          </a:p>
+          <a:p>
+            <a:pPr algn="l">
+              <a:spcAft>
+                <a:spcPts val="900"/>
+              </a:spcAft>
+            </a:pPr>
+            <a:r>
+              <a:rPr sz="1800" b="0">
+                <a:solidFill>
+                  <a:srgbClr val="2B2D42"/>
+                </a:solidFill>
+                <a:latin typeface="Patrick Hand"/>
+              </a:rPr>
+              <a:t>~0 up to L52, grows from </a:t>
+            </a:r>
+            <a:r>
+              <a:rPr sz="1800" b="1">
+                <a:solidFill>
+                  <a:srgbClr val="2B2D42"/>
+                </a:solidFill>
+                <a:latin typeface="Patrick Hand"/>
+              </a:rPr>
+              <a:t>L54</a:t>
+            </a:r>
+          </a:p>
+          <a:p>
+            <a:pPr algn="l">
+              <a:spcAft>
+                <a:spcPts val="900"/>
+              </a:spcAft>
+            </a:pPr>
+            <a:r>
+              <a:rPr sz="1800" b="0">
+                <a:solidFill>
+                  <a:srgbClr val="2B2D42"/>
+                </a:solidFill>
+                <a:latin typeface="Patrick Hand"/>
+              </a:rPr>
+              <a:t>no title (prior): +0.10</a:t>
+            </a:r>
+          </a:p>
+          <a:p>
+            <a:pPr algn="l">
+              <a:spcAft>
+                <a:spcPts val="900"/>
+              </a:spcAft>
+            </a:pPr>
+            <a:r>
+              <a:rPr sz="1800" b="0">
+                <a:solidFill>
+                  <a:srgbClr val="2B2D42"/>
+                </a:solidFill>
+                <a:latin typeface="Patrick Hand"/>
+              </a:rPr>
+              <a:t>same without first authors</a:t>
+            </a:r>
+          </a:p>
+        </p:txBody>
+      </p:sp>
+      <p:sp>
+        <p:nvSpPr>
+          <p:cNvPr id="7" name="Rounded Rectangle 6"/>
+          <p:cNvSpPr/>
+          <p:nvPr/>
+        </p:nvSpPr>
+        <p:spPr>
+          <a:xfrm>
+            <a:off x="10241280" y="182880"/>
+            <a:ext cx="1691640" cy="384048"/>
+          </a:xfrm>
+          <a:prstGeom prst="roundRect">
+            <a:avLst>
+              <a:gd name="adj" fmla="val 30000"/>
+            </a:avLst>
+          </a:prstGeom>
+          <a:solidFill>
+            <a:srgbClr val="FFFFFF"/>
+          </a:solidFill>
+          <a:ln w="22225">
+            <a:solidFill>
+              <a:srgbClr val="8A4FA3"/>
+            </a:solidFill>
+          </a:ln>
+          <a:effectLst/>
+        </p:spPr>
+        <p:style>
+          <a:lnRef idx="1">
+            <a:schemeClr val="accent1"/>
+          </a:lnRef>
+          <a:fillRef idx="3">
+            <a:schemeClr val="accent1"/>
+          </a:fillRef>
+          <a:effectRef idx="2">
+            <a:schemeClr val="accent1"/>
+          </a:effectRef>
+          <a:fontRef idx="minor">
+            <a:schemeClr val="lt1"/>
+          </a:fontRef>
+        </p:style>
+        <p:txBody>
+          <a:bodyPr rtlCol="0" anchor="ctr" lIns="0" rIns="0" tIns="0" bIns="0"/>
+          <a:lstStyle/>
+          <a:p>
+            <a:pPr algn="ctr"/>
+            <a:r>
+              <a:rPr sz="1500" b="1">
+                <a:solidFill>
+                  <a:srgbClr val="8A4FA3"/>
+                </a:solidFill>
+                <a:latin typeface="Patrick Hand"/>
+              </a:rPr>
+              <a:t>Stage 10-11</a:t>
+            </a:r>
+          </a:p>
+        </p:txBody>
+      </p:sp>
+    </p:spTree>
+  </p:cSld>
+  <p:clrMapOvr>
+    <a:masterClrMapping/>
+  </p:clrMapOvr>
+</p:sld>
+</file>
+
+<file path=ppt/slides/slide27.xml><?xml version="1.0" encoding="utf-8"?>
 <p:sld xmlns:a="http://schemas.openxmlformats.org/drawingml/2006/main" xmlns:p="http://schemas.openxmlformats.org/presentationml/2006/main" xmlns:r="http://schemas.openxmlformats.org/officeDocument/2006/relationships">
   <p:cSld>
     <p:spTree>

</xml_diff>

<commit_message>
Merged deck: probe slides under review; Stage 11 design review notes; Stage 12 P1/P2 CPU preview
</commit_message>
<xml_diff>
--- a/experiment_files/351_stage10/reports/talk/Stage10_author_readout_talk.pptx
+++ b/experiment_files/351_stage10/reports/talk/Stage10_author_readout_talk.pptx
@@ -7089,6 +7089,63 @@
           </a:p>
         </p:txBody>
       </p:sp>
+      <p:sp>
+        <p:nvSpPr>
+          <p:cNvPr id="8" name="Rounded Rectangle 7"/>
+          <p:cNvSpPr/>
+          <p:nvPr/>
+        </p:nvSpPr>
+        <p:spPr>
+          <a:xfrm rot="21510000">
+            <a:off x="731520" y="5989320"/>
+            <a:ext cx="5943600" cy="384048"/>
+          </a:xfrm>
+          <a:prstGeom prst="roundRect">
+            <a:avLst>
+              <a:gd name="adj" fmla="val 30000"/>
+            </a:avLst>
+          </a:prstGeom>
+          <a:solidFill>
+            <a:srgbClr val="B42318"/>
+          </a:solidFill>
+          <a:ln>
+            <a:solidFill>
+              <a:srgbClr val="B42318"/>
+            </a:solidFill>
+          </a:ln>
+          <a:effectLst/>
+        </p:spPr>
+        <p:style>
+          <a:lnRef idx="1">
+            <a:schemeClr val="accent1"/>
+          </a:lnRef>
+          <a:fillRef idx="3">
+            <a:schemeClr val="accent1"/>
+          </a:fillRef>
+          <a:effectRef idx="2">
+            <a:schemeClr val="accent1"/>
+          </a:effectRef>
+          <a:fontRef idx="minor">
+            <a:schemeClr val="lt1"/>
+          </a:fontRef>
+        </p:style>
+        <p:txBody>
+          <a:bodyPr rtlCol="0" anchor="ctr" lIns="0" rIns="0" tIns="0" bIns="0"/>
+          <a:lstStyle/>
+          <a:p>
+            <a:pPr algn="ctr"/>
+            <a:r>
+              <a:rPr sz="1500" b="1">
+                <a:solidFill>
+                  <a:srgbClr val="FFFFFF"/>
+                </a:solidFill>
+                <a:latin typeface="Patrick Hand"/>
+              </a:rPr>
+              <a:t>UNDER REVIEW: probe split leaks being re-checked (Stage 13)</a:t>
+            </a:r>
+          </a:p>
+        </p:txBody>
+      </p:sp>
     </p:spTree>
   </p:cSld>
   <p:clrMapOvr>
@@ -8110,6 +8167,63 @@
                 <a:latin typeface="Patrick Hand"/>
               </a:rPr>
               <a:t>Stage 12</a:t>
+            </a:r>
+          </a:p>
+        </p:txBody>
+      </p:sp>
+      <p:sp>
+        <p:nvSpPr>
+          <p:cNvPr id="8" name="Rounded Rectangle 7"/>
+          <p:cNvSpPr/>
+          <p:nvPr/>
+        </p:nvSpPr>
+        <p:spPr>
+          <a:xfrm rot="21510000">
+            <a:off x="731520" y="5989320"/>
+            <a:ext cx="5943600" cy="384048"/>
+          </a:xfrm>
+          <a:prstGeom prst="roundRect">
+            <a:avLst>
+              <a:gd name="adj" fmla="val 30000"/>
+            </a:avLst>
+          </a:prstGeom>
+          <a:solidFill>
+            <a:srgbClr val="B42318"/>
+          </a:solidFill>
+          <a:ln>
+            <a:solidFill>
+              <a:srgbClr val="B42318"/>
+            </a:solidFill>
+          </a:ln>
+          <a:effectLst/>
+        </p:spPr>
+        <p:style>
+          <a:lnRef idx="1">
+            <a:schemeClr val="accent1"/>
+          </a:lnRef>
+          <a:fillRef idx="3">
+            <a:schemeClr val="accent1"/>
+          </a:fillRef>
+          <a:effectRef idx="2">
+            <a:schemeClr val="accent1"/>
+          </a:effectRef>
+          <a:fontRef idx="minor">
+            <a:schemeClr val="lt1"/>
+          </a:fontRef>
+        </p:style>
+        <p:txBody>
+          <a:bodyPr rtlCol="0" anchor="ctr" lIns="0" rIns="0" tIns="0" bIns="0"/>
+          <a:lstStyle/>
+          <a:p>
+            <a:pPr algn="ctr"/>
+            <a:r>
+              <a:rPr sz="1500" b="1">
+                <a:solidFill>
+                  <a:srgbClr val="FFFFFF"/>
+                </a:solidFill>
+                <a:latin typeface="Patrick Hand"/>
+              </a:rPr>
+              <a:t>UNDER REVIEW: probe split leaks being re-checked (Stage 13)</a:t>
             </a:r>
           </a:p>
         </p:txBody>

</xml_diff>

<commit_message>
Probe statements rewritten with re-checked numbers (report + deck); under-review markers kept only for the post-title-token wording
</commit_message>
<xml_diff>
--- a/experiment_files/351_stage10/reports/talk/Stage10_author_readout_talk.pptx
+++ b/experiment_files/351_stage10/reports/talk/Stage10_author_readout_talk.pptx
@@ -808,7 +808,7 @@
           <a:lstStyle/>
           <a:p>
             <a:r>
-              <a:t>Is the author readable at the title itself? With the lenses, barely: about 0.01 to 0.03 title-specific signal at the last title token. A linear probe trained across papers gets more, 0.04 at L16 rising to 0.08 at L56, and a little more for target papers. The controls (appendix) show this probe signal is specific to the paper, not a topic-to-name association. This is not in conflict with the lens result: the title is read early, at the title token, but names only become readable at the name positions in L57 to L61. Read early, spoken late.</a:t>
+              <a:t>Is the author readable at the title itself? With the lenses, barely: about 0.01 to 0.03 title-specific signal at the last title token. A linear probe trained across papers gets more: re-checked with author-team folds and with papers whose prompt title the probe saw in training removed, about 0.05 at L24 rising to 0.08 at L56, and 0.04 to 0.08 more for target papers. The controls (appendix) show this probe signal is specific to the paper, not a topic-to-name association. This is not in conflict with the lens result: the title is read early, at the title token, but names only become readable at the name positions in L57 to L61. Read early, spoken late.</a:t>
             </a:r>
           </a:p>
         </p:txBody>
@@ -1018,7 +1018,7 @@
           <a:lstStyle/>
           <a:p>
             <a:r>
-              <a:t>Is the probe at the title token reading real paper knowledge, or just topic to name associations? If we score its output against the authors of another paper, or of another paper in the same field, the signal drops to zero. If we train it only on false-title pairs it gets even stronger. So the last title token carries linearly decodable, paper-specific author information already at L24, more for target papers, even though the lenses cannot read it.</a:t>
+              <a:t>Is the probe at the title token reading real paper knowledge, or just topic to name associations? If we score its output against the authors of another paper, or of another paper in the same field, the signal drops to zero. If we train it only on false-title pairs it gives a similar signal (the earlier even-stronger result came from a leak: the same donor title in training and test). So the last title token carries linearly decodable, paper-specific author information already at L24, more for target papers, even though the lenses cannot read it.</a:t>
             </a:r>
           </a:p>
         </p:txBody>
@@ -6842,7 +6842,7 @@
                 </a:solidFill>
                 <a:latin typeface="Patrick Hand"/>
               </a:rPr>
-              <a:t>title-specific signal at the last title token · all 9,108 papers</a:t>
+              <a:t>title-specific signal at the last title token · lenses: all 9,108 papers · probe: re-checked, 1,395 papers</a:t>
             </a:r>
           </a:p>
         </p:txBody>
@@ -6959,7 +6959,7 @@
                 </a:solidFill>
                 <a:latin typeface="Patrick Hand"/>
               </a:rPr>
-              <a:t>0.04 -&gt; 0.08</a:t>
+              <a:t>0.05 -&gt; 0.08</a:t>
             </a:r>
           </a:p>
           <a:p>
@@ -6984,7 +6984,23 @@
                 </a:solidFill>
                 <a:latin typeface="Patrick Hand"/>
               </a:rPr>
-              <a:t>+0.02-0.04</a:t>
+              <a:t>+0.04-0.08</a:t>
+            </a:r>
+          </a:p>
+          <a:p>
+            <a:pPr algn="l">
+              <a:spcAft>
+                <a:spcPts val="900"/>
+              </a:spcAft>
+            </a:pPr>
+            <a:r>
+              <a:rPr sz="1800" b="0">
+                <a:solidFill>
+                  <a:srgbClr val="2B2D42"/>
+                </a:solidFill>
+                <a:latin typeface="Patrick Hand"/>
+              </a:rPr>
+              <a:t>re-checked: team folds, title reuse removed</a:t>
             </a:r>
           </a:p>
           <a:p>
@@ -7085,63 +7101,6 @@
                 <a:latin typeface="Patrick Hand"/>
               </a:rPr>
               <a:t>Stage 11</a:t>
-            </a:r>
-          </a:p>
-        </p:txBody>
-      </p:sp>
-      <p:sp>
-        <p:nvSpPr>
-          <p:cNvPr id="8" name="Rounded Rectangle 7"/>
-          <p:cNvSpPr/>
-          <p:nvPr/>
-        </p:nvSpPr>
-        <p:spPr>
-          <a:xfrm rot="21510000">
-            <a:off x="731520" y="5989320"/>
-            <a:ext cx="5943600" cy="384048"/>
-          </a:xfrm>
-          <a:prstGeom prst="roundRect">
-            <a:avLst>
-              <a:gd name="adj" fmla="val 30000"/>
-            </a:avLst>
-          </a:prstGeom>
-          <a:solidFill>
-            <a:srgbClr val="B42318"/>
-          </a:solidFill>
-          <a:ln>
-            <a:solidFill>
-              <a:srgbClr val="B42318"/>
-            </a:solidFill>
-          </a:ln>
-          <a:effectLst/>
-        </p:spPr>
-        <p:style>
-          <a:lnRef idx="1">
-            <a:schemeClr val="accent1"/>
-          </a:lnRef>
-          <a:fillRef idx="3">
-            <a:schemeClr val="accent1"/>
-          </a:fillRef>
-          <a:effectRef idx="2">
-            <a:schemeClr val="accent1"/>
-          </a:effectRef>
-          <a:fontRef idx="minor">
-            <a:schemeClr val="lt1"/>
-          </a:fontRef>
-        </p:style>
-        <p:txBody>
-          <a:bodyPr rtlCol="0" anchor="ctr" lIns="0" rIns="0" tIns="0" bIns="0"/>
-          <a:lstStyle/>
-          <a:p>
-            <a:pPr algn="ctr"/>
-            <a:r>
-              <a:rPr sz="1500" b="1">
-                <a:solidFill>
-                  <a:srgbClr val="FFFFFF"/>
-                </a:solidFill>
-                <a:latin typeface="Patrick Hand"/>
-              </a:rPr>
-              <a:t>UNDER REVIEW: probe split leaks being re-checked (Stage 13)</a:t>
             </a:r>
           </a:p>
         </p:txBody>
@@ -7942,7 +7901,7 @@
                 </a:solidFill>
                 <a:latin typeface="Patrick Hand"/>
               </a:rPr>
-              <a:t>last title token · 5-fold ridge probe · controls · all 9,108 papers</a:t>
+              <a:t>last title token · 5-fold ridge probe · re-checked: author-team folds, title reuse removed</a:t>
             </a:r>
           </a:p>
         </p:txBody>
@@ -8167,63 +8126,6 @@
                 <a:latin typeface="Patrick Hand"/>
               </a:rPr>
               <a:t>Stage 12</a:t>
-            </a:r>
-          </a:p>
-        </p:txBody>
-      </p:sp>
-      <p:sp>
-        <p:nvSpPr>
-          <p:cNvPr id="8" name="Rounded Rectangle 7"/>
-          <p:cNvSpPr/>
-          <p:nvPr/>
-        </p:nvSpPr>
-        <p:spPr>
-          <a:xfrm rot="21510000">
-            <a:off x="731520" y="5989320"/>
-            <a:ext cx="5943600" cy="384048"/>
-          </a:xfrm>
-          <a:prstGeom prst="roundRect">
-            <a:avLst>
-              <a:gd name="adj" fmla="val 30000"/>
-            </a:avLst>
-          </a:prstGeom>
-          <a:solidFill>
-            <a:srgbClr val="B42318"/>
-          </a:solidFill>
-          <a:ln>
-            <a:solidFill>
-              <a:srgbClr val="B42318"/>
-            </a:solidFill>
-          </a:ln>
-          <a:effectLst/>
-        </p:spPr>
-        <p:style>
-          <a:lnRef idx="1">
-            <a:schemeClr val="accent1"/>
-          </a:lnRef>
-          <a:fillRef idx="3">
-            <a:schemeClr val="accent1"/>
-          </a:fillRef>
-          <a:effectRef idx="2">
-            <a:schemeClr val="accent1"/>
-          </a:effectRef>
-          <a:fontRef idx="minor">
-            <a:schemeClr val="lt1"/>
-          </a:fontRef>
-        </p:style>
-        <p:txBody>
-          <a:bodyPr rtlCol="0" anchor="ctr" lIns="0" rIns="0" tIns="0" bIns="0"/>
-          <a:lstStyle/>
-          <a:p>
-            <a:pPr algn="ctr"/>
-            <a:r>
-              <a:rPr sz="1500" b="1">
-                <a:solidFill>
-                  <a:srgbClr val="FFFFFF"/>
-                </a:solidFill>
-                <a:latin typeface="Patrick Hand"/>
-              </a:rPr>
-              <a:t>UNDER REVIEW: probe split leaks being re-checked (Stage 13)</a:t>
             </a:r>
           </a:p>
         </p:txBody>

</xml_diff>